<commit_message>
Drop redundant uncertainty/temporal rows from the ablation table
Those two ablations are identical or near-identical to the full planner
on every metric, so they added rows without adding information. Table
now shows only the three ablations that actually move a number
(staleness, coverage-first, lookahead); the explanation of why
uncertainty/temporal don't move stays as prose below the table.

Co-Authored-By: Claude Sonnet 5 <noreply@anthropic.com>
</commit_message>
<xml_diff>
--- a/drone-sim-today/Autonomous_Drone_Inspection_Progress.pptx
+++ b/drone-sim-today/Autonomous_Drone_Inspection_Progress.pptx
@@ -10212,7 +10212,7 @@
               <a:buNone/>
             </a:pPr>
             <a:r>
-              <a:rPr lang="en-US" sz="1150" dirty="0">
+              <a:rPr lang="en-US" sz="1100" dirty="0">
                 <a:solidFill>
                   <a:srgbClr val="404040"/>
                 </a:solidFill>
@@ -10220,9 +10220,9 @@
                 <a:ea typeface="Calibri" pitchFamily="34" charset="-122"/>
                 <a:cs typeface="Calibri" pitchFamily="34" charset="-120"/>
               </a:rPr>
-              <a:t>Every addition from the novelty slide is independently ablated in PLANNER_REGISTRY -- measured, not just claimed. Mean over static / uncertain / multi-defect x 5 test seeds x 3 missions:</a:t>
+              <a:t>Only ablations that actually change a number are shown -- uncertainty and temporal are omitted (explained below: they're identical or near-identical to the full planner). Mean over static / uncertain / multi-defect x 5 test seeds x 3 missions:</a:t>
             </a:r>
-            <a:endParaRPr lang="en-US" sz="1150" dirty="0"/>
+            <a:endParaRPr lang="en-US" sz="1100" dirty="0"/>
           </a:p>
         </p:txBody>
       </p:sp>
@@ -10241,7 +10241,7 @@
           </p:nvPr>
         </p:nvGraphicFramePr>
         <p:xfrm>
-          <a:off x="548640" y="1737360"/>
+          <a:off x="548640" y="1783080"/>
           <a:ext cx="11064240" cy="914400"/>
         </p:xfrm>
         <a:graphic>
@@ -10257,7 +10257,7 @@
                 <a:gridCol w="1371600"/>
                 <a:gridCol w="1371600"/>
               </a:tblGrid>
-              <a:tr h="347472">
+              <a:tr h="438912">
                 <a:tc>
                   <a:txBody>
                     <a:bodyPr/>
@@ -10267,7 +10267,7 @@
                         <a:buNone/>
                       </a:pPr>
                       <a:r>
-                        <a:rPr lang="en-US" sz="1030" b="1" dirty="0">
+                        <a:rPr lang="en-US" sz="1150" b="1" dirty="0">
                           <a:solidFill>
                             <a:srgbClr val="000000"/>
                           </a:solidFill>
@@ -10277,7 +10277,7 @@
                         </a:rPr>
                         <a:t>Planner</a:t>
                       </a:r>
-                      <a:endParaRPr lang="en-US" sz="1030" dirty="0">
+                      <a:endParaRPr lang="en-US" sz="1150" dirty="0">
                         <a:latin typeface="Calibri" charset="0"/>
                         <a:ea typeface="Calibri" charset="0"/>
                         <a:cs typeface="Calibri" charset="0"/>
@@ -10317,7 +10317,7 @@
                         <a:buNone/>
                       </a:pPr>
                       <a:r>
-                        <a:rPr lang="en-US" sz="1030" b="1" dirty="0">
+                        <a:rPr lang="en-US" sz="1150" b="1" dirty="0">
                           <a:solidFill>
                             <a:srgbClr val="000000"/>
                           </a:solidFill>
@@ -10327,7 +10327,7 @@
                         </a:rPr>
                         <a:t>Precision</a:t>
                       </a:r>
-                      <a:endParaRPr lang="en-US" sz="1030" dirty="0">
+                      <a:endParaRPr lang="en-US" sz="1150" dirty="0">
                         <a:latin typeface="Calibri" charset="0"/>
                         <a:ea typeface="Calibri" charset="0"/>
                         <a:cs typeface="Calibri" charset="0"/>
@@ -10367,7 +10367,7 @@
                         <a:buNone/>
                       </a:pPr>
                       <a:r>
-                        <a:rPr lang="en-US" sz="1030" b="1" dirty="0">
+                        <a:rPr lang="en-US" sz="1150" b="1" dirty="0">
                           <a:solidFill>
                             <a:srgbClr val="000000"/>
                           </a:solidFill>
@@ -10377,7 +10377,7 @@
                         </a:rPr>
                         <a:t>Recall</a:t>
                       </a:r>
-                      <a:endParaRPr lang="en-US" sz="1030" dirty="0">
+                      <a:endParaRPr lang="en-US" sz="1150" dirty="0">
                         <a:latin typeface="Calibri" charset="0"/>
                         <a:ea typeface="Calibri" charset="0"/>
                         <a:cs typeface="Calibri" charset="0"/>
@@ -10417,7 +10417,7 @@
                         <a:buNone/>
                       </a:pPr>
                       <a:r>
-                        <a:rPr lang="en-US" sz="1030" b="1" dirty="0">
+                        <a:rPr lang="en-US" sz="1150" b="1" dirty="0">
                           <a:solidFill>
                             <a:srgbClr val="000000"/>
                           </a:solidFill>
@@ -10427,7 +10427,7 @@
                         </a:rPr>
                         <a:t>F1</a:t>
                       </a:r>
-                      <a:endParaRPr lang="en-US" sz="1030" dirty="0">
+                      <a:endParaRPr lang="en-US" sz="1150" dirty="0">
                         <a:latin typeface="Calibri" charset="0"/>
                         <a:ea typeface="Calibri" charset="0"/>
                         <a:cs typeface="Calibri" charset="0"/>
@@ -10467,7 +10467,7 @@
                         <a:buNone/>
                       </a:pPr>
                       <a:r>
-                        <a:rPr lang="en-US" sz="1030" b="1" dirty="0">
+                        <a:rPr lang="en-US" sz="1150" b="1" dirty="0">
                           <a:solidFill>
                             <a:srgbClr val="000000"/>
                           </a:solidFill>
@@ -10477,7 +10477,7 @@
                         </a:rPr>
                         <a:t>Loc. err (m)</a:t>
                       </a:r>
-                      <a:endParaRPr lang="en-US" sz="1030" dirty="0">
+                      <a:endParaRPr lang="en-US" sz="1150" dirty="0">
                         <a:latin typeface="Calibri" charset="0"/>
                         <a:ea typeface="Calibri" charset="0"/>
                         <a:cs typeface="Calibri" charset="0"/>
@@ -10517,7 +10517,7 @@
                         <a:buNone/>
                       </a:pPr>
                       <a:r>
-                        <a:rPr lang="en-US" sz="1030" b="1" dirty="0">
+                        <a:rPr lang="en-US" sz="1150" b="1" dirty="0">
                           <a:solidFill>
                             <a:srgbClr val="000000"/>
                           </a:solidFill>
@@ -10527,7 +10527,7 @@
                         </a:rPr>
                         <a:t>Flight (m)</a:t>
                       </a:r>
-                      <a:endParaRPr lang="en-US" sz="1030" dirty="0">
+                      <a:endParaRPr lang="en-US" sz="1150" dirty="0">
                         <a:latin typeface="Calibri" charset="0"/>
                         <a:ea typeface="Calibri" charset="0"/>
                         <a:cs typeface="Calibri" charset="0"/>
@@ -10567,7 +10567,7 @@
                         <a:buNone/>
                       </a:pPr>
                       <a:r>
-                        <a:rPr lang="en-US" sz="1030" b="1" dirty="0">
+                        <a:rPr lang="en-US" sz="1150" b="1" dirty="0">
                           <a:solidFill>
                             <a:srgbClr val="000000"/>
                           </a:solidFill>
@@ -10577,7 +10577,7 @@
                         </a:rPr>
                         <a:t>Coverage</a:t>
                       </a:r>
-                      <a:endParaRPr lang="en-US" sz="1030" dirty="0">
+                      <a:endParaRPr lang="en-US" sz="1150" dirty="0">
                         <a:latin typeface="Calibri" charset="0"/>
                         <a:ea typeface="Calibri" charset="0"/>
                         <a:cs typeface="Calibri" charset="0"/>
@@ -10609,7 +10609,7 @@
                   </a:tcPr>
                 </a:tc>
               </a:tr>
-              <a:tr h="347472">
+              <a:tr h="438912">
                 <a:tc>
                   <a:txBody>
                     <a:bodyPr/>
@@ -10619,7 +10619,7 @@
                         <a:buNone/>
                       </a:pPr>
                       <a:r>
-                        <a:rPr lang="en-US" sz="1000" b="1" dirty="0">
+                        <a:rPr lang="en-US" sz="1150" b="1" dirty="0">
                           <a:solidFill>
                             <a:srgbClr val="000000"/>
                           </a:solidFill>
@@ -10629,7 +10629,7 @@
                         </a:rPr>
                         <a:t>uwtig (full)</a:t>
                       </a:r>
-                      <a:endParaRPr lang="en-US" sz="1000" dirty="0">
+                      <a:endParaRPr lang="en-US" sz="1150" dirty="0">
                         <a:latin typeface="Calibri" charset="0"/>
                         <a:ea typeface="Calibri" charset="0"/>
                         <a:cs typeface="Calibri" charset="0"/>
@@ -10687,7 +10687,7 @@
                         <a:buNone/>
                       </a:pPr>
                       <a:r>
-                        <a:rPr lang="en-US" sz="1000" b="1" dirty="0">
+                        <a:rPr lang="en-US" sz="1150" b="1" dirty="0">
                           <a:solidFill>
                             <a:srgbClr val="000000"/>
                           </a:solidFill>
@@ -10697,7 +10697,7 @@
                         </a:rPr>
                         <a:t>0.949</a:t>
                       </a:r>
-                      <a:endParaRPr lang="en-US" sz="1000" dirty="0">
+                      <a:endParaRPr lang="en-US" sz="1150" dirty="0">
                         <a:latin typeface="Calibri" charset="0"/>
                         <a:ea typeface="Calibri" charset="0"/>
                         <a:cs typeface="Calibri" charset="0"/>
@@ -10755,7 +10755,7 @@
                         <a:buNone/>
                       </a:pPr>
                       <a:r>
-                        <a:rPr lang="en-US" sz="1000" b="1" dirty="0">
+                        <a:rPr lang="en-US" sz="1150" b="1" dirty="0">
                           <a:solidFill>
                             <a:srgbClr val="000000"/>
                           </a:solidFill>
@@ -10765,7 +10765,7 @@
                         </a:rPr>
                         <a:t>0.967</a:t>
                       </a:r>
-                      <a:endParaRPr lang="en-US" sz="1000" dirty="0">
+                      <a:endParaRPr lang="en-US" sz="1150" dirty="0">
                         <a:latin typeface="Calibri" charset="0"/>
                         <a:ea typeface="Calibri" charset="0"/>
                         <a:cs typeface="Calibri" charset="0"/>
@@ -10823,7 +10823,7 @@
                         <a:buNone/>
                       </a:pPr>
                       <a:r>
-                        <a:rPr lang="en-US" sz="1000" b="1" dirty="0">
+                        <a:rPr lang="en-US" sz="1150" b="1" dirty="0">
                           <a:solidFill>
                             <a:srgbClr val="000000"/>
                           </a:solidFill>
@@ -10833,7 +10833,7 @@
                         </a:rPr>
                         <a:t>0.953</a:t>
                       </a:r>
-                      <a:endParaRPr lang="en-US" sz="1000" dirty="0">
+                      <a:endParaRPr lang="en-US" sz="1150" dirty="0">
                         <a:latin typeface="Calibri" charset="0"/>
                         <a:ea typeface="Calibri" charset="0"/>
                         <a:cs typeface="Calibri" charset="0"/>
@@ -10891,7 +10891,7 @@
                         <a:buNone/>
                       </a:pPr>
                       <a:r>
-                        <a:rPr lang="en-US" sz="1000" b="1" dirty="0">
+                        <a:rPr lang="en-US" sz="1150" b="1" dirty="0">
                           <a:solidFill>
                             <a:srgbClr val="000000"/>
                           </a:solidFill>
@@ -10901,7 +10901,7 @@
                         </a:rPr>
                         <a:t>0.70</a:t>
                       </a:r>
-                      <a:endParaRPr lang="en-US" sz="1000" dirty="0">
+                      <a:endParaRPr lang="en-US" sz="1150" dirty="0">
                         <a:latin typeface="Calibri" charset="0"/>
                         <a:ea typeface="Calibri" charset="0"/>
                         <a:cs typeface="Calibri" charset="0"/>
@@ -10959,7 +10959,7 @@
                         <a:buNone/>
                       </a:pPr>
                       <a:r>
-                        <a:rPr lang="en-US" sz="1000" b="1" dirty="0">
+                        <a:rPr lang="en-US" sz="1150" b="1" dirty="0">
                           <a:solidFill>
                             <a:srgbClr val="000000"/>
                           </a:solidFill>
@@ -10969,7 +10969,7 @@
                         </a:rPr>
                         <a:t>125.1</a:t>
                       </a:r>
-                      <a:endParaRPr lang="en-US" sz="1000" dirty="0">
+                      <a:endParaRPr lang="en-US" sz="1150" dirty="0">
                         <a:latin typeface="Calibri" charset="0"/>
                         <a:ea typeface="Calibri" charset="0"/>
                         <a:cs typeface="Calibri" charset="0"/>
@@ -11027,7 +11027,7 @@
                         <a:buNone/>
                       </a:pPr>
                       <a:r>
-                        <a:rPr lang="en-US" sz="1000" b="1" dirty="0">
+                        <a:rPr lang="en-US" sz="1150" b="1" dirty="0">
                           <a:solidFill>
                             <a:srgbClr val="000000"/>
                           </a:solidFill>
@@ -11037,7 +11037,7 @@
                         </a:rPr>
                         <a:t>1.00</a:t>
                       </a:r>
-                      <a:endParaRPr lang="en-US" sz="1000" dirty="0">
+                      <a:endParaRPr lang="en-US" sz="1150" dirty="0">
                         <a:latin typeface="Calibri" charset="0"/>
                         <a:ea typeface="Calibri" charset="0"/>
                         <a:cs typeface="Calibri" charset="0"/>
@@ -11087,7 +11087,7 @@
                   </a:tcPr>
                 </a:tc>
               </a:tr>
-              <a:tr h="347472">
+              <a:tr h="438912">
                 <a:tc>
                   <a:txBody>
                     <a:bodyPr/>
@@ -11097,17 +11097,17 @@
                         <a:buNone/>
                       </a:pPr>
                       <a:r>
-                        <a:rPr lang="en-US" sz="1000" dirty="0">
-                          <a:solidFill>
-                            <a:srgbClr val="000000"/>
-                          </a:solidFill>
-                          <a:latin typeface="Calibri" pitchFamily="34" charset="0"/>
-                          <a:ea typeface="Calibri" pitchFamily="34" charset="-122"/>
-                          <a:cs typeface="Calibri" pitchFamily="34" charset="-120"/>
-                        </a:rPr>
-                        <a:t>uwtig_no_uncertainty</a:t>
-                      </a:r>
-                      <a:endParaRPr lang="en-US" sz="1000" dirty="0">
+                        <a:rPr lang="en-US" sz="1150" dirty="0">
+                          <a:solidFill>
+                            <a:srgbClr val="000000"/>
+                          </a:solidFill>
+                          <a:latin typeface="Calibri" pitchFamily="34" charset="0"/>
+                          <a:ea typeface="Calibri" pitchFamily="34" charset="-122"/>
+                          <a:cs typeface="Calibri" pitchFamily="34" charset="-120"/>
+                        </a:rPr>
+                        <a:t>uwtig_no_staleness</a:t>
+                      </a:r>
+                      <a:endParaRPr lang="en-US" sz="1150" dirty="0">
                         <a:latin typeface="Calibri" charset="0"/>
                         <a:ea typeface="Calibri" charset="0"/>
                         <a:cs typeface="Calibri" charset="0"/>
@@ -11165,17 +11165,17 @@
                         <a:buNone/>
                       </a:pPr>
                       <a:r>
-                        <a:rPr lang="en-US" sz="1000" dirty="0">
-                          <a:solidFill>
-                            <a:srgbClr val="000000"/>
-                          </a:solidFill>
-                          <a:latin typeface="Calibri" pitchFamily="34" charset="0"/>
-                          <a:ea typeface="Calibri" pitchFamily="34" charset="-122"/>
-                          <a:cs typeface="Calibri" pitchFamily="34" charset="-120"/>
-                        </a:rPr>
-                        <a:t>0.949</a:t>
-                      </a:r>
-                      <a:endParaRPr lang="en-US" sz="1000" dirty="0">
+                        <a:rPr lang="en-US" sz="1150" dirty="0">
+                          <a:solidFill>
+                            <a:srgbClr val="000000"/>
+                          </a:solidFill>
+                          <a:latin typeface="Calibri" pitchFamily="34" charset="0"/>
+                          <a:ea typeface="Calibri" pitchFamily="34" charset="-122"/>
+                          <a:cs typeface="Calibri" pitchFamily="34" charset="-120"/>
+                        </a:rPr>
+                        <a:t>0.967</a:t>
+                      </a:r>
+                      <a:endParaRPr lang="en-US" sz="1150" dirty="0">
                         <a:latin typeface="Calibri" charset="0"/>
                         <a:ea typeface="Calibri" charset="0"/>
                         <a:cs typeface="Calibri" charset="0"/>
@@ -11233,7 +11233,895 @@
                         <a:buNone/>
                       </a:pPr>
                       <a:r>
-                        <a:rPr lang="en-US" sz="1000" dirty="0">
+                        <a:rPr lang="en-US" sz="1150" dirty="0">
+                          <a:solidFill>
+                            <a:srgbClr val="000000"/>
+                          </a:solidFill>
+                          <a:latin typeface="Calibri" pitchFamily="34" charset="0"/>
+                          <a:ea typeface="Calibri" pitchFamily="34" charset="-122"/>
+                          <a:cs typeface="Calibri" pitchFamily="34" charset="-120"/>
+                        </a:rPr>
+                        <a:t>0.956</a:t>
+                      </a:r>
+                      <a:endParaRPr lang="en-US" sz="1150" dirty="0">
+                        <a:latin typeface="Calibri" charset="0"/>
+                        <a:ea typeface="Calibri" charset="0"/>
+                        <a:cs typeface="Calibri" charset="0"/>
+                      </a:endParaRPr>
+                    </a:p>
+                  </a:txBody>
+                  <a:tcPr marL="91440" marR="91440" marT="45720" marB="45720" anchor="ctr">
+                    <a:lnL w="6350" cap="flat" cmpd="sng" algn="ctr">
+                      <a:solidFill>
+                        <a:srgbClr val="A6A6A6"/>
+                      </a:solidFill>
+                      <a:prstDash val="solid"/>
+                      <a:round/>
+                      <a:headEnd type="none" w="med" len="med"/>
+                      <a:tailEnd type="none" w="med" len="med"/>
+                    </a:lnL>
+                    <a:lnR w="6350" cap="flat" cmpd="sng" algn="ctr">
+                      <a:solidFill>
+                        <a:srgbClr val="A6A6A6"/>
+                      </a:solidFill>
+                      <a:prstDash val="solid"/>
+                      <a:round/>
+                      <a:headEnd type="none" w="med" len="med"/>
+                      <a:tailEnd type="none" w="med" len="med"/>
+                    </a:lnR>
+                    <a:lnT w="6350" cap="flat" cmpd="sng" algn="ctr">
+                      <a:solidFill>
+                        <a:srgbClr val="A6A6A6"/>
+                      </a:solidFill>
+                      <a:prstDash val="solid"/>
+                      <a:round/>
+                      <a:headEnd type="none" w="med" len="med"/>
+                      <a:tailEnd type="none" w="med" len="med"/>
+                    </a:lnT>
+                    <a:lnB w="6350" cap="flat" cmpd="sng" algn="ctr">
+                      <a:solidFill>
+                        <a:srgbClr val="A6A6A6"/>
+                      </a:solidFill>
+                      <a:prstDash val="solid"/>
+                      <a:round/>
+                      <a:headEnd type="none" w="med" len="med"/>
+                      <a:tailEnd type="none" w="med" len="med"/>
+                    </a:lnB>
+                    <a:solidFill>
+                      <a:srgbClr val="F2F2F2"/>
+                    </a:solidFill>
+                  </a:tcPr>
+                </a:tc>
+                <a:tc>
+                  <a:txBody>
+                    <a:bodyPr/>
+                    <a:lstStyle/>
+                    <a:p>
+                      <a:pPr algn="ctr" indent="0" marL="0">
+                        <a:buNone/>
+                      </a:pPr>
+                      <a:r>
+                        <a:rPr lang="en-US" sz="1150" dirty="0">
+                          <a:solidFill>
+                            <a:srgbClr val="000000"/>
+                          </a:solidFill>
+                          <a:latin typeface="Calibri" pitchFamily="34" charset="0"/>
+                          <a:ea typeface="Calibri" pitchFamily="34" charset="-122"/>
+                          <a:cs typeface="Calibri" pitchFamily="34" charset="-120"/>
+                        </a:rPr>
+                        <a:t>0.958</a:t>
+                      </a:r>
+                      <a:endParaRPr lang="en-US" sz="1150" dirty="0">
+                        <a:latin typeface="Calibri" charset="0"/>
+                        <a:ea typeface="Calibri" charset="0"/>
+                        <a:cs typeface="Calibri" charset="0"/>
+                      </a:endParaRPr>
+                    </a:p>
+                  </a:txBody>
+                  <a:tcPr marL="91440" marR="91440" marT="45720" marB="45720" anchor="ctr">
+                    <a:lnL w="6350" cap="flat" cmpd="sng" algn="ctr">
+                      <a:solidFill>
+                        <a:srgbClr val="A6A6A6"/>
+                      </a:solidFill>
+                      <a:prstDash val="solid"/>
+                      <a:round/>
+                      <a:headEnd type="none" w="med" len="med"/>
+                      <a:tailEnd type="none" w="med" len="med"/>
+                    </a:lnL>
+                    <a:lnR w="6350" cap="flat" cmpd="sng" algn="ctr">
+                      <a:solidFill>
+                        <a:srgbClr val="A6A6A6"/>
+                      </a:solidFill>
+                      <a:prstDash val="solid"/>
+                      <a:round/>
+                      <a:headEnd type="none" w="med" len="med"/>
+                      <a:tailEnd type="none" w="med" len="med"/>
+                    </a:lnR>
+                    <a:lnT w="6350" cap="flat" cmpd="sng" algn="ctr">
+                      <a:solidFill>
+                        <a:srgbClr val="A6A6A6"/>
+                      </a:solidFill>
+                      <a:prstDash val="solid"/>
+                      <a:round/>
+                      <a:headEnd type="none" w="med" len="med"/>
+                      <a:tailEnd type="none" w="med" len="med"/>
+                    </a:lnT>
+                    <a:lnB w="6350" cap="flat" cmpd="sng" algn="ctr">
+                      <a:solidFill>
+                        <a:srgbClr val="A6A6A6"/>
+                      </a:solidFill>
+                      <a:prstDash val="solid"/>
+                      <a:round/>
+                      <a:headEnd type="none" w="med" len="med"/>
+                      <a:tailEnd type="none" w="med" len="med"/>
+                    </a:lnB>
+                    <a:solidFill>
+                      <a:srgbClr val="F2F2F2"/>
+                    </a:solidFill>
+                  </a:tcPr>
+                </a:tc>
+                <a:tc>
+                  <a:txBody>
+                    <a:bodyPr/>
+                    <a:lstStyle/>
+                    <a:p>
+                      <a:pPr algn="ctr" indent="0" marL="0">
+                        <a:buNone/>
+                      </a:pPr>
+                      <a:r>
+                        <a:rPr lang="en-US" sz="1150" dirty="0">
+                          <a:solidFill>
+                            <a:srgbClr val="000000"/>
+                          </a:solidFill>
+                          <a:latin typeface="Calibri" pitchFamily="34" charset="0"/>
+                          <a:ea typeface="Calibri" pitchFamily="34" charset="-122"/>
+                          <a:cs typeface="Calibri" pitchFamily="34" charset="-120"/>
+                        </a:rPr>
+                        <a:t>0.57</a:t>
+                      </a:r>
+                      <a:endParaRPr lang="en-US" sz="1150" dirty="0">
+                        <a:latin typeface="Calibri" charset="0"/>
+                        <a:ea typeface="Calibri" charset="0"/>
+                        <a:cs typeface="Calibri" charset="0"/>
+                      </a:endParaRPr>
+                    </a:p>
+                  </a:txBody>
+                  <a:tcPr marL="91440" marR="91440" marT="45720" marB="45720" anchor="ctr">
+                    <a:lnL w="6350" cap="flat" cmpd="sng" algn="ctr">
+                      <a:solidFill>
+                        <a:srgbClr val="A6A6A6"/>
+                      </a:solidFill>
+                      <a:prstDash val="solid"/>
+                      <a:round/>
+                      <a:headEnd type="none" w="med" len="med"/>
+                      <a:tailEnd type="none" w="med" len="med"/>
+                    </a:lnL>
+                    <a:lnR w="6350" cap="flat" cmpd="sng" algn="ctr">
+                      <a:solidFill>
+                        <a:srgbClr val="A6A6A6"/>
+                      </a:solidFill>
+                      <a:prstDash val="solid"/>
+                      <a:round/>
+                      <a:headEnd type="none" w="med" len="med"/>
+                      <a:tailEnd type="none" w="med" len="med"/>
+                    </a:lnR>
+                    <a:lnT w="6350" cap="flat" cmpd="sng" algn="ctr">
+                      <a:solidFill>
+                        <a:srgbClr val="A6A6A6"/>
+                      </a:solidFill>
+                      <a:prstDash val="solid"/>
+                      <a:round/>
+                      <a:headEnd type="none" w="med" len="med"/>
+                      <a:tailEnd type="none" w="med" len="med"/>
+                    </a:lnT>
+                    <a:lnB w="6350" cap="flat" cmpd="sng" algn="ctr">
+                      <a:solidFill>
+                        <a:srgbClr val="A6A6A6"/>
+                      </a:solidFill>
+                      <a:prstDash val="solid"/>
+                      <a:round/>
+                      <a:headEnd type="none" w="med" len="med"/>
+                      <a:tailEnd type="none" w="med" len="med"/>
+                    </a:lnB>
+                    <a:solidFill>
+                      <a:srgbClr val="F2F2F2"/>
+                    </a:solidFill>
+                  </a:tcPr>
+                </a:tc>
+                <a:tc>
+                  <a:txBody>
+                    <a:bodyPr/>
+                    <a:lstStyle/>
+                    <a:p>
+                      <a:pPr algn="ctr" indent="0" marL="0">
+                        <a:buNone/>
+                      </a:pPr>
+                      <a:r>
+                        <a:rPr lang="en-US" sz="1150" dirty="0">
+                          <a:solidFill>
+                            <a:srgbClr val="000000"/>
+                          </a:solidFill>
+                          <a:latin typeface="Calibri" pitchFamily="34" charset="0"/>
+                          <a:ea typeface="Calibri" pitchFamily="34" charset="-122"/>
+                          <a:cs typeface="Calibri" pitchFamily="34" charset="-120"/>
+                        </a:rPr>
+                        <a:t>80.6</a:t>
+                      </a:r>
+                      <a:endParaRPr lang="en-US" sz="1150" dirty="0">
+                        <a:latin typeface="Calibri" charset="0"/>
+                        <a:ea typeface="Calibri" charset="0"/>
+                        <a:cs typeface="Calibri" charset="0"/>
+                      </a:endParaRPr>
+                    </a:p>
+                  </a:txBody>
+                  <a:tcPr marL="91440" marR="91440" marT="45720" marB="45720" anchor="ctr">
+                    <a:lnL w="6350" cap="flat" cmpd="sng" algn="ctr">
+                      <a:solidFill>
+                        <a:srgbClr val="A6A6A6"/>
+                      </a:solidFill>
+                      <a:prstDash val="solid"/>
+                      <a:round/>
+                      <a:headEnd type="none" w="med" len="med"/>
+                      <a:tailEnd type="none" w="med" len="med"/>
+                    </a:lnL>
+                    <a:lnR w="6350" cap="flat" cmpd="sng" algn="ctr">
+                      <a:solidFill>
+                        <a:srgbClr val="A6A6A6"/>
+                      </a:solidFill>
+                      <a:prstDash val="solid"/>
+                      <a:round/>
+                      <a:headEnd type="none" w="med" len="med"/>
+                      <a:tailEnd type="none" w="med" len="med"/>
+                    </a:lnR>
+                    <a:lnT w="6350" cap="flat" cmpd="sng" algn="ctr">
+                      <a:solidFill>
+                        <a:srgbClr val="A6A6A6"/>
+                      </a:solidFill>
+                      <a:prstDash val="solid"/>
+                      <a:round/>
+                      <a:headEnd type="none" w="med" len="med"/>
+                      <a:tailEnd type="none" w="med" len="med"/>
+                    </a:lnT>
+                    <a:lnB w="6350" cap="flat" cmpd="sng" algn="ctr">
+                      <a:solidFill>
+                        <a:srgbClr val="A6A6A6"/>
+                      </a:solidFill>
+                      <a:prstDash val="solid"/>
+                      <a:round/>
+                      <a:headEnd type="none" w="med" len="med"/>
+                      <a:tailEnd type="none" w="med" len="med"/>
+                    </a:lnB>
+                    <a:solidFill>
+                      <a:srgbClr val="F2F2F2"/>
+                    </a:solidFill>
+                  </a:tcPr>
+                </a:tc>
+                <a:tc>
+                  <a:txBody>
+                    <a:bodyPr/>
+                    <a:lstStyle/>
+                    <a:p>
+                      <a:pPr algn="ctr" indent="0" marL="0">
+                        <a:buNone/>
+                      </a:pPr>
+                      <a:r>
+                        <a:rPr lang="en-US" sz="1150" dirty="0">
+                          <a:solidFill>
+                            <a:srgbClr val="000000"/>
+                          </a:solidFill>
+                          <a:latin typeface="Calibri" pitchFamily="34" charset="0"/>
+                          <a:ea typeface="Calibri" pitchFamily="34" charset="-122"/>
+                          <a:cs typeface="Calibri" pitchFamily="34" charset="-120"/>
+                        </a:rPr>
+                        <a:t>1.00</a:t>
+                      </a:r>
+                      <a:endParaRPr lang="en-US" sz="1150" dirty="0">
+                        <a:latin typeface="Calibri" charset="0"/>
+                        <a:ea typeface="Calibri" charset="0"/>
+                        <a:cs typeface="Calibri" charset="0"/>
+                      </a:endParaRPr>
+                    </a:p>
+                  </a:txBody>
+                  <a:tcPr marL="91440" marR="91440" marT="45720" marB="45720" anchor="ctr">
+                    <a:lnL w="6350" cap="flat" cmpd="sng" algn="ctr">
+                      <a:solidFill>
+                        <a:srgbClr val="A6A6A6"/>
+                      </a:solidFill>
+                      <a:prstDash val="solid"/>
+                      <a:round/>
+                      <a:headEnd type="none" w="med" len="med"/>
+                      <a:tailEnd type="none" w="med" len="med"/>
+                    </a:lnL>
+                    <a:lnR w="6350" cap="flat" cmpd="sng" algn="ctr">
+                      <a:solidFill>
+                        <a:srgbClr val="A6A6A6"/>
+                      </a:solidFill>
+                      <a:prstDash val="solid"/>
+                      <a:round/>
+                      <a:headEnd type="none" w="med" len="med"/>
+                      <a:tailEnd type="none" w="med" len="med"/>
+                    </a:lnR>
+                    <a:lnT w="6350" cap="flat" cmpd="sng" algn="ctr">
+                      <a:solidFill>
+                        <a:srgbClr val="A6A6A6"/>
+                      </a:solidFill>
+                      <a:prstDash val="solid"/>
+                      <a:round/>
+                      <a:headEnd type="none" w="med" len="med"/>
+                      <a:tailEnd type="none" w="med" len="med"/>
+                    </a:lnT>
+                    <a:lnB w="6350" cap="flat" cmpd="sng" algn="ctr">
+                      <a:solidFill>
+                        <a:srgbClr val="A6A6A6"/>
+                      </a:solidFill>
+                      <a:prstDash val="solid"/>
+                      <a:round/>
+                      <a:headEnd type="none" w="med" len="med"/>
+                      <a:tailEnd type="none" w="med" len="med"/>
+                    </a:lnB>
+                    <a:solidFill>
+                      <a:srgbClr val="F2F2F2"/>
+                    </a:solidFill>
+                  </a:tcPr>
+                </a:tc>
+              </a:tr>
+              <a:tr h="438912">
+                <a:tc>
+                  <a:txBody>
+                    <a:bodyPr/>
+                    <a:lstStyle/>
+                    <a:p>
+                      <a:pPr algn="l" indent="0" marL="0">
+                        <a:buNone/>
+                      </a:pPr>
+                      <a:r>
+                        <a:rPr lang="en-US" sz="1150" dirty="0">
+                          <a:solidFill>
+                            <a:srgbClr val="000000"/>
+                          </a:solidFill>
+                          <a:latin typeface="Calibri" pitchFamily="34" charset="0"/>
+                          <a:ea typeface="Calibri" pitchFamily="34" charset="-122"/>
+                          <a:cs typeface="Calibri" pitchFamily="34" charset="-120"/>
+                        </a:rPr>
+                        <a:t>uwtig_no_coverage_first</a:t>
+                      </a:r>
+                      <a:endParaRPr lang="en-US" sz="1150" dirty="0">
+                        <a:latin typeface="Calibri" charset="0"/>
+                        <a:ea typeface="Calibri" charset="0"/>
+                        <a:cs typeface="Calibri" charset="0"/>
+                      </a:endParaRPr>
+                    </a:p>
+                  </a:txBody>
+                  <a:tcPr marL="91440" marR="91440" marT="45720" marB="45720" anchor="ctr">
+                    <a:lnL w="6350" cap="flat" cmpd="sng" algn="ctr">
+                      <a:solidFill>
+                        <a:srgbClr val="A6A6A6"/>
+                      </a:solidFill>
+                      <a:prstDash val="solid"/>
+                      <a:round/>
+                      <a:headEnd type="none" w="med" len="med"/>
+                      <a:tailEnd type="none" w="med" len="med"/>
+                    </a:lnL>
+                    <a:lnR w="6350" cap="flat" cmpd="sng" algn="ctr">
+                      <a:solidFill>
+                        <a:srgbClr val="A6A6A6"/>
+                      </a:solidFill>
+                      <a:prstDash val="solid"/>
+                      <a:round/>
+                      <a:headEnd type="none" w="med" len="med"/>
+                      <a:tailEnd type="none" w="med" len="med"/>
+                    </a:lnR>
+                    <a:lnT w="6350" cap="flat" cmpd="sng" algn="ctr">
+                      <a:solidFill>
+                        <a:srgbClr val="A6A6A6"/>
+                      </a:solidFill>
+                      <a:prstDash val="solid"/>
+                      <a:round/>
+                      <a:headEnd type="none" w="med" len="med"/>
+                      <a:tailEnd type="none" w="med" len="med"/>
+                    </a:lnT>
+                    <a:lnB w="6350" cap="flat" cmpd="sng" algn="ctr">
+                      <a:solidFill>
+                        <a:srgbClr val="A6A6A6"/>
+                      </a:solidFill>
+                      <a:prstDash val="solid"/>
+                      <a:round/>
+                      <a:headEnd type="none" w="med" len="med"/>
+                      <a:tailEnd type="none" w="med" len="med"/>
+                    </a:lnB>
+                    <a:solidFill>
+                      <a:srgbClr val="FFFFFF"/>
+                    </a:solidFill>
+                  </a:tcPr>
+                </a:tc>
+                <a:tc>
+                  <a:txBody>
+                    <a:bodyPr/>
+                    <a:lstStyle/>
+                    <a:p>
+                      <a:pPr algn="ctr" indent="0" marL="0">
+                        <a:buNone/>
+                      </a:pPr>
+                      <a:r>
+                        <a:rPr lang="en-US" sz="1150" dirty="0">
+                          <a:solidFill>
+                            <a:srgbClr val="000000"/>
+                          </a:solidFill>
+                          <a:latin typeface="Calibri" pitchFamily="34" charset="0"/>
+                          <a:ea typeface="Calibri" pitchFamily="34" charset="-122"/>
+                          <a:cs typeface="Calibri" pitchFamily="34" charset="-120"/>
+                        </a:rPr>
+                        <a:t>0.911</a:t>
+                      </a:r>
+                      <a:endParaRPr lang="en-US" sz="1150" dirty="0">
+                        <a:latin typeface="Calibri" charset="0"/>
+                        <a:ea typeface="Calibri" charset="0"/>
+                        <a:cs typeface="Calibri" charset="0"/>
+                      </a:endParaRPr>
+                    </a:p>
+                  </a:txBody>
+                  <a:tcPr marL="91440" marR="91440" marT="45720" marB="45720" anchor="ctr">
+                    <a:lnL w="6350" cap="flat" cmpd="sng" algn="ctr">
+                      <a:solidFill>
+                        <a:srgbClr val="A6A6A6"/>
+                      </a:solidFill>
+                      <a:prstDash val="solid"/>
+                      <a:round/>
+                      <a:headEnd type="none" w="med" len="med"/>
+                      <a:tailEnd type="none" w="med" len="med"/>
+                    </a:lnL>
+                    <a:lnR w="6350" cap="flat" cmpd="sng" algn="ctr">
+                      <a:solidFill>
+                        <a:srgbClr val="A6A6A6"/>
+                      </a:solidFill>
+                      <a:prstDash val="solid"/>
+                      <a:round/>
+                      <a:headEnd type="none" w="med" len="med"/>
+                      <a:tailEnd type="none" w="med" len="med"/>
+                    </a:lnR>
+                    <a:lnT w="6350" cap="flat" cmpd="sng" algn="ctr">
+                      <a:solidFill>
+                        <a:srgbClr val="A6A6A6"/>
+                      </a:solidFill>
+                      <a:prstDash val="solid"/>
+                      <a:round/>
+                      <a:headEnd type="none" w="med" len="med"/>
+                      <a:tailEnd type="none" w="med" len="med"/>
+                    </a:lnT>
+                    <a:lnB w="6350" cap="flat" cmpd="sng" algn="ctr">
+                      <a:solidFill>
+                        <a:srgbClr val="A6A6A6"/>
+                      </a:solidFill>
+                      <a:prstDash val="solid"/>
+                      <a:round/>
+                      <a:headEnd type="none" w="med" len="med"/>
+                      <a:tailEnd type="none" w="med" len="med"/>
+                    </a:lnB>
+                    <a:solidFill>
+                      <a:srgbClr val="FFFFFF"/>
+                    </a:solidFill>
+                  </a:tcPr>
+                </a:tc>
+                <a:tc>
+                  <a:txBody>
+                    <a:bodyPr/>
+                    <a:lstStyle/>
+                    <a:p>
+                      <a:pPr algn="ctr" indent="0" marL="0">
+                        <a:buNone/>
+                      </a:pPr>
+                      <a:r>
+                        <a:rPr lang="en-US" sz="1150" dirty="0">
+                          <a:solidFill>
+                            <a:srgbClr val="000000"/>
+                          </a:solidFill>
+                          <a:latin typeface="Calibri" pitchFamily="34" charset="0"/>
+                          <a:ea typeface="Calibri" pitchFamily="34" charset="-122"/>
+                          <a:cs typeface="Calibri" pitchFamily="34" charset="-120"/>
+                        </a:rPr>
+                        <a:t>0.556</a:t>
+                      </a:r>
+                      <a:endParaRPr lang="en-US" sz="1150" dirty="0">
+                        <a:latin typeface="Calibri" charset="0"/>
+                        <a:ea typeface="Calibri" charset="0"/>
+                        <a:cs typeface="Calibri" charset="0"/>
+                      </a:endParaRPr>
+                    </a:p>
+                  </a:txBody>
+                  <a:tcPr marL="91440" marR="91440" marT="45720" marB="45720" anchor="ctr">
+                    <a:lnL w="6350" cap="flat" cmpd="sng" algn="ctr">
+                      <a:solidFill>
+                        <a:srgbClr val="A6A6A6"/>
+                      </a:solidFill>
+                      <a:prstDash val="solid"/>
+                      <a:round/>
+                      <a:headEnd type="none" w="med" len="med"/>
+                      <a:tailEnd type="none" w="med" len="med"/>
+                    </a:lnL>
+                    <a:lnR w="6350" cap="flat" cmpd="sng" algn="ctr">
+                      <a:solidFill>
+                        <a:srgbClr val="A6A6A6"/>
+                      </a:solidFill>
+                      <a:prstDash val="solid"/>
+                      <a:round/>
+                      <a:headEnd type="none" w="med" len="med"/>
+                      <a:tailEnd type="none" w="med" len="med"/>
+                    </a:lnR>
+                    <a:lnT w="6350" cap="flat" cmpd="sng" algn="ctr">
+                      <a:solidFill>
+                        <a:srgbClr val="A6A6A6"/>
+                      </a:solidFill>
+                      <a:prstDash val="solid"/>
+                      <a:round/>
+                      <a:headEnd type="none" w="med" len="med"/>
+                      <a:tailEnd type="none" w="med" len="med"/>
+                    </a:lnT>
+                    <a:lnB w="6350" cap="flat" cmpd="sng" algn="ctr">
+                      <a:solidFill>
+                        <a:srgbClr val="A6A6A6"/>
+                      </a:solidFill>
+                      <a:prstDash val="solid"/>
+                      <a:round/>
+                      <a:headEnd type="none" w="med" len="med"/>
+                      <a:tailEnd type="none" w="med" len="med"/>
+                    </a:lnB>
+                    <a:solidFill>
+                      <a:srgbClr val="FFFFFF"/>
+                    </a:solidFill>
+                  </a:tcPr>
+                </a:tc>
+                <a:tc>
+                  <a:txBody>
+                    <a:bodyPr/>
+                    <a:lstStyle/>
+                    <a:p>
+                      <a:pPr algn="ctr" indent="0" marL="0">
+                        <a:buNone/>
+                      </a:pPr>
+                      <a:r>
+                        <a:rPr lang="en-US" sz="1150" dirty="0">
+                          <a:solidFill>
+                            <a:srgbClr val="000000"/>
+                          </a:solidFill>
+                          <a:latin typeface="Calibri" pitchFamily="34" charset="0"/>
+                          <a:ea typeface="Calibri" pitchFamily="34" charset="-122"/>
+                          <a:cs typeface="Calibri" pitchFamily="34" charset="-120"/>
+                        </a:rPr>
+                        <a:t>0.680</a:t>
+                      </a:r>
+                      <a:endParaRPr lang="en-US" sz="1150" dirty="0">
+                        <a:latin typeface="Calibri" charset="0"/>
+                        <a:ea typeface="Calibri" charset="0"/>
+                        <a:cs typeface="Calibri" charset="0"/>
+                      </a:endParaRPr>
+                    </a:p>
+                  </a:txBody>
+                  <a:tcPr marL="91440" marR="91440" marT="45720" marB="45720" anchor="ctr">
+                    <a:lnL w="6350" cap="flat" cmpd="sng" algn="ctr">
+                      <a:solidFill>
+                        <a:srgbClr val="A6A6A6"/>
+                      </a:solidFill>
+                      <a:prstDash val="solid"/>
+                      <a:round/>
+                      <a:headEnd type="none" w="med" len="med"/>
+                      <a:tailEnd type="none" w="med" len="med"/>
+                    </a:lnL>
+                    <a:lnR w="6350" cap="flat" cmpd="sng" algn="ctr">
+                      <a:solidFill>
+                        <a:srgbClr val="A6A6A6"/>
+                      </a:solidFill>
+                      <a:prstDash val="solid"/>
+                      <a:round/>
+                      <a:headEnd type="none" w="med" len="med"/>
+                      <a:tailEnd type="none" w="med" len="med"/>
+                    </a:lnR>
+                    <a:lnT w="6350" cap="flat" cmpd="sng" algn="ctr">
+                      <a:solidFill>
+                        <a:srgbClr val="A6A6A6"/>
+                      </a:solidFill>
+                      <a:prstDash val="solid"/>
+                      <a:round/>
+                      <a:headEnd type="none" w="med" len="med"/>
+                      <a:tailEnd type="none" w="med" len="med"/>
+                    </a:lnT>
+                    <a:lnB w="6350" cap="flat" cmpd="sng" algn="ctr">
+                      <a:solidFill>
+                        <a:srgbClr val="A6A6A6"/>
+                      </a:solidFill>
+                      <a:prstDash val="solid"/>
+                      <a:round/>
+                      <a:headEnd type="none" w="med" len="med"/>
+                      <a:tailEnd type="none" w="med" len="med"/>
+                    </a:lnB>
+                    <a:solidFill>
+                      <a:srgbClr val="FFFFFF"/>
+                    </a:solidFill>
+                  </a:tcPr>
+                </a:tc>
+                <a:tc>
+                  <a:txBody>
+                    <a:bodyPr/>
+                    <a:lstStyle/>
+                    <a:p>
+                      <a:pPr algn="ctr" indent="0" marL="0">
+                        <a:buNone/>
+                      </a:pPr>
+                      <a:r>
+                        <a:rPr lang="en-US" sz="1150" dirty="0">
+                          <a:solidFill>
+                            <a:srgbClr val="000000"/>
+                          </a:solidFill>
+                          <a:latin typeface="Calibri" pitchFamily="34" charset="0"/>
+                          <a:ea typeface="Calibri" pitchFamily="34" charset="-122"/>
+                          <a:cs typeface="Calibri" pitchFamily="34" charset="-120"/>
+                        </a:rPr>
+                        <a:t>0.81</a:t>
+                      </a:r>
+                      <a:endParaRPr lang="en-US" sz="1150" dirty="0">
+                        <a:latin typeface="Calibri" charset="0"/>
+                        <a:ea typeface="Calibri" charset="0"/>
+                        <a:cs typeface="Calibri" charset="0"/>
+                      </a:endParaRPr>
+                    </a:p>
+                  </a:txBody>
+                  <a:tcPr marL="91440" marR="91440" marT="45720" marB="45720" anchor="ctr">
+                    <a:lnL w="6350" cap="flat" cmpd="sng" algn="ctr">
+                      <a:solidFill>
+                        <a:srgbClr val="A6A6A6"/>
+                      </a:solidFill>
+                      <a:prstDash val="solid"/>
+                      <a:round/>
+                      <a:headEnd type="none" w="med" len="med"/>
+                      <a:tailEnd type="none" w="med" len="med"/>
+                    </a:lnL>
+                    <a:lnR w="6350" cap="flat" cmpd="sng" algn="ctr">
+                      <a:solidFill>
+                        <a:srgbClr val="A6A6A6"/>
+                      </a:solidFill>
+                      <a:prstDash val="solid"/>
+                      <a:round/>
+                      <a:headEnd type="none" w="med" len="med"/>
+                      <a:tailEnd type="none" w="med" len="med"/>
+                    </a:lnR>
+                    <a:lnT w="6350" cap="flat" cmpd="sng" algn="ctr">
+                      <a:solidFill>
+                        <a:srgbClr val="A6A6A6"/>
+                      </a:solidFill>
+                      <a:prstDash val="solid"/>
+                      <a:round/>
+                      <a:headEnd type="none" w="med" len="med"/>
+                      <a:tailEnd type="none" w="med" len="med"/>
+                    </a:lnT>
+                    <a:lnB w="6350" cap="flat" cmpd="sng" algn="ctr">
+                      <a:solidFill>
+                        <a:srgbClr val="A6A6A6"/>
+                      </a:solidFill>
+                      <a:prstDash val="solid"/>
+                      <a:round/>
+                      <a:headEnd type="none" w="med" len="med"/>
+                      <a:tailEnd type="none" w="med" len="med"/>
+                    </a:lnB>
+                    <a:solidFill>
+                      <a:srgbClr val="FFFFFF"/>
+                    </a:solidFill>
+                  </a:tcPr>
+                </a:tc>
+                <a:tc>
+                  <a:txBody>
+                    <a:bodyPr/>
+                    <a:lstStyle/>
+                    <a:p>
+                      <a:pPr algn="ctr" indent="0" marL="0">
+                        <a:buNone/>
+                      </a:pPr>
+                      <a:r>
+                        <a:rPr lang="en-US" sz="1150" dirty="0">
+                          <a:solidFill>
+                            <a:srgbClr val="000000"/>
+                          </a:solidFill>
+                          <a:latin typeface="Calibri" pitchFamily="34" charset="0"/>
+                          <a:ea typeface="Calibri" pitchFamily="34" charset="-122"/>
+                          <a:cs typeface="Calibri" pitchFamily="34" charset="-120"/>
+                        </a:rPr>
+                        <a:t>13.4</a:t>
+                      </a:r>
+                      <a:endParaRPr lang="en-US" sz="1150" dirty="0">
+                        <a:latin typeface="Calibri" charset="0"/>
+                        <a:ea typeface="Calibri" charset="0"/>
+                        <a:cs typeface="Calibri" charset="0"/>
+                      </a:endParaRPr>
+                    </a:p>
+                  </a:txBody>
+                  <a:tcPr marL="91440" marR="91440" marT="45720" marB="45720" anchor="ctr">
+                    <a:lnL w="6350" cap="flat" cmpd="sng" algn="ctr">
+                      <a:solidFill>
+                        <a:srgbClr val="A6A6A6"/>
+                      </a:solidFill>
+                      <a:prstDash val="solid"/>
+                      <a:round/>
+                      <a:headEnd type="none" w="med" len="med"/>
+                      <a:tailEnd type="none" w="med" len="med"/>
+                    </a:lnL>
+                    <a:lnR w="6350" cap="flat" cmpd="sng" algn="ctr">
+                      <a:solidFill>
+                        <a:srgbClr val="A6A6A6"/>
+                      </a:solidFill>
+                      <a:prstDash val="solid"/>
+                      <a:round/>
+                      <a:headEnd type="none" w="med" len="med"/>
+                      <a:tailEnd type="none" w="med" len="med"/>
+                    </a:lnR>
+                    <a:lnT w="6350" cap="flat" cmpd="sng" algn="ctr">
+                      <a:solidFill>
+                        <a:srgbClr val="A6A6A6"/>
+                      </a:solidFill>
+                      <a:prstDash val="solid"/>
+                      <a:round/>
+                      <a:headEnd type="none" w="med" len="med"/>
+                      <a:tailEnd type="none" w="med" len="med"/>
+                    </a:lnT>
+                    <a:lnB w="6350" cap="flat" cmpd="sng" algn="ctr">
+                      <a:solidFill>
+                        <a:srgbClr val="A6A6A6"/>
+                      </a:solidFill>
+                      <a:prstDash val="solid"/>
+                      <a:round/>
+                      <a:headEnd type="none" w="med" len="med"/>
+                      <a:tailEnd type="none" w="med" len="med"/>
+                    </a:lnB>
+                    <a:solidFill>
+                      <a:srgbClr val="FFFFFF"/>
+                    </a:solidFill>
+                  </a:tcPr>
+                </a:tc>
+                <a:tc>
+                  <a:txBody>
+                    <a:bodyPr/>
+                    <a:lstStyle/>
+                    <a:p>
+                      <a:pPr algn="ctr" indent="0" marL="0">
+                        <a:buNone/>
+                      </a:pPr>
+                      <a:r>
+                        <a:rPr lang="en-US" sz="1150" dirty="0">
+                          <a:solidFill>
+                            <a:srgbClr val="000000"/>
+                          </a:solidFill>
+                          <a:latin typeface="Calibri" pitchFamily="34" charset="0"/>
+                          <a:ea typeface="Calibri" pitchFamily="34" charset="-122"/>
+                          <a:cs typeface="Calibri" pitchFamily="34" charset="-120"/>
+                        </a:rPr>
+                        <a:t>0.44</a:t>
+                      </a:r>
+                      <a:endParaRPr lang="en-US" sz="1150" dirty="0">
+                        <a:latin typeface="Calibri" charset="0"/>
+                        <a:ea typeface="Calibri" charset="0"/>
+                        <a:cs typeface="Calibri" charset="0"/>
+                      </a:endParaRPr>
+                    </a:p>
+                  </a:txBody>
+                  <a:tcPr marL="91440" marR="91440" marT="45720" marB="45720" anchor="ctr">
+                    <a:lnL w="6350" cap="flat" cmpd="sng" algn="ctr">
+                      <a:solidFill>
+                        <a:srgbClr val="A6A6A6"/>
+                      </a:solidFill>
+                      <a:prstDash val="solid"/>
+                      <a:round/>
+                      <a:headEnd type="none" w="med" len="med"/>
+                      <a:tailEnd type="none" w="med" len="med"/>
+                    </a:lnL>
+                    <a:lnR w="6350" cap="flat" cmpd="sng" algn="ctr">
+                      <a:solidFill>
+                        <a:srgbClr val="A6A6A6"/>
+                      </a:solidFill>
+                      <a:prstDash val="solid"/>
+                      <a:round/>
+                      <a:headEnd type="none" w="med" len="med"/>
+                      <a:tailEnd type="none" w="med" len="med"/>
+                    </a:lnR>
+                    <a:lnT w="6350" cap="flat" cmpd="sng" algn="ctr">
+                      <a:solidFill>
+                        <a:srgbClr val="A6A6A6"/>
+                      </a:solidFill>
+                      <a:prstDash val="solid"/>
+                      <a:round/>
+                      <a:headEnd type="none" w="med" len="med"/>
+                      <a:tailEnd type="none" w="med" len="med"/>
+                    </a:lnT>
+                    <a:lnB w="6350" cap="flat" cmpd="sng" algn="ctr">
+                      <a:solidFill>
+                        <a:srgbClr val="A6A6A6"/>
+                      </a:solidFill>
+                      <a:prstDash val="solid"/>
+                      <a:round/>
+                      <a:headEnd type="none" w="med" len="med"/>
+                      <a:tailEnd type="none" w="med" len="med"/>
+                    </a:lnB>
+                    <a:solidFill>
+                      <a:srgbClr val="FFFFFF"/>
+                    </a:solidFill>
+                  </a:tcPr>
+                </a:tc>
+              </a:tr>
+              <a:tr h="438912">
+                <a:tc>
+                  <a:txBody>
+                    <a:bodyPr/>
+                    <a:lstStyle/>
+                    <a:p>
+                      <a:pPr algn="l" indent="0" marL="0">
+                        <a:buNone/>
+                      </a:pPr>
+                      <a:r>
+                        <a:rPr lang="en-US" sz="1150" dirty="0">
+                          <a:solidFill>
+                            <a:srgbClr val="000000"/>
+                          </a:solidFill>
+                          <a:latin typeface="Calibri" pitchFamily="34" charset="0"/>
+                          <a:ea typeface="Calibri" pitchFamily="34" charset="-122"/>
+                          <a:cs typeface="Calibri" pitchFamily="34" charset="-120"/>
+                        </a:rPr>
+                        <a:t>uwtig_no_lookahead</a:t>
+                      </a:r>
+                      <a:endParaRPr lang="en-US" sz="1150" dirty="0">
+                        <a:latin typeface="Calibri" charset="0"/>
+                        <a:ea typeface="Calibri" charset="0"/>
+                        <a:cs typeface="Calibri" charset="0"/>
+                      </a:endParaRPr>
+                    </a:p>
+                  </a:txBody>
+                  <a:tcPr marL="91440" marR="91440" marT="45720" marB="45720" anchor="ctr">
+                    <a:lnL w="6350" cap="flat" cmpd="sng" algn="ctr">
+                      <a:solidFill>
+                        <a:srgbClr val="A6A6A6"/>
+                      </a:solidFill>
+                      <a:prstDash val="solid"/>
+                      <a:round/>
+                      <a:headEnd type="none" w="med" len="med"/>
+                      <a:tailEnd type="none" w="med" len="med"/>
+                    </a:lnL>
+                    <a:lnR w="6350" cap="flat" cmpd="sng" algn="ctr">
+                      <a:solidFill>
+                        <a:srgbClr val="A6A6A6"/>
+                      </a:solidFill>
+                      <a:prstDash val="solid"/>
+                      <a:round/>
+                      <a:headEnd type="none" w="med" len="med"/>
+                      <a:tailEnd type="none" w="med" len="med"/>
+                    </a:lnR>
+                    <a:lnT w="6350" cap="flat" cmpd="sng" algn="ctr">
+                      <a:solidFill>
+                        <a:srgbClr val="A6A6A6"/>
+                      </a:solidFill>
+                      <a:prstDash val="solid"/>
+                      <a:round/>
+                      <a:headEnd type="none" w="med" len="med"/>
+                      <a:tailEnd type="none" w="med" len="med"/>
+                    </a:lnT>
+                    <a:lnB w="6350" cap="flat" cmpd="sng" algn="ctr">
+                      <a:solidFill>
+                        <a:srgbClr val="A6A6A6"/>
+                      </a:solidFill>
+                      <a:prstDash val="solid"/>
+                      <a:round/>
+                      <a:headEnd type="none" w="med" len="med"/>
+                      <a:tailEnd type="none" w="med" len="med"/>
+                    </a:lnB>
+                    <a:solidFill>
+                      <a:srgbClr val="F2F2F2"/>
+                    </a:solidFill>
+                  </a:tcPr>
+                </a:tc>
+                <a:tc>
+                  <a:txBody>
+                    <a:bodyPr/>
+                    <a:lstStyle/>
+                    <a:p>
+                      <a:pPr algn="ctr" indent="0" marL="0">
+                        <a:buNone/>
+                      </a:pPr>
+                      <a:r>
+                        <a:rPr lang="en-US" sz="1150" dirty="0">
                           <a:solidFill>
                             <a:srgbClr val="000000"/>
                           </a:solidFill>
@@ -11243,7 +12131,7 @@
                         </a:rPr>
                         <a:t>0.967</a:t>
                       </a:r>
-                      <a:endParaRPr lang="en-US" sz="1000" dirty="0">
+                      <a:endParaRPr lang="en-US" sz="1150" dirty="0">
                         <a:latin typeface="Calibri" charset="0"/>
                         <a:ea typeface="Calibri" charset="0"/>
                         <a:cs typeface="Calibri" charset="0"/>
@@ -11301,17 +12189,17 @@
                         <a:buNone/>
                       </a:pPr>
                       <a:r>
-                        <a:rPr lang="en-US" sz="1000" dirty="0">
-                          <a:solidFill>
-                            <a:srgbClr val="000000"/>
-                          </a:solidFill>
-                          <a:latin typeface="Calibri" pitchFamily="34" charset="0"/>
-                          <a:ea typeface="Calibri" pitchFamily="34" charset="-122"/>
-                          <a:cs typeface="Calibri" pitchFamily="34" charset="-120"/>
-                        </a:rPr>
-                        <a:t>0.953</a:t>
-                      </a:r>
-                      <a:endParaRPr lang="en-US" sz="1000" dirty="0">
+                        <a:rPr lang="en-US" sz="1150" dirty="0">
+                          <a:solidFill>
+                            <a:srgbClr val="000000"/>
+                          </a:solidFill>
+                          <a:latin typeface="Calibri" pitchFamily="34" charset="0"/>
+                          <a:ea typeface="Calibri" pitchFamily="34" charset="-122"/>
+                          <a:cs typeface="Calibri" pitchFamily="34" charset="-120"/>
+                        </a:rPr>
+                        <a:t>0.956</a:t>
+                      </a:r>
+                      <a:endParaRPr lang="en-US" sz="1150" dirty="0">
                         <a:latin typeface="Calibri" charset="0"/>
                         <a:ea typeface="Calibri" charset="0"/>
                         <a:cs typeface="Calibri" charset="0"/>
@@ -11369,17 +12257,17 @@
                         <a:buNone/>
                       </a:pPr>
                       <a:r>
-                        <a:rPr lang="en-US" sz="1000" dirty="0">
-                          <a:solidFill>
-                            <a:srgbClr val="000000"/>
-                          </a:solidFill>
-                          <a:latin typeface="Calibri" pitchFamily="34" charset="0"/>
-                          <a:ea typeface="Calibri" pitchFamily="34" charset="-122"/>
-                          <a:cs typeface="Calibri" pitchFamily="34" charset="-120"/>
-                        </a:rPr>
-                        <a:t>0.71</a:t>
-                      </a:r>
-                      <a:endParaRPr lang="en-US" sz="1000" dirty="0">
+                        <a:rPr lang="en-US" sz="1150" dirty="0">
+                          <a:solidFill>
+                            <a:srgbClr val="000000"/>
+                          </a:solidFill>
+                          <a:latin typeface="Calibri" pitchFamily="34" charset="0"/>
+                          <a:ea typeface="Calibri" pitchFamily="34" charset="-122"/>
+                          <a:cs typeface="Calibri" pitchFamily="34" charset="-120"/>
+                        </a:rPr>
+                        <a:t>0.958</a:t>
+                      </a:r>
+                      <a:endParaRPr lang="en-US" sz="1150" dirty="0">
                         <a:latin typeface="Calibri" charset="0"/>
                         <a:ea typeface="Calibri" charset="0"/>
                         <a:cs typeface="Calibri" charset="0"/>
@@ -11437,17 +12325,17 @@
                         <a:buNone/>
                       </a:pPr>
                       <a:r>
-                        <a:rPr lang="en-US" sz="1000" dirty="0">
-                          <a:solidFill>
-                            <a:srgbClr val="000000"/>
-                          </a:solidFill>
-                          <a:latin typeface="Calibri" pitchFamily="34" charset="0"/>
-                          <a:ea typeface="Calibri" pitchFamily="34" charset="-122"/>
-                          <a:cs typeface="Calibri" pitchFamily="34" charset="-120"/>
-                        </a:rPr>
-                        <a:t>124.6</a:t>
-                      </a:r>
-                      <a:endParaRPr lang="en-US" sz="1000" dirty="0">
+                        <a:rPr lang="en-US" sz="1150" dirty="0">
+                          <a:solidFill>
+                            <a:srgbClr val="000000"/>
+                          </a:solidFill>
+                          <a:latin typeface="Calibri" pitchFamily="34" charset="0"/>
+                          <a:ea typeface="Calibri" pitchFamily="34" charset="-122"/>
+                          <a:cs typeface="Calibri" pitchFamily="34" charset="-120"/>
+                        </a:rPr>
+                        <a:t>0.59</a:t>
+                      </a:r>
+                      <a:endParaRPr lang="en-US" sz="1150" dirty="0">
                         <a:latin typeface="Calibri" charset="0"/>
                         <a:ea typeface="Calibri" charset="0"/>
                         <a:cs typeface="Calibri" charset="0"/>
@@ -11505,7 +12393,75 @@
                         <a:buNone/>
                       </a:pPr>
                       <a:r>
-                        <a:rPr lang="en-US" sz="1000" dirty="0">
+                        <a:rPr lang="en-US" sz="1150" dirty="0">
+                          <a:solidFill>
+                            <a:srgbClr val="000000"/>
+                          </a:solidFill>
+                          <a:latin typeface="Calibri" pitchFamily="34" charset="0"/>
+                          <a:ea typeface="Calibri" pitchFamily="34" charset="-122"/>
+                          <a:cs typeface="Calibri" pitchFamily="34" charset="-120"/>
+                        </a:rPr>
+                        <a:t>85.2</a:t>
+                      </a:r>
+                      <a:endParaRPr lang="en-US" sz="1150" dirty="0">
+                        <a:latin typeface="Calibri" charset="0"/>
+                        <a:ea typeface="Calibri" charset="0"/>
+                        <a:cs typeface="Calibri" charset="0"/>
+                      </a:endParaRPr>
+                    </a:p>
+                  </a:txBody>
+                  <a:tcPr marL="91440" marR="91440" marT="45720" marB="45720" anchor="ctr">
+                    <a:lnL w="6350" cap="flat" cmpd="sng" algn="ctr">
+                      <a:solidFill>
+                        <a:srgbClr val="A6A6A6"/>
+                      </a:solidFill>
+                      <a:prstDash val="solid"/>
+                      <a:round/>
+                      <a:headEnd type="none" w="med" len="med"/>
+                      <a:tailEnd type="none" w="med" len="med"/>
+                    </a:lnL>
+                    <a:lnR w="6350" cap="flat" cmpd="sng" algn="ctr">
+                      <a:solidFill>
+                        <a:srgbClr val="A6A6A6"/>
+                      </a:solidFill>
+                      <a:prstDash val="solid"/>
+                      <a:round/>
+                      <a:headEnd type="none" w="med" len="med"/>
+                      <a:tailEnd type="none" w="med" len="med"/>
+                    </a:lnR>
+                    <a:lnT w="6350" cap="flat" cmpd="sng" algn="ctr">
+                      <a:solidFill>
+                        <a:srgbClr val="A6A6A6"/>
+                      </a:solidFill>
+                      <a:prstDash val="solid"/>
+                      <a:round/>
+                      <a:headEnd type="none" w="med" len="med"/>
+                      <a:tailEnd type="none" w="med" len="med"/>
+                    </a:lnT>
+                    <a:lnB w="6350" cap="flat" cmpd="sng" algn="ctr">
+                      <a:solidFill>
+                        <a:srgbClr val="A6A6A6"/>
+                      </a:solidFill>
+                      <a:prstDash val="solid"/>
+                      <a:round/>
+                      <a:headEnd type="none" w="med" len="med"/>
+                      <a:tailEnd type="none" w="med" len="med"/>
+                    </a:lnB>
+                    <a:solidFill>
+                      <a:srgbClr val="F2F2F2"/>
+                    </a:solidFill>
+                  </a:tcPr>
+                </a:tc>
+                <a:tc>
+                  <a:txBody>
+                    <a:bodyPr/>
+                    <a:lstStyle/>
+                    <a:p>
+                      <a:pPr algn="ctr" indent="0" marL="0">
+                        <a:buNone/>
+                      </a:pPr>
+                      <a:r>
+                        <a:rPr lang="en-US" sz="1150" dirty="0">
                           <a:solidFill>
                             <a:srgbClr val="000000"/>
                           </a:solidFill>
@@ -11515,1919 +12471,7 @@
                         </a:rPr>
                         <a:t>1.00</a:t>
                       </a:r>
-                      <a:endParaRPr lang="en-US" sz="1000" dirty="0">
-                        <a:latin typeface="Calibri" charset="0"/>
-                        <a:ea typeface="Calibri" charset="0"/>
-                        <a:cs typeface="Calibri" charset="0"/>
-                      </a:endParaRPr>
-                    </a:p>
-                  </a:txBody>
-                  <a:tcPr marL="91440" marR="91440" marT="45720" marB="45720" anchor="ctr">
-                    <a:lnL w="6350" cap="flat" cmpd="sng" algn="ctr">
-                      <a:solidFill>
-                        <a:srgbClr val="A6A6A6"/>
-                      </a:solidFill>
-                      <a:prstDash val="solid"/>
-                      <a:round/>
-                      <a:headEnd type="none" w="med" len="med"/>
-                      <a:tailEnd type="none" w="med" len="med"/>
-                    </a:lnL>
-                    <a:lnR w="6350" cap="flat" cmpd="sng" algn="ctr">
-                      <a:solidFill>
-                        <a:srgbClr val="A6A6A6"/>
-                      </a:solidFill>
-                      <a:prstDash val="solid"/>
-                      <a:round/>
-                      <a:headEnd type="none" w="med" len="med"/>
-                      <a:tailEnd type="none" w="med" len="med"/>
-                    </a:lnR>
-                    <a:lnT w="6350" cap="flat" cmpd="sng" algn="ctr">
-                      <a:solidFill>
-                        <a:srgbClr val="A6A6A6"/>
-                      </a:solidFill>
-                      <a:prstDash val="solid"/>
-                      <a:round/>
-                      <a:headEnd type="none" w="med" len="med"/>
-                      <a:tailEnd type="none" w="med" len="med"/>
-                    </a:lnT>
-                    <a:lnB w="6350" cap="flat" cmpd="sng" algn="ctr">
-                      <a:solidFill>
-                        <a:srgbClr val="A6A6A6"/>
-                      </a:solidFill>
-                      <a:prstDash val="solid"/>
-                      <a:round/>
-                      <a:headEnd type="none" w="med" len="med"/>
-                      <a:tailEnd type="none" w="med" len="med"/>
-                    </a:lnB>
-                    <a:solidFill>
-                      <a:srgbClr val="F2F2F2"/>
-                    </a:solidFill>
-                  </a:tcPr>
-                </a:tc>
-              </a:tr>
-              <a:tr h="347472">
-                <a:tc>
-                  <a:txBody>
-                    <a:bodyPr/>
-                    <a:lstStyle/>
-                    <a:p>
-                      <a:pPr algn="l" indent="0" marL="0">
-                        <a:buNone/>
-                      </a:pPr>
-                      <a:r>
-                        <a:rPr lang="en-US" sz="1000" dirty="0">
-                          <a:solidFill>
-                            <a:srgbClr val="000000"/>
-                          </a:solidFill>
-                          <a:latin typeface="Calibri" pitchFamily="34" charset="0"/>
-                          <a:ea typeface="Calibri" pitchFamily="34" charset="-122"/>
-                          <a:cs typeface="Calibri" pitchFamily="34" charset="-120"/>
-                        </a:rPr>
-                        <a:t>uwtig_no_temporal</a:t>
-                      </a:r>
-                      <a:endParaRPr lang="en-US" sz="1000" dirty="0">
-                        <a:latin typeface="Calibri" charset="0"/>
-                        <a:ea typeface="Calibri" charset="0"/>
-                        <a:cs typeface="Calibri" charset="0"/>
-                      </a:endParaRPr>
-                    </a:p>
-                  </a:txBody>
-                  <a:tcPr marL="91440" marR="91440" marT="45720" marB="45720" anchor="ctr">
-                    <a:lnL w="6350" cap="flat" cmpd="sng" algn="ctr">
-                      <a:solidFill>
-                        <a:srgbClr val="A6A6A6"/>
-                      </a:solidFill>
-                      <a:prstDash val="solid"/>
-                      <a:round/>
-                      <a:headEnd type="none" w="med" len="med"/>
-                      <a:tailEnd type="none" w="med" len="med"/>
-                    </a:lnL>
-                    <a:lnR w="6350" cap="flat" cmpd="sng" algn="ctr">
-                      <a:solidFill>
-                        <a:srgbClr val="A6A6A6"/>
-                      </a:solidFill>
-                      <a:prstDash val="solid"/>
-                      <a:round/>
-                      <a:headEnd type="none" w="med" len="med"/>
-                      <a:tailEnd type="none" w="med" len="med"/>
-                    </a:lnR>
-                    <a:lnT w="6350" cap="flat" cmpd="sng" algn="ctr">
-                      <a:solidFill>
-                        <a:srgbClr val="A6A6A6"/>
-                      </a:solidFill>
-                      <a:prstDash val="solid"/>
-                      <a:round/>
-                      <a:headEnd type="none" w="med" len="med"/>
-                      <a:tailEnd type="none" w="med" len="med"/>
-                    </a:lnT>
-                    <a:lnB w="6350" cap="flat" cmpd="sng" algn="ctr">
-                      <a:solidFill>
-                        <a:srgbClr val="A6A6A6"/>
-                      </a:solidFill>
-                      <a:prstDash val="solid"/>
-                      <a:round/>
-                      <a:headEnd type="none" w="med" len="med"/>
-                      <a:tailEnd type="none" w="med" len="med"/>
-                    </a:lnB>
-                    <a:solidFill>
-                      <a:srgbClr val="FFFFFF"/>
-                    </a:solidFill>
-                  </a:tcPr>
-                </a:tc>
-                <a:tc>
-                  <a:txBody>
-                    <a:bodyPr/>
-                    <a:lstStyle/>
-                    <a:p>
-                      <a:pPr algn="ctr" indent="0" marL="0">
-                        <a:buNone/>
-                      </a:pPr>
-                      <a:r>
-                        <a:rPr lang="en-US" sz="1000" dirty="0">
-                          <a:solidFill>
-                            <a:srgbClr val="000000"/>
-                          </a:solidFill>
-                          <a:latin typeface="Calibri" pitchFamily="34" charset="0"/>
-                          <a:ea typeface="Calibri" pitchFamily="34" charset="-122"/>
-                          <a:cs typeface="Calibri" pitchFamily="34" charset="-120"/>
-                        </a:rPr>
-                        <a:t>0.949</a:t>
-                      </a:r>
-                      <a:endParaRPr lang="en-US" sz="1000" dirty="0">
-                        <a:latin typeface="Calibri" charset="0"/>
-                        <a:ea typeface="Calibri" charset="0"/>
-                        <a:cs typeface="Calibri" charset="0"/>
-                      </a:endParaRPr>
-                    </a:p>
-                  </a:txBody>
-                  <a:tcPr marL="91440" marR="91440" marT="45720" marB="45720" anchor="ctr">
-                    <a:lnL w="6350" cap="flat" cmpd="sng" algn="ctr">
-                      <a:solidFill>
-                        <a:srgbClr val="A6A6A6"/>
-                      </a:solidFill>
-                      <a:prstDash val="solid"/>
-                      <a:round/>
-                      <a:headEnd type="none" w="med" len="med"/>
-                      <a:tailEnd type="none" w="med" len="med"/>
-                    </a:lnL>
-                    <a:lnR w="6350" cap="flat" cmpd="sng" algn="ctr">
-                      <a:solidFill>
-                        <a:srgbClr val="A6A6A6"/>
-                      </a:solidFill>
-                      <a:prstDash val="solid"/>
-                      <a:round/>
-                      <a:headEnd type="none" w="med" len="med"/>
-                      <a:tailEnd type="none" w="med" len="med"/>
-                    </a:lnR>
-                    <a:lnT w="6350" cap="flat" cmpd="sng" algn="ctr">
-                      <a:solidFill>
-                        <a:srgbClr val="A6A6A6"/>
-                      </a:solidFill>
-                      <a:prstDash val="solid"/>
-                      <a:round/>
-                      <a:headEnd type="none" w="med" len="med"/>
-                      <a:tailEnd type="none" w="med" len="med"/>
-                    </a:lnT>
-                    <a:lnB w="6350" cap="flat" cmpd="sng" algn="ctr">
-                      <a:solidFill>
-                        <a:srgbClr val="A6A6A6"/>
-                      </a:solidFill>
-                      <a:prstDash val="solid"/>
-                      <a:round/>
-                      <a:headEnd type="none" w="med" len="med"/>
-                      <a:tailEnd type="none" w="med" len="med"/>
-                    </a:lnB>
-                    <a:solidFill>
-                      <a:srgbClr val="FFFFFF"/>
-                    </a:solidFill>
-                  </a:tcPr>
-                </a:tc>
-                <a:tc>
-                  <a:txBody>
-                    <a:bodyPr/>
-                    <a:lstStyle/>
-                    <a:p>
-                      <a:pPr algn="ctr" indent="0" marL="0">
-                        <a:buNone/>
-                      </a:pPr>
-                      <a:r>
-                        <a:rPr lang="en-US" sz="1000" dirty="0">
-                          <a:solidFill>
-                            <a:srgbClr val="000000"/>
-                          </a:solidFill>
-                          <a:latin typeface="Calibri" pitchFamily="34" charset="0"/>
-                          <a:ea typeface="Calibri" pitchFamily="34" charset="-122"/>
-                          <a:cs typeface="Calibri" pitchFamily="34" charset="-120"/>
-                        </a:rPr>
-                        <a:t>0.967</a:t>
-                      </a:r>
-                      <a:endParaRPr lang="en-US" sz="1000" dirty="0">
-                        <a:latin typeface="Calibri" charset="0"/>
-                        <a:ea typeface="Calibri" charset="0"/>
-                        <a:cs typeface="Calibri" charset="0"/>
-                      </a:endParaRPr>
-                    </a:p>
-                  </a:txBody>
-                  <a:tcPr marL="91440" marR="91440" marT="45720" marB="45720" anchor="ctr">
-                    <a:lnL w="6350" cap="flat" cmpd="sng" algn="ctr">
-                      <a:solidFill>
-                        <a:srgbClr val="A6A6A6"/>
-                      </a:solidFill>
-                      <a:prstDash val="solid"/>
-                      <a:round/>
-                      <a:headEnd type="none" w="med" len="med"/>
-                      <a:tailEnd type="none" w="med" len="med"/>
-                    </a:lnL>
-                    <a:lnR w="6350" cap="flat" cmpd="sng" algn="ctr">
-                      <a:solidFill>
-                        <a:srgbClr val="A6A6A6"/>
-                      </a:solidFill>
-                      <a:prstDash val="solid"/>
-                      <a:round/>
-                      <a:headEnd type="none" w="med" len="med"/>
-                      <a:tailEnd type="none" w="med" len="med"/>
-                    </a:lnR>
-                    <a:lnT w="6350" cap="flat" cmpd="sng" algn="ctr">
-                      <a:solidFill>
-                        <a:srgbClr val="A6A6A6"/>
-                      </a:solidFill>
-                      <a:prstDash val="solid"/>
-                      <a:round/>
-                      <a:headEnd type="none" w="med" len="med"/>
-                      <a:tailEnd type="none" w="med" len="med"/>
-                    </a:lnT>
-                    <a:lnB w="6350" cap="flat" cmpd="sng" algn="ctr">
-                      <a:solidFill>
-                        <a:srgbClr val="A6A6A6"/>
-                      </a:solidFill>
-                      <a:prstDash val="solid"/>
-                      <a:round/>
-                      <a:headEnd type="none" w="med" len="med"/>
-                      <a:tailEnd type="none" w="med" len="med"/>
-                    </a:lnB>
-                    <a:solidFill>
-                      <a:srgbClr val="FFFFFF"/>
-                    </a:solidFill>
-                  </a:tcPr>
-                </a:tc>
-                <a:tc>
-                  <a:txBody>
-                    <a:bodyPr/>
-                    <a:lstStyle/>
-                    <a:p>
-                      <a:pPr algn="ctr" indent="0" marL="0">
-                        <a:buNone/>
-                      </a:pPr>
-                      <a:r>
-                        <a:rPr lang="en-US" sz="1000" dirty="0">
-                          <a:solidFill>
-                            <a:srgbClr val="000000"/>
-                          </a:solidFill>
-                          <a:latin typeface="Calibri" pitchFamily="34" charset="0"/>
-                          <a:ea typeface="Calibri" pitchFamily="34" charset="-122"/>
-                          <a:cs typeface="Calibri" pitchFamily="34" charset="-120"/>
-                        </a:rPr>
-                        <a:t>0.953</a:t>
-                      </a:r>
-                      <a:endParaRPr lang="en-US" sz="1000" dirty="0">
-                        <a:latin typeface="Calibri" charset="0"/>
-                        <a:ea typeface="Calibri" charset="0"/>
-                        <a:cs typeface="Calibri" charset="0"/>
-                      </a:endParaRPr>
-                    </a:p>
-                  </a:txBody>
-                  <a:tcPr marL="91440" marR="91440" marT="45720" marB="45720" anchor="ctr">
-                    <a:lnL w="6350" cap="flat" cmpd="sng" algn="ctr">
-                      <a:solidFill>
-                        <a:srgbClr val="A6A6A6"/>
-                      </a:solidFill>
-                      <a:prstDash val="solid"/>
-                      <a:round/>
-                      <a:headEnd type="none" w="med" len="med"/>
-                      <a:tailEnd type="none" w="med" len="med"/>
-                    </a:lnL>
-                    <a:lnR w="6350" cap="flat" cmpd="sng" algn="ctr">
-                      <a:solidFill>
-                        <a:srgbClr val="A6A6A6"/>
-                      </a:solidFill>
-                      <a:prstDash val="solid"/>
-                      <a:round/>
-                      <a:headEnd type="none" w="med" len="med"/>
-                      <a:tailEnd type="none" w="med" len="med"/>
-                    </a:lnR>
-                    <a:lnT w="6350" cap="flat" cmpd="sng" algn="ctr">
-                      <a:solidFill>
-                        <a:srgbClr val="A6A6A6"/>
-                      </a:solidFill>
-                      <a:prstDash val="solid"/>
-                      <a:round/>
-                      <a:headEnd type="none" w="med" len="med"/>
-                      <a:tailEnd type="none" w="med" len="med"/>
-                    </a:lnT>
-                    <a:lnB w="6350" cap="flat" cmpd="sng" algn="ctr">
-                      <a:solidFill>
-                        <a:srgbClr val="A6A6A6"/>
-                      </a:solidFill>
-                      <a:prstDash val="solid"/>
-                      <a:round/>
-                      <a:headEnd type="none" w="med" len="med"/>
-                      <a:tailEnd type="none" w="med" len="med"/>
-                    </a:lnB>
-                    <a:solidFill>
-                      <a:srgbClr val="FFFFFF"/>
-                    </a:solidFill>
-                  </a:tcPr>
-                </a:tc>
-                <a:tc>
-                  <a:txBody>
-                    <a:bodyPr/>
-                    <a:lstStyle/>
-                    <a:p>
-                      <a:pPr algn="ctr" indent="0" marL="0">
-                        <a:buNone/>
-                      </a:pPr>
-                      <a:r>
-                        <a:rPr lang="en-US" sz="1000" dirty="0">
-                          <a:solidFill>
-                            <a:srgbClr val="000000"/>
-                          </a:solidFill>
-                          <a:latin typeface="Calibri" pitchFamily="34" charset="0"/>
-                          <a:ea typeface="Calibri" pitchFamily="34" charset="-122"/>
-                          <a:cs typeface="Calibri" pitchFamily="34" charset="-120"/>
-                        </a:rPr>
-                        <a:t>0.70</a:t>
-                      </a:r>
-                      <a:endParaRPr lang="en-US" sz="1000" dirty="0">
-                        <a:latin typeface="Calibri" charset="0"/>
-                        <a:ea typeface="Calibri" charset="0"/>
-                        <a:cs typeface="Calibri" charset="0"/>
-                      </a:endParaRPr>
-                    </a:p>
-                  </a:txBody>
-                  <a:tcPr marL="91440" marR="91440" marT="45720" marB="45720" anchor="ctr">
-                    <a:lnL w="6350" cap="flat" cmpd="sng" algn="ctr">
-                      <a:solidFill>
-                        <a:srgbClr val="A6A6A6"/>
-                      </a:solidFill>
-                      <a:prstDash val="solid"/>
-                      <a:round/>
-                      <a:headEnd type="none" w="med" len="med"/>
-                      <a:tailEnd type="none" w="med" len="med"/>
-                    </a:lnL>
-                    <a:lnR w="6350" cap="flat" cmpd="sng" algn="ctr">
-                      <a:solidFill>
-                        <a:srgbClr val="A6A6A6"/>
-                      </a:solidFill>
-                      <a:prstDash val="solid"/>
-                      <a:round/>
-                      <a:headEnd type="none" w="med" len="med"/>
-                      <a:tailEnd type="none" w="med" len="med"/>
-                    </a:lnR>
-                    <a:lnT w="6350" cap="flat" cmpd="sng" algn="ctr">
-                      <a:solidFill>
-                        <a:srgbClr val="A6A6A6"/>
-                      </a:solidFill>
-                      <a:prstDash val="solid"/>
-                      <a:round/>
-                      <a:headEnd type="none" w="med" len="med"/>
-                      <a:tailEnd type="none" w="med" len="med"/>
-                    </a:lnT>
-                    <a:lnB w="6350" cap="flat" cmpd="sng" algn="ctr">
-                      <a:solidFill>
-                        <a:srgbClr val="A6A6A6"/>
-                      </a:solidFill>
-                      <a:prstDash val="solid"/>
-                      <a:round/>
-                      <a:headEnd type="none" w="med" len="med"/>
-                      <a:tailEnd type="none" w="med" len="med"/>
-                    </a:lnB>
-                    <a:solidFill>
-                      <a:srgbClr val="FFFFFF"/>
-                    </a:solidFill>
-                  </a:tcPr>
-                </a:tc>
-                <a:tc>
-                  <a:txBody>
-                    <a:bodyPr/>
-                    <a:lstStyle/>
-                    <a:p>
-                      <a:pPr algn="ctr" indent="0" marL="0">
-                        <a:buNone/>
-                      </a:pPr>
-                      <a:r>
-                        <a:rPr lang="en-US" sz="1000" dirty="0">
-                          <a:solidFill>
-                            <a:srgbClr val="000000"/>
-                          </a:solidFill>
-                          <a:latin typeface="Calibri" pitchFamily="34" charset="0"/>
-                          <a:ea typeface="Calibri" pitchFamily="34" charset="-122"/>
-                          <a:cs typeface="Calibri" pitchFamily="34" charset="-120"/>
-                        </a:rPr>
-                        <a:t>125.1</a:t>
-                      </a:r>
-                      <a:endParaRPr lang="en-US" sz="1000" dirty="0">
-                        <a:latin typeface="Calibri" charset="0"/>
-                        <a:ea typeface="Calibri" charset="0"/>
-                        <a:cs typeface="Calibri" charset="0"/>
-                      </a:endParaRPr>
-                    </a:p>
-                  </a:txBody>
-                  <a:tcPr marL="91440" marR="91440" marT="45720" marB="45720" anchor="ctr">
-                    <a:lnL w="6350" cap="flat" cmpd="sng" algn="ctr">
-                      <a:solidFill>
-                        <a:srgbClr val="A6A6A6"/>
-                      </a:solidFill>
-                      <a:prstDash val="solid"/>
-                      <a:round/>
-                      <a:headEnd type="none" w="med" len="med"/>
-                      <a:tailEnd type="none" w="med" len="med"/>
-                    </a:lnL>
-                    <a:lnR w="6350" cap="flat" cmpd="sng" algn="ctr">
-                      <a:solidFill>
-                        <a:srgbClr val="A6A6A6"/>
-                      </a:solidFill>
-                      <a:prstDash val="solid"/>
-                      <a:round/>
-                      <a:headEnd type="none" w="med" len="med"/>
-                      <a:tailEnd type="none" w="med" len="med"/>
-                    </a:lnR>
-                    <a:lnT w="6350" cap="flat" cmpd="sng" algn="ctr">
-                      <a:solidFill>
-                        <a:srgbClr val="A6A6A6"/>
-                      </a:solidFill>
-                      <a:prstDash val="solid"/>
-                      <a:round/>
-                      <a:headEnd type="none" w="med" len="med"/>
-                      <a:tailEnd type="none" w="med" len="med"/>
-                    </a:lnT>
-                    <a:lnB w="6350" cap="flat" cmpd="sng" algn="ctr">
-                      <a:solidFill>
-                        <a:srgbClr val="A6A6A6"/>
-                      </a:solidFill>
-                      <a:prstDash val="solid"/>
-                      <a:round/>
-                      <a:headEnd type="none" w="med" len="med"/>
-                      <a:tailEnd type="none" w="med" len="med"/>
-                    </a:lnB>
-                    <a:solidFill>
-                      <a:srgbClr val="FFFFFF"/>
-                    </a:solidFill>
-                  </a:tcPr>
-                </a:tc>
-                <a:tc>
-                  <a:txBody>
-                    <a:bodyPr/>
-                    <a:lstStyle/>
-                    <a:p>
-                      <a:pPr algn="ctr" indent="0" marL="0">
-                        <a:buNone/>
-                      </a:pPr>
-                      <a:r>
-                        <a:rPr lang="en-US" sz="1000" dirty="0">
-                          <a:solidFill>
-                            <a:srgbClr val="000000"/>
-                          </a:solidFill>
-                          <a:latin typeface="Calibri" pitchFamily="34" charset="0"/>
-                          <a:ea typeface="Calibri" pitchFamily="34" charset="-122"/>
-                          <a:cs typeface="Calibri" pitchFamily="34" charset="-120"/>
-                        </a:rPr>
-                        <a:t>1.00</a:t>
-                      </a:r>
-                      <a:endParaRPr lang="en-US" sz="1000" dirty="0">
-                        <a:latin typeface="Calibri" charset="0"/>
-                        <a:ea typeface="Calibri" charset="0"/>
-                        <a:cs typeface="Calibri" charset="0"/>
-                      </a:endParaRPr>
-                    </a:p>
-                  </a:txBody>
-                  <a:tcPr marL="91440" marR="91440" marT="45720" marB="45720" anchor="ctr">
-                    <a:lnL w="6350" cap="flat" cmpd="sng" algn="ctr">
-                      <a:solidFill>
-                        <a:srgbClr val="A6A6A6"/>
-                      </a:solidFill>
-                      <a:prstDash val="solid"/>
-                      <a:round/>
-                      <a:headEnd type="none" w="med" len="med"/>
-                      <a:tailEnd type="none" w="med" len="med"/>
-                    </a:lnL>
-                    <a:lnR w="6350" cap="flat" cmpd="sng" algn="ctr">
-                      <a:solidFill>
-                        <a:srgbClr val="A6A6A6"/>
-                      </a:solidFill>
-                      <a:prstDash val="solid"/>
-                      <a:round/>
-                      <a:headEnd type="none" w="med" len="med"/>
-                      <a:tailEnd type="none" w="med" len="med"/>
-                    </a:lnR>
-                    <a:lnT w="6350" cap="flat" cmpd="sng" algn="ctr">
-                      <a:solidFill>
-                        <a:srgbClr val="A6A6A6"/>
-                      </a:solidFill>
-                      <a:prstDash val="solid"/>
-                      <a:round/>
-                      <a:headEnd type="none" w="med" len="med"/>
-                      <a:tailEnd type="none" w="med" len="med"/>
-                    </a:lnT>
-                    <a:lnB w="6350" cap="flat" cmpd="sng" algn="ctr">
-                      <a:solidFill>
-                        <a:srgbClr val="A6A6A6"/>
-                      </a:solidFill>
-                      <a:prstDash val="solid"/>
-                      <a:round/>
-                      <a:headEnd type="none" w="med" len="med"/>
-                      <a:tailEnd type="none" w="med" len="med"/>
-                    </a:lnB>
-                    <a:solidFill>
-                      <a:srgbClr val="FFFFFF"/>
-                    </a:solidFill>
-                  </a:tcPr>
-                </a:tc>
-              </a:tr>
-              <a:tr h="347472">
-                <a:tc>
-                  <a:txBody>
-                    <a:bodyPr/>
-                    <a:lstStyle/>
-                    <a:p>
-                      <a:pPr algn="l" indent="0" marL="0">
-                        <a:buNone/>
-                      </a:pPr>
-                      <a:r>
-                        <a:rPr lang="en-US" sz="1000" dirty="0">
-                          <a:solidFill>
-                            <a:srgbClr val="000000"/>
-                          </a:solidFill>
-                          <a:latin typeface="Calibri" pitchFamily="34" charset="0"/>
-                          <a:ea typeface="Calibri" pitchFamily="34" charset="-122"/>
-                          <a:cs typeface="Calibri" pitchFamily="34" charset="-120"/>
-                        </a:rPr>
-                        <a:t>uwtig_no_staleness</a:t>
-                      </a:r>
-                      <a:endParaRPr lang="en-US" sz="1000" dirty="0">
-                        <a:latin typeface="Calibri" charset="0"/>
-                        <a:ea typeface="Calibri" charset="0"/>
-                        <a:cs typeface="Calibri" charset="0"/>
-                      </a:endParaRPr>
-                    </a:p>
-                  </a:txBody>
-                  <a:tcPr marL="91440" marR="91440" marT="45720" marB="45720" anchor="ctr">
-                    <a:lnL w="6350" cap="flat" cmpd="sng" algn="ctr">
-                      <a:solidFill>
-                        <a:srgbClr val="A6A6A6"/>
-                      </a:solidFill>
-                      <a:prstDash val="solid"/>
-                      <a:round/>
-                      <a:headEnd type="none" w="med" len="med"/>
-                      <a:tailEnd type="none" w="med" len="med"/>
-                    </a:lnL>
-                    <a:lnR w="6350" cap="flat" cmpd="sng" algn="ctr">
-                      <a:solidFill>
-                        <a:srgbClr val="A6A6A6"/>
-                      </a:solidFill>
-                      <a:prstDash val="solid"/>
-                      <a:round/>
-                      <a:headEnd type="none" w="med" len="med"/>
-                      <a:tailEnd type="none" w="med" len="med"/>
-                    </a:lnR>
-                    <a:lnT w="6350" cap="flat" cmpd="sng" algn="ctr">
-                      <a:solidFill>
-                        <a:srgbClr val="A6A6A6"/>
-                      </a:solidFill>
-                      <a:prstDash val="solid"/>
-                      <a:round/>
-                      <a:headEnd type="none" w="med" len="med"/>
-                      <a:tailEnd type="none" w="med" len="med"/>
-                    </a:lnT>
-                    <a:lnB w="6350" cap="flat" cmpd="sng" algn="ctr">
-                      <a:solidFill>
-                        <a:srgbClr val="A6A6A6"/>
-                      </a:solidFill>
-                      <a:prstDash val="solid"/>
-                      <a:round/>
-                      <a:headEnd type="none" w="med" len="med"/>
-                      <a:tailEnd type="none" w="med" len="med"/>
-                    </a:lnB>
-                    <a:solidFill>
-                      <a:srgbClr val="F2F2F2"/>
-                    </a:solidFill>
-                  </a:tcPr>
-                </a:tc>
-                <a:tc>
-                  <a:txBody>
-                    <a:bodyPr/>
-                    <a:lstStyle/>
-                    <a:p>
-                      <a:pPr algn="ctr" indent="0" marL="0">
-                        <a:buNone/>
-                      </a:pPr>
-                      <a:r>
-                        <a:rPr lang="en-US" sz="1000" dirty="0">
-                          <a:solidFill>
-                            <a:srgbClr val="000000"/>
-                          </a:solidFill>
-                          <a:latin typeface="Calibri" pitchFamily="34" charset="0"/>
-                          <a:ea typeface="Calibri" pitchFamily="34" charset="-122"/>
-                          <a:cs typeface="Calibri" pitchFamily="34" charset="-120"/>
-                        </a:rPr>
-                        <a:t>0.967</a:t>
-                      </a:r>
-                      <a:endParaRPr lang="en-US" sz="1000" dirty="0">
-                        <a:latin typeface="Calibri" charset="0"/>
-                        <a:ea typeface="Calibri" charset="0"/>
-                        <a:cs typeface="Calibri" charset="0"/>
-                      </a:endParaRPr>
-                    </a:p>
-                  </a:txBody>
-                  <a:tcPr marL="91440" marR="91440" marT="45720" marB="45720" anchor="ctr">
-                    <a:lnL w="6350" cap="flat" cmpd="sng" algn="ctr">
-                      <a:solidFill>
-                        <a:srgbClr val="A6A6A6"/>
-                      </a:solidFill>
-                      <a:prstDash val="solid"/>
-                      <a:round/>
-                      <a:headEnd type="none" w="med" len="med"/>
-                      <a:tailEnd type="none" w="med" len="med"/>
-                    </a:lnL>
-                    <a:lnR w="6350" cap="flat" cmpd="sng" algn="ctr">
-                      <a:solidFill>
-                        <a:srgbClr val="A6A6A6"/>
-                      </a:solidFill>
-                      <a:prstDash val="solid"/>
-                      <a:round/>
-                      <a:headEnd type="none" w="med" len="med"/>
-                      <a:tailEnd type="none" w="med" len="med"/>
-                    </a:lnR>
-                    <a:lnT w="6350" cap="flat" cmpd="sng" algn="ctr">
-                      <a:solidFill>
-                        <a:srgbClr val="A6A6A6"/>
-                      </a:solidFill>
-                      <a:prstDash val="solid"/>
-                      <a:round/>
-                      <a:headEnd type="none" w="med" len="med"/>
-                      <a:tailEnd type="none" w="med" len="med"/>
-                    </a:lnT>
-                    <a:lnB w="6350" cap="flat" cmpd="sng" algn="ctr">
-                      <a:solidFill>
-                        <a:srgbClr val="A6A6A6"/>
-                      </a:solidFill>
-                      <a:prstDash val="solid"/>
-                      <a:round/>
-                      <a:headEnd type="none" w="med" len="med"/>
-                      <a:tailEnd type="none" w="med" len="med"/>
-                    </a:lnB>
-                    <a:solidFill>
-                      <a:srgbClr val="F2F2F2"/>
-                    </a:solidFill>
-                  </a:tcPr>
-                </a:tc>
-                <a:tc>
-                  <a:txBody>
-                    <a:bodyPr/>
-                    <a:lstStyle/>
-                    <a:p>
-                      <a:pPr algn="ctr" indent="0" marL="0">
-                        <a:buNone/>
-                      </a:pPr>
-                      <a:r>
-                        <a:rPr lang="en-US" sz="1000" dirty="0">
-                          <a:solidFill>
-                            <a:srgbClr val="000000"/>
-                          </a:solidFill>
-                          <a:latin typeface="Calibri" pitchFamily="34" charset="0"/>
-                          <a:ea typeface="Calibri" pitchFamily="34" charset="-122"/>
-                          <a:cs typeface="Calibri" pitchFamily="34" charset="-120"/>
-                        </a:rPr>
-                        <a:t>0.956</a:t>
-                      </a:r>
-                      <a:endParaRPr lang="en-US" sz="1000" dirty="0">
-                        <a:latin typeface="Calibri" charset="0"/>
-                        <a:ea typeface="Calibri" charset="0"/>
-                        <a:cs typeface="Calibri" charset="0"/>
-                      </a:endParaRPr>
-                    </a:p>
-                  </a:txBody>
-                  <a:tcPr marL="91440" marR="91440" marT="45720" marB="45720" anchor="ctr">
-                    <a:lnL w="6350" cap="flat" cmpd="sng" algn="ctr">
-                      <a:solidFill>
-                        <a:srgbClr val="A6A6A6"/>
-                      </a:solidFill>
-                      <a:prstDash val="solid"/>
-                      <a:round/>
-                      <a:headEnd type="none" w="med" len="med"/>
-                      <a:tailEnd type="none" w="med" len="med"/>
-                    </a:lnL>
-                    <a:lnR w="6350" cap="flat" cmpd="sng" algn="ctr">
-                      <a:solidFill>
-                        <a:srgbClr val="A6A6A6"/>
-                      </a:solidFill>
-                      <a:prstDash val="solid"/>
-                      <a:round/>
-                      <a:headEnd type="none" w="med" len="med"/>
-                      <a:tailEnd type="none" w="med" len="med"/>
-                    </a:lnR>
-                    <a:lnT w="6350" cap="flat" cmpd="sng" algn="ctr">
-                      <a:solidFill>
-                        <a:srgbClr val="A6A6A6"/>
-                      </a:solidFill>
-                      <a:prstDash val="solid"/>
-                      <a:round/>
-                      <a:headEnd type="none" w="med" len="med"/>
-                      <a:tailEnd type="none" w="med" len="med"/>
-                    </a:lnT>
-                    <a:lnB w="6350" cap="flat" cmpd="sng" algn="ctr">
-                      <a:solidFill>
-                        <a:srgbClr val="A6A6A6"/>
-                      </a:solidFill>
-                      <a:prstDash val="solid"/>
-                      <a:round/>
-                      <a:headEnd type="none" w="med" len="med"/>
-                      <a:tailEnd type="none" w="med" len="med"/>
-                    </a:lnB>
-                    <a:solidFill>
-                      <a:srgbClr val="F2F2F2"/>
-                    </a:solidFill>
-                  </a:tcPr>
-                </a:tc>
-                <a:tc>
-                  <a:txBody>
-                    <a:bodyPr/>
-                    <a:lstStyle/>
-                    <a:p>
-                      <a:pPr algn="ctr" indent="0" marL="0">
-                        <a:buNone/>
-                      </a:pPr>
-                      <a:r>
-                        <a:rPr lang="en-US" sz="1000" dirty="0">
-                          <a:solidFill>
-                            <a:srgbClr val="000000"/>
-                          </a:solidFill>
-                          <a:latin typeface="Calibri" pitchFamily="34" charset="0"/>
-                          <a:ea typeface="Calibri" pitchFamily="34" charset="-122"/>
-                          <a:cs typeface="Calibri" pitchFamily="34" charset="-120"/>
-                        </a:rPr>
-                        <a:t>0.958</a:t>
-                      </a:r>
-                      <a:endParaRPr lang="en-US" sz="1000" dirty="0">
-                        <a:latin typeface="Calibri" charset="0"/>
-                        <a:ea typeface="Calibri" charset="0"/>
-                        <a:cs typeface="Calibri" charset="0"/>
-                      </a:endParaRPr>
-                    </a:p>
-                  </a:txBody>
-                  <a:tcPr marL="91440" marR="91440" marT="45720" marB="45720" anchor="ctr">
-                    <a:lnL w="6350" cap="flat" cmpd="sng" algn="ctr">
-                      <a:solidFill>
-                        <a:srgbClr val="A6A6A6"/>
-                      </a:solidFill>
-                      <a:prstDash val="solid"/>
-                      <a:round/>
-                      <a:headEnd type="none" w="med" len="med"/>
-                      <a:tailEnd type="none" w="med" len="med"/>
-                    </a:lnL>
-                    <a:lnR w="6350" cap="flat" cmpd="sng" algn="ctr">
-                      <a:solidFill>
-                        <a:srgbClr val="A6A6A6"/>
-                      </a:solidFill>
-                      <a:prstDash val="solid"/>
-                      <a:round/>
-                      <a:headEnd type="none" w="med" len="med"/>
-                      <a:tailEnd type="none" w="med" len="med"/>
-                    </a:lnR>
-                    <a:lnT w="6350" cap="flat" cmpd="sng" algn="ctr">
-                      <a:solidFill>
-                        <a:srgbClr val="A6A6A6"/>
-                      </a:solidFill>
-                      <a:prstDash val="solid"/>
-                      <a:round/>
-                      <a:headEnd type="none" w="med" len="med"/>
-                      <a:tailEnd type="none" w="med" len="med"/>
-                    </a:lnT>
-                    <a:lnB w="6350" cap="flat" cmpd="sng" algn="ctr">
-                      <a:solidFill>
-                        <a:srgbClr val="A6A6A6"/>
-                      </a:solidFill>
-                      <a:prstDash val="solid"/>
-                      <a:round/>
-                      <a:headEnd type="none" w="med" len="med"/>
-                      <a:tailEnd type="none" w="med" len="med"/>
-                    </a:lnB>
-                    <a:solidFill>
-                      <a:srgbClr val="F2F2F2"/>
-                    </a:solidFill>
-                  </a:tcPr>
-                </a:tc>
-                <a:tc>
-                  <a:txBody>
-                    <a:bodyPr/>
-                    <a:lstStyle/>
-                    <a:p>
-                      <a:pPr algn="ctr" indent="0" marL="0">
-                        <a:buNone/>
-                      </a:pPr>
-                      <a:r>
-                        <a:rPr lang="en-US" sz="1000" dirty="0">
-                          <a:solidFill>
-                            <a:srgbClr val="000000"/>
-                          </a:solidFill>
-                          <a:latin typeface="Calibri" pitchFamily="34" charset="0"/>
-                          <a:ea typeface="Calibri" pitchFamily="34" charset="-122"/>
-                          <a:cs typeface="Calibri" pitchFamily="34" charset="-120"/>
-                        </a:rPr>
-                        <a:t>0.57</a:t>
-                      </a:r>
-                      <a:endParaRPr lang="en-US" sz="1000" dirty="0">
-                        <a:latin typeface="Calibri" charset="0"/>
-                        <a:ea typeface="Calibri" charset="0"/>
-                        <a:cs typeface="Calibri" charset="0"/>
-                      </a:endParaRPr>
-                    </a:p>
-                  </a:txBody>
-                  <a:tcPr marL="91440" marR="91440" marT="45720" marB="45720" anchor="ctr">
-                    <a:lnL w="6350" cap="flat" cmpd="sng" algn="ctr">
-                      <a:solidFill>
-                        <a:srgbClr val="A6A6A6"/>
-                      </a:solidFill>
-                      <a:prstDash val="solid"/>
-                      <a:round/>
-                      <a:headEnd type="none" w="med" len="med"/>
-                      <a:tailEnd type="none" w="med" len="med"/>
-                    </a:lnL>
-                    <a:lnR w="6350" cap="flat" cmpd="sng" algn="ctr">
-                      <a:solidFill>
-                        <a:srgbClr val="A6A6A6"/>
-                      </a:solidFill>
-                      <a:prstDash val="solid"/>
-                      <a:round/>
-                      <a:headEnd type="none" w="med" len="med"/>
-                      <a:tailEnd type="none" w="med" len="med"/>
-                    </a:lnR>
-                    <a:lnT w="6350" cap="flat" cmpd="sng" algn="ctr">
-                      <a:solidFill>
-                        <a:srgbClr val="A6A6A6"/>
-                      </a:solidFill>
-                      <a:prstDash val="solid"/>
-                      <a:round/>
-                      <a:headEnd type="none" w="med" len="med"/>
-                      <a:tailEnd type="none" w="med" len="med"/>
-                    </a:lnT>
-                    <a:lnB w="6350" cap="flat" cmpd="sng" algn="ctr">
-                      <a:solidFill>
-                        <a:srgbClr val="A6A6A6"/>
-                      </a:solidFill>
-                      <a:prstDash val="solid"/>
-                      <a:round/>
-                      <a:headEnd type="none" w="med" len="med"/>
-                      <a:tailEnd type="none" w="med" len="med"/>
-                    </a:lnB>
-                    <a:solidFill>
-                      <a:srgbClr val="F2F2F2"/>
-                    </a:solidFill>
-                  </a:tcPr>
-                </a:tc>
-                <a:tc>
-                  <a:txBody>
-                    <a:bodyPr/>
-                    <a:lstStyle/>
-                    <a:p>
-                      <a:pPr algn="ctr" indent="0" marL="0">
-                        <a:buNone/>
-                      </a:pPr>
-                      <a:r>
-                        <a:rPr lang="en-US" sz="1000" dirty="0">
-                          <a:solidFill>
-                            <a:srgbClr val="000000"/>
-                          </a:solidFill>
-                          <a:latin typeface="Calibri" pitchFamily="34" charset="0"/>
-                          <a:ea typeface="Calibri" pitchFamily="34" charset="-122"/>
-                          <a:cs typeface="Calibri" pitchFamily="34" charset="-120"/>
-                        </a:rPr>
-                        <a:t>80.6</a:t>
-                      </a:r>
-                      <a:endParaRPr lang="en-US" sz="1000" dirty="0">
-                        <a:latin typeface="Calibri" charset="0"/>
-                        <a:ea typeface="Calibri" charset="0"/>
-                        <a:cs typeface="Calibri" charset="0"/>
-                      </a:endParaRPr>
-                    </a:p>
-                  </a:txBody>
-                  <a:tcPr marL="91440" marR="91440" marT="45720" marB="45720" anchor="ctr">
-                    <a:lnL w="6350" cap="flat" cmpd="sng" algn="ctr">
-                      <a:solidFill>
-                        <a:srgbClr val="A6A6A6"/>
-                      </a:solidFill>
-                      <a:prstDash val="solid"/>
-                      <a:round/>
-                      <a:headEnd type="none" w="med" len="med"/>
-                      <a:tailEnd type="none" w="med" len="med"/>
-                    </a:lnL>
-                    <a:lnR w="6350" cap="flat" cmpd="sng" algn="ctr">
-                      <a:solidFill>
-                        <a:srgbClr val="A6A6A6"/>
-                      </a:solidFill>
-                      <a:prstDash val="solid"/>
-                      <a:round/>
-                      <a:headEnd type="none" w="med" len="med"/>
-                      <a:tailEnd type="none" w="med" len="med"/>
-                    </a:lnR>
-                    <a:lnT w="6350" cap="flat" cmpd="sng" algn="ctr">
-                      <a:solidFill>
-                        <a:srgbClr val="A6A6A6"/>
-                      </a:solidFill>
-                      <a:prstDash val="solid"/>
-                      <a:round/>
-                      <a:headEnd type="none" w="med" len="med"/>
-                      <a:tailEnd type="none" w="med" len="med"/>
-                    </a:lnT>
-                    <a:lnB w="6350" cap="flat" cmpd="sng" algn="ctr">
-                      <a:solidFill>
-                        <a:srgbClr val="A6A6A6"/>
-                      </a:solidFill>
-                      <a:prstDash val="solid"/>
-                      <a:round/>
-                      <a:headEnd type="none" w="med" len="med"/>
-                      <a:tailEnd type="none" w="med" len="med"/>
-                    </a:lnB>
-                    <a:solidFill>
-                      <a:srgbClr val="F2F2F2"/>
-                    </a:solidFill>
-                  </a:tcPr>
-                </a:tc>
-                <a:tc>
-                  <a:txBody>
-                    <a:bodyPr/>
-                    <a:lstStyle/>
-                    <a:p>
-                      <a:pPr algn="ctr" indent="0" marL="0">
-                        <a:buNone/>
-                      </a:pPr>
-                      <a:r>
-                        <a:rPr lang="en-US" sz="1000" dirty="0">
-                          <a:solidFill>
-                            <a:srgbClr val="000000"/>
-                          </a:solidFill>
-                          <a:latin typeface="Calibri" pitchFamily="34" charset="0"/>
-                          <a:ea typeface="Calibri" pitchFamily="34" charset="-122"/>
-                          <a:cs typeface="Calibri" pitchFamily="34" charset="-120"/>
-                        </a:rPr>
-                        <a:t>1.00</a:t>
-                      </a:r>
-                      <a:endParaRPr lang="en-US" sz="1000" dirty="0">
-                        <a:latin typeface="Calibri" charset="0"/>
-                        <a:ea typeface="Calibri" charset="0"/>
-                        <a:cs typeface="Calibri" charset="0"/>
-                      </a:endParaRPr>
-                    </a:p>
-                  </a:txBody>
-                  <a:tcPr marL="91440" marR="91440" marT="45720" marB="45720" anchor="ctr">
-                    <a:lnL w="6350" cap="flat" cmpd="sng" algn="ctr">
-                      <a:solidFill>
-                        <a:srgbClr val="A6A6A6"/>
-                      </a:solidFill>
-                      <a:prstDash val="solid"/>
-                      <a:round/>
-                      <a:headEnd type="none" w="med" len="med"/>
-                      <a:tailEnd type="none" w="med" len="med"/>
-                    </a:lnL>
-                    <a:lnR w="6350" cap="flat" cmpd="sng" algn="ctr">
-                      <a:solidFill>
-                        <a:srgbClr val="A6A6A6"/>
-                      </a:solidFill>
-                      <a:prstDash val="solid"/>
-                      <a:round/>
-                      <a:headEnd type="none" w="med" len="med"/>
-                      <a:tailEnd type="none" w="med" len="med"/>
-                    </a:lnR>
-                    <a:lnT w="6350" cap="flat" cmpd="sng" algn="ctr">
-                      <a:solidFill>
-                        <a:srgbClr val="A6A6A6"/>
-                      </a:solidFill>
-                      <a:prstDash val="solid"/>
-                      <a:round/>
-                      <a:headEnd type="none" w="med" len="med"/>
-                      <a:tailEnd type="none" w="med" len="med"/>
-                    </a:lnT>
-                    <a:lnB w="6350" cap="flat" cmpd="sng" algn="ctr">
-                      <a:solidFill>
-                        <a:srgbClr val="A6A6A6"/>
-                      </a:solidFill>
-                      <a:prstDash val="solid"/>
-                      <a:round/>
-                      <a:headEnd type="none" w="med" len="med"/>
-                      <a:tailEnd type="none" w="med" len="med"/>
-                    </a:lnB>
-                    <a:solidFill>
-                      <a:srgbClr val="F2F2F2"/>
-                    </a:solidFill>
-                  </a:tcPr>
-                </a:tc>
-              </a:tr>
-              <a:tr h="347472">
-                <a:tc>
-                  <a:txBody>
-                    <a:bodyPr/>
-                    <a:lstStyle/>
-                    <a:p>
-                      <a:pPr algn="l" indent="0" marL="0">
-                        <a:buNone/>
-                      </a:pPr>
-                      <a:r>
-                        <a:rPr lang="en-US" sz="1000" dirty="0">
-                          <a:solidFill>
-                            <a:srgbClr val="000000"/>
-                          </a:solidFill>
-                          <a:latin typeface="Calibri" pitchFamily="34" charset="0"/>
-                          <a:ea typeface="Calibri" pitchFamily="34" charset="-122"/>
-                          <a:cs typeface="Calibri" pitchFamily="34" charset="-120"/>
-                        </a:rPr>
-                        <a:t>uwtig_no_coverage_first</a:t>
-                      </a:r>
-                      <a:endParaRPr lang="en-US" sz="1000" dirty="0">
-                        <a:latin typeface="Calibri" charset="0"/>
-                        <a:ea typeface="Calibri" charset="0"/>
-                        <a:cs typeface="Calibri" charset="0"/>
-                      </a:endParaRPr>
-                    </a:p>
-                  </a:txBody>
-                  <a:tcPr marL="91440" marR="91440" marT="45720" marB="45720" anchor="ctr">
-                    <a:lnL w="6350" cap="flat" cmpd="sng" algn="ctr">
-                      <a:solidFill>
-                        <a:srgbClr val="A6A6A6"/>
-                      </a:solidFill>
-                      <a:prstDash val="solid"/>
-                      <a:round/>
-                      <a:headEnd type="none" w="med" len="med"/>
-                      <a:tailEnd type="none" w="med" len="med"/>
-                    </a:lnL>
-                    <a:lnR w="6350" cap="flat" cmpd="sng" algn="ctr">
-                      <a:solidFill>
-                        <a:srgbClr val="A6A6A6"/>
-                      </a:solidFill>
-                      <a:prstDash val="solid"/>
-                      <a:round/>
-                      <a:headEnd type="none" w="med" len="med"/>
-                      <a:tailEnd type="none" w="med" len="med"/>
-                    </a:lnR>
-                    <a:lnT w="6350" cap="flat" cmpd="sng" algn="ctr">
-                      <a:solidFill>
-                        <a:srgbClr val="A6A6A6"/>
-                      </a:solidFill>
-                      <a:prstDash val="solid"/>
-                      <a:round/>
-                      <a:headEnd type="none" w="med" len="med"/>
-                      <a:tailEnd type="none" w="med" len="med"/>
-                    </a:lnT>
-                    <a:lnB w="6350" cap="flat" cmpd="sng" algn="ctr">
-                      <a:solidFill>
-                        <a:srgbClr val="A6A6A6"/>
-                      </a:solidFill>
-                      <a:prstDash val="solid"/>
-                      <a:round/>
-                      <a:headEnd type="none" w="med" len="med"/>
-                      <a:tailEnd type="none" w="med" len="med"/>
-                    </a:lnB>
-                    <a:solidFill>
-                      <a:srgbClr val="FFFFFF"/>
-                    </a:solidFill>
-                  </a:tcPr>
-                </a:tc>
-                <a:tc>
-                  <a:txBody>
-                    <a:bodyPr/>
-                    <a:lstStyle/>
-                    <a:p>
-                      <a:pPr algn="ctr" indent="0" marL="0">
-                        <a:buNone/>
-                      </a:pPr>
-                      <a:r>
-                        <a:rPr lang="en-US" sz="1000" dirty="0">
-                          <a:solidFill>
-                            <a:srgbClr val="000000"/>
-                          </a:solidFill>
-                          <a:latin typeface="Calibri" pitchFamily="34" charset="0"/>
-                          <a:ea typeface="Calibri" pitchFamily="34" charset="-122"/>
-                          <a:cs typeface="Calibri" pitchFamily="34" charset="-120"/>
-                        </a:rPr>
-                        <a:t>0.911</a:t>
-                      </a:r>
-                      <a:endParaRPr lang="en-US" sz="1000" dirty="0">
-                        <a:latin typeface="Calibri" charset="0"/>
-                        <a:ea typeface="Calibri" charset="0"/>
-                        <a:cs typeface="Calibri" charset="0"/>
-                      </a:endParaRPr>
-                    </a:p>
-                  </a:txBody>
-                  <a:tcPr marL="91440" marR="91440" marT="45720" marB="45720" anchor="ctr">
-                    <a:lnL w="6350" cap="flat" cmpd="sng" algn="ctr">
-                      <a:solidFill>
-                        <a:srgbClr val="A6A6A6"/>
-                      </a:solidFill>
-                      <a:prstDash val="solid"/>
-                      <a:round/>
-                      <a:headEnd type="none" w="med" len="med"/>
-                      <a:tailEnd type="none" w="med" len="med"/>
-                    </a:lnL>
-                    <a:lnR w="6350" cap="flat" cmpd="sng" algn="ctr">
-                      <a:solidFill>
-                        <a:srgbClr val="A6A6A6"/>
-                      </a:solidFill>
-                      <a:prstDash val="solid"/>
-                      <a:round/>
-                      <a:headEnd type="none" w="med" len="med"/>
-                      <a:tailEnd type="none" w="med" len="med"/>
-                    </a:lnR>
-                    <a:lnT w="6350" cap="flat" cmpd="sng" algn="ctr">
-                      <a:solidFill>
-                        <a:srgbClr val="A6A6A6"/>
-                      </a:solidFill>
-                      <a:prstDash val="solid"/>
-                      <a:round/>
-                      <a:headEnd type="none" w="med" len="med"/>
-                      <a:tailEnd type="none" w="med" len="med"/>
-                    </a:lnT>
-                    <a:lnB w="6350" cap="flat" cmpd="sng" algn="ctr">
-                      <a:solidFill>
-                        <a:srgbClr val="A6A6A6"/>
-                      </a:solidFill>
-                      <a:prstDash val="solid"/>
-                      <a:round/>
-                      <a:headEnd type="none" w="med" len="med"/>
-                      <a:tailEnd type="none" w="med" len="med"/>
-                    </a:lnB>
-                    <a:solidFill>
-                      <a:srgbClr val="FFFFFF"/>
-                    </a:solidFill>
-                  </a:tcPr>
-                </a:tc>
-                <a:tc>
-                  <a:txBody>
-                    <a:bodyPr/>
-                    <a:lstStyle/>
-                    <a:p>
-                      <a:pPr algn="ctr" indent="0" marL="0">
-                        <a:buNone/>
-                      </a:pPr>
-                      <a:r>
-                        <a:rPr lang="en-US" sz="1000" dirty="0">
-                          <a:solidFill>
-                            <a:srgbClr val="000000"/>
-                          </a:solidFill>
-                          <a:latin typeface="Calibri" pitchFamily="34" charset="0"/>
-                          <a:ea typeface="Calibri" pitchFamily="34" charset="-122"/>
-                          <a:cs typeface="Calibri" pitchFamily="34" charset="-120"/>
-                        </a:rPr>
-                        <a:t>0.556</a:t>
-                      </a:r>
-                      <a:endParaRPr lang="en-US" sz="1000" dirty="0">
-                        <a:latin typeface="Calibri" charset="0"/>
-                        <a:ea typeface="Calibri" charset="0"/>
-                        <a:cs typeface="Calibri" charset="0"/>
-                      </a:endParaRPr>
-                    </a:p>
-                  </a:txBody>
-                  <a:tcPr marL="91440" marR="91440" marT="45720" marB="45720" anchor="ctr">
-                    <a:lnL w="6350" cap="flat" cmpd="sng" algn="ctr">
-                      <a:solidFill>
-                        <a:srgbClr val="A6A6A6"/>
-                      </a:solidFill>
-                      <a:prstDash val="solid"/>
-                      <a:round/>
-                      <a:headEnd type="none" w="med" len="med"/>
-                      <a:tailEnd type="none" w="med" len="med"/>
-                    </a:lnL>
-                    <a:lnR w="6350" cap="flat" cmpd="sng" algn="ctr">
-                      <a:solidFill>
-                        <a:srgbClr val="A6A6A6"/>
-                      </a:solidFill>
-                      <a:prstDash val="solid"/>
-                      <a:round/>
-                      <a:headEnd type="none" w="med" len="med"/>
-                      <a:tailEnd type="none" w="med" len="med"/>
-                    </a:lnR>
-                    <a:lnT w="6350" cap="flat" cmpd="sng" algn="ctr">
-                      <a:solidFill>
-                        <a:srgbClr val="A6A6A6"/>
-                      </a:solidFill>
-                      <a:prstDash val="solid"/>
-                      <a:round/>
-                      <a:headEnd type="none" w="med" len="med"/>
-                      <a:tailEnd type="none" w="med" len="med"/>
-                    </a:lnT>
-                    <a:lnB w="6350" cap="flat" cmpd="sng" algn="ctr">
-                      <a:solidFill>
-                        <a:srgbClr val="A6A6A6"/>
-                      </a:solidFill>
-                      <a:prstDash val="solid"/>
-                      <a:round/>
-                      <a:headEnd type="none" w="med" len="med"/>
-                      <a:tailEnd type="none" w="med" len="med"/>
-                    </a:lnB>
-                    <a:solidFill>
-                      <a:srgbClr val="FFFFFF"/>
-                    </a:solidFill>
-                  </a:tcPr>
-                </a:tc>
-                <a:tc>
-                  <a:txBody>
-                    <a:bodyPr/>
-                    <a:lstStyle/>
-                    <a:p>
-                      <a:pPr algn="ctr" indent="0" marL="0">
-                        <a:buNone/>
-                      </a:pPr>
-                      <a:r>
-                        <a:rPr lang="en-US" sz="1000" dirty="0">
-                          <a:solidFill>
-                            <a:srgbClr val="000000"/>
-                          </a:solidFill>
-                          <a:latin typeface="Calibri" pitchFamily="34" charset="0"/>
-                          <a:ea typeface="Calibri" pitchFamily="34" charset="-122"/>
-                          <a:cs typeface="Calibri" pitchFamily="34" charset="-120"/>
-                        </a:rPr>
-                        <a:t>0.680</a:t>
-                      </a:r>
-                      <a:endParaRPr lang="en-US" sz="1000" dirty="0">
-                        <a:latin typeface="Calibri" charset="0"/>
-                        <a:ea typeface="Calibri" charset="0"/>
-                        <a:cs typeface="Calibri" charset="0"/>
-                      </a:endParaRPr>
-                    </a:p>
-                  </a:txBody>
-                  <a:tcPr marL="91440" marR="91440" marT="45720" marB="45720" anchor="ctr">
-                    <a:lnL w="6350" cap="flat" cmpd="sng" algn="ctr">
-                      <a:solidFill>
-                        <a:srgbClr val="A6A6A6"/>
-                      </a:solidFill>
-                      <a:prstDash val="solid"/>
-                      <a:round/>
-                      <a:headEnd type="none" w="med" len="med"/>
-                      <a:tailEnd type="none" w="med" len="med"/>
-                    </a:lnL>
-                    <a:lnR w="6350" cap="flat" cmpd="sng" algn="ctr">
-                      <a:solidFill>
-                        <a:srgbClr val="A6A6A6"/>
-                      </a:solidFill>
-                      <a:prstDash val="solid"/>
-                      <a:round/>
-                      <a:headEnd type="none" w="med" len="med"/>
-                      <a:tailEnd type="none" w="med" len="med"/>
-                    </a:lnR>
-                    <a:lnT w="6350" cap="flat" cmpd="sng" algn="ctr">
-                      <a:solidFill>
-                        <a:srgbClr val="A6A6A6"/>
-                      </a:solidFill>
-                      <a:prstDash val="solid"/>
-                      <a:round/>
-                      <a:headEnd type="none" w="med" len="med"/>
-                      <a:tailEnd type="none" w="med" len="med"/>
-                    </a:lnT>
-                    <a:lnB w="6350" cap="flat" cmpd="sng" algn="ctr">
-                      <a:solidFill>
-                        <a:srgbClr val="A6A6A6"/>
-                      </a:solidFill>
-                      <a:prstDash val="solid"/>
-                      <a:round/>
-                      <a:headEnd type="none" w="med" len="med"/>
-                      <a:tailEnd type="none" w="med" len="med"/>
-                    </a:lnB>
-                    <a:solidFill>
-                      <a:srgbClr val="FFFFFF"/>
-                    </a:solidFill>
-                  </a:tcPr>
-                </a:tc>
-                <a:tc>
-                  <a:txBody>
-                    <a:bodyPr/>
-                    <a:lstStyle/>
-                    <a:p>
-                      <a:pPr algn="ctr" indent="0" marL="0">
-                        <a:buNone/>
-                      </a:pPr>
-                      <a:r>
-                        <a:rPr lang="en-US" sz="1000" dirty="0">
-                          <a:solidFill>
-                            <a:srgbClr val="000000"/>
-                          </a:solidFill>
-                          <a:latin typeface="Calibri" pitchFamily="34" charset="0"/>
-                          <a:ea typeface="Calibri" pitchFamily="34" charset="-122"/>
-                          <a:cs typeface="Calibri" pitchFamily="34" charset="-120"/>
-                        </a:rPr>
-                        <a:t>0.81</a:t>
-                      </a:r>
-                      <a:endParaRPr lang="en-US" sz="1000" dirty="0">
-                        <a:latin typeface="Calibri" charset="0"/>
-                        <a:ea typeface="Calibri" charset="0"/>
-                        <a:cs typeface="Calibri" charset="0"/>
-                      </a:endParaRPr>
-                    </a:p>
-                  </a:txBody>
-                  <a:tcPr marL="91440" marR="91440" marT="45720" marB="45720" anchor="ctr">
-                    <a:lnL w="6350" cap="flat" cmpd="sng" algn="ctr">
-                      <a:solidFill>
-                        <a:srgbClr val="A6A6A6"/>
-                      </a:solidFill>
-                      <a:prstDash val="solid"/>
-                      <a:round/>
-                      <a:headEnd type="none" w="med" len="med"/>
-                      <a:tailEnd type="none" w="med" len="med"/>
-                    </a:lnL>
-                    <a:lnR w="6350" cap="flat" cmpd="sng" algn="ctr">
-                      <a:solidFill>
-                        <a:srgbClr val="A6A6A6"/>
-                      </a:solidFill>
-                      <a:prstDash val="solid"/>
-                      <a:round/>
-                      <a:headEnd type="none" w="med" len="med"/>
-                      <a:tailEnd type="none" w="med" len="med"/>
-                    </a:lnR>
-                    <a:lnT w="6350" cap="flat" cmpd="sng" algn="ctr">
-                      <a:solidFill>
-                        <a:srgbClr val="A6A6A6"/>
-                      </a:solidFill>
-                      <a:prstDash val="solid"/>
-                      <a:round/>
-                      <a:headEnd type="none" w="med" len="med"/>
-                      <a:tailEnd type="none" w="med" len="med"/>
-                    </a:lnT>
-                    <a:lnB w="6350" cap="flat" cmpd="sng" algn="ctr">
-                      <a:solidFill>
-                        <a:srgbClr val="A6A6A6"/>
-                      </a:solidFill>
-                      <a:prstDash val="solid"/>
-                      <a:round/>
-                      <a:headEnd type="none" w="med" len="med"/>
-                      <a:tailEnd type="none" w="med" len="med"/>
-                    </a:lnB>
-                    <a:solidFill>
-                      <a:srgbClr val="FFFFFF"/>
-                    </a:solidFill>
-                  </a:tcPr>
-                </a:tc>
-                <a:tc>
-                  <a:txBody>
-                    <a:bodyPr/>
-                    <a:lstStyle/>
-                    <a:p>
-                      <a:pPr algn="ctr" indent="0" marL="0">
-                        <a:buNone/>
-                      </a:pPr>
-                      <a:r>
-                        <a:rPr lang="en-US" sz="1000" dirty="0">
-                          <a:solidFill>
-                            <a:srgbClr val="000000"/>
-                          </a:solidFill>
-                          <a:latin typeface="Calibri" pitchFamily="34" charset="0"/>
-                          <a:ea typeface="Calibri" pitchFamily="34" charset="-122"/>
-                          <a:cs typeface="Calibri" pitchFamily="34" charset="-120"/>
-                        </a:rPr>
-                        <a:t>13.4</a:t>
-                      </a:r>
-                      <a:endParaRPr lang="en-US" sz="1000" dirty="0">
-                        <a:latin typeface="Calibri" charset="0"/>
-                        <a:ea typeface="Calibri" charset="0"/>
-                        <a:cs typeface="Calibri" charset="0"/>
-                      </a:endParaRPr>
-                    </a:p>
-                  </a:txBody>
-                  <a:tcPr marL="91440" marR="91440" marT="45720" marB="45720" anchor="ctr">
-                    <a:lnL w="6350" cap="flat" cmpd="sng" algn="ctr">
-                      <a:solidFill>
-                        <a:srgbClr val="A6A6A6"/>
-                      </a:solidFill>
-                      <a:prstDash val="solid"/>
-                      <a:round/>
-                      <a:headEnd type="none" w="med" len="med"/>
-                      <a:tailEnd type="none" w="med" len="med"/>
-                    </a:lnL>
-                    <a:lnR w="6350" cap="flat" cmpd="sng" algn="ctr">
-                      <a:solidFill>
-                        <a:srgbClr val="A6A6A6"/>
-                      </a:solidFill>
-                      <a:prstDash val="solid"/>
-                      <a:round/>
-                      <a:headEnd type="none" w="med" len="med"/>
-                      <a:tailEnd type="none" w="med" len="med"/>
-                    </a:lnR>
-                    <a:lnT w="6350" cap="flat" cmpd="sng" algn="ctr">
-                      <a:solidFill>
-                        <a:srgbClr val="A6A6A6"/>
-                      </a:solidFill>
-                      <a:prstDash val="solid"/>
-                      <a:round/>
-                      <a:headEnd type="none" w="med" len="med"/>
-                      <a:tailEnd type="none" w="med" len="med"/>
-                    </a:lnT>
-                    <a:lnB w="6350" cap="flat" cmpd="sng" algn="ctr">
-                      <a:solidFill>
-                        <a:srgbClr val="A6A6A6"/>
-                      </a:solidFill>
-                      <a:prstDash val="solid"/>
-                      <a:round/>
-                      <a:headEnd type="none" w="med" len="med"/>
-                      <a:tailEnd type="none" w="med" len="med"/>
-                    </a:lnB>
-                    <a:solidFill>
-                      <a:srgbClr val="FFFFFF"/>
-                    </a:solidFill>
-                  </a:tcPr>
-                </a:tc>
-                <a:tc>
-                  <a:txBody>
-                    <a:bodyPr/>
-                    <a:lstStyle/>
-                    <a:p>
-                      <a:pPr algn="ctr" indent="0" marL="0">
-                        <a:buNone/>
-                      </a:pPr>
-                      <a:r>
-                        <a:rPr lang="en-US" sz="1000" dirty="0">
-                          <a:solidFill>
-                            <a:srgbClr val="000000"/>
-                          </a:solidFill>
-                          <a:latin typeface="Calibri" pitchFamily="34" charset="0"/>
-                          <a:ea typeface="Calibri" pitchFamily="34" charset="-122"/>
-                          <a:cs typeface="Calibri" pitchFamily="34" charset="-120"/>
-                        </a:rPr>
-                        <a:t>0.44</a:t>
-                      </a:r>
-                      <a:endParaRPr lang="en-US" sz="1000" dirty="0">
-                        <a:latin typeface="Calibri" charset="0"/>
-                        <a:ea typeface="Calibri" charset="0"/>
-                        <a:cs typeface="Calibri" charset="0"/>
-                      </a:endParaRPr>
-                    </a:p>
-                  </a:txBody>
-                  <a:tcPr marL="91440" marR="91440" marT="45720" marB="45720" anchor="ctr">
-                    <a:lnL w="6350" cap="flat" cmpd="sng" algn="ctr">
-                      <a:solidFill>
-                        <a:srgbClr val="A6A6A6"/>
-                      </a:solidFill>
-                      <a:prstDash val="solid"/>
-                      <a:round/>
-                      <a:headEnd type="none" w="med" len="med"/>
-                      <a:tailEnd type="none" w="med" len="med"/>
-                    </a:lnL>
-                    <a:lnR w="6350" cap="flat" cmpd="sng" algn="ctr">
-                      <a:solidFill>
-                        <a:srgbClr val="A6A6A6"/>
-                      </a:solidFill>
-                      <a:prstDash val="solid"/>
-                      <a:round/>
-                      <a:headEnd type="none" w="med" len="med"/>
-                      <a:tailEnd type="none" w="med" len="med"/>
-                    </a:lnR>
-                    <a:lnT w="6350" cap="flat" cmpd="sng" algn="ctr">
-                      <a:solidFill>
-                        <a:srgbClr val="A6A6A6"/>
-                      </a:solidFill>
-                      <a:prstDash val="solid"/>
-                      <a:round/>
-                      <a:headEnd type="none" w="med" len="med"/>
-                      <a:tailEnd type="none" w="med" len="med"/>
-                    </a:lnT>
-                    <a:lnB w="6350" cap="flat" cmpd="sng" algn="ctr">
-                      <a:solidFill>
-                        <a:srgbClr val="A6A6A6"/>
-                      </a:solidFill>
-                      <a:prstDash val="solid"/>
-                      <a:round/>
-                      <a:headEnd type="none" w="med" len="med"/>
-                      <a:tailEnd type="none" w="med" len="med"/>
-                    </a:lnB>
-                    <a:solidFill>
-                      <a:srgbClr val="FFFFFF"/>
-                    </a:solidFill>
-                  </a:tcPr>
-                </a:tc>
-              </a:tr>
-              <a:tr h="347472">
-                <a:tc>
-                  <a:txBody>
-                    <a:bodyPr/>
-                    <a:lstStyle/>
-                    <a:p>
-                      <a:pPr algn="l" indent="0" marL="0">
-                        <a:buNone/>
-                      </a:pPr>
-                      <a:r>
-                        <a:rPr lang="en-US" sz="1000" dirty="0">
-                          <a:solidFill>
-                            <a:srgbClr val="000000"/>
-                          </a:solidFill>
-                          <a:latin typeface="Calibri" pitchFamily="34" charset="0"/>
-                          <a:ea typeface="Calibri" pitchFamily="34" charset="-122"/>
-                          <a:cs typeface="Calibri" pitchFamily="34" charset="-120"/>
-                        </a:rPr>
-                        <a:t>uwtig_no_lookahead</a:t>
-                      </a:r>
-                      <a:endParaRPr lang="en-US" sz="1000" dirty="0">
-                        <a:latin typeface="Calibri" charset="0"/>
-                        <a:ea typeface="Calibri" charset="0"/>
-                        <a:cs typeface="Calibri" charset="0"/>
-                      </a:endParaRPr>
-                    </a:p>
-                  </a:txBody>
-                  <a:tcPr marL="91440" marR="91440" marT="45720" marB="45720" anchor="ctr">
-                    <a:lnL w="6350" cap="flat" cmpd="sng" algn="ctr">
-                      <a:solidFill>
-                        <a:srgbClr val="A6A6A6"/>
-                      </a:solidFill>
-                      <a:prstDash val="solid"/>
-                      <a:round/>
-                      <a:headEnd type="none" w="med" len="med"/>
-                      <a:tailEnd type="none" w="med" len="med"/>
-                    </a:lnL>
-                    <a:lnR w="6350" cap="flat" cmpd="sng" algn="ctr">
-                      <a:solidFill>
-                        <a:srgbClr val="A6A6A6"/>
-                      </a:solidFill>
-                      <a:prstDash val="solid"/>
-                      <a:round/>
-                      <a:headEnd type="none" w="med" len="med"/>
-                      <a:tailEnd type="none" w="med" len="med"/>
-                    </a:lnR>
-                    <a:lnT w="6350" cap="flat" cmpd="sng" algn="ctr">
-                      <a:solidFill>
-                        <a:srgbClr val="A6A6A6"/>
-                      </a:solidFill>
-                      <a:prstDash val="solid"/>
-                      <a:round/>
-                      <a:headEnd type="none" w="med" len="med"/>
-                      <a:tailEnd type="none" w="med" len="med"/>
-                    </a:lnT>
-                    <a:lnB w="6350" cap="flat" cmpd="sng" algn="ctr">
-                      <a:solidFill>
-                        <a:srgbClr val="A6A6A6"/>
-                      </a:solidFill>
-                      <a:prstDash val="solid"/>
-                      <a:round/>
-                      <a:headEnd type="none" w="med" len="med"/>
-                      <a:tailEnd type="none" w="med" len="med"/>
-                    </a:lnB>
-                    <a:solidFill>
-                      <a:srgbClr val="F2F2F2"/>
-                    </a:solidFill>
-                  </a:tcPr>
-                </a:tc>
-                <a:tc>
-                  <a:txBody>
-                    <a:bodyPr/>
-                    <a:lstStyle/>
-                    <a:p>
-                      <a:pPr algn="ctr" indent="0" marL="0">
-                        <a:buNone/>
-                      </a:pPr>
-                      <a:r>
-                        <a:rPr lang="en-US" sz="1000" dirty="0">
-                          <a:solidFill>
-                            <a:srgbClr val="000000"/>
-                          </a:solidFill>
-                          <a:latin typeface="Calibri" pitchFamily="34" charset="0"/>
-                          <a:ea typeface="Calibri" pitchFamily="34" charset="-122"/>
-                          <a:cs typeface="Calibri" pitchFamily="34" charset="-120"/>
-                        </a:rPr>
-                        <a:t>0.967</a:t>
-                      </a:r>
-                      <a:endParaRPr lang="en-US" sz="1000" dirty="0">
-                        <a:latin typeface="Calibri" charset="0"/>
-                        <a:ea typeface="Calibri" charset="0"/>
-                        <a:cs typeface="Calibri" charset="0"/>
-                      </a:endParaRPr>
-                    </a:p>
-                  </a:txBody>
-                  <a:tcPr marL="91440" marR="91440" marT="45720" marB="45720" anchor="ctr">
-                    <a:lnL w="6350" cap="flat" cmpd="sng" algn="ctr">
-                      <a:solidFill>
-                        <a:srgbClr val="A6A6A6"/>
-                      </a:solidFill>
-                      <a:prstDash val="solid"/>
-                      <a:round/>
-                      <a:headEnd type="none" w="med" len="med"/>
-                      <a:tailEnd type="none" w="med" len="med"/>
-                    </a:lnL>
-                    <a:lnR w="6350" cap="flat" cmpd="sng" algn="ctr">
-                      <a:solidFill>
-                        <a:srgbClr val="A6A6A6"/>
-                      </a:solidFill>
-                      <a:prstDash val="solid"/>
-                      <a:round/>
-                      <a:headEnd type="none" w="med" len="med"/>
-                      <a:tailEnd type="none" w="med" len="med"/>
-                    </a:lnR>
-                    <a:lnT w="6350" cap="flat" cmpd="sng" algn="ctr">
-                      <a:solidFill>
-                        <a:srgbClr val="A6A6A6"/>
-                      </a:solidFill>
-                      <a:prstDash val="solid"/>
-                      <a:round/>
-                      <a:headEnd type="none" w="med" len="med"/>
-                      <a:tailEnd type="none" w="med" len="med"/>
-                    </a:lnT>
-                    <a:lnB w="6350" cap="flat" cmpd="sng" algn="ctr">
-                      <a:solidFill>
-                        <a:srgbClr val="A6A6A6"/>
-                      </a:solidFill>
-                      <a:prstDash val="solid"/>
-                      <a:round/>
-                      <a:headEnd type="none" w="med" len="med"/>
-                      <a:tailEnd type="none" w="med" len="med"/>
-                    </a:lnB>
-                    <a:solidFill>
-                      <a:srgbClr val="F2F2F2"/>
-                    </a:solidFill>
-                  </a:tcPr>
-                </a:tc>
-                <a:tc>
-                  <a:txBody>
-                    <a:bodyPr/>
-                    <a:lstStyle/>
-                    <a:p>
-                      <a:pPr algn="ctr" indent="0" marL="0">
-                        <a:buNone/>
-                      </a:pPr>
-                      <a:r>
-                        <a:rPr lang="en-US" sz="1000" dirty="0">
-                          <a:solidFill>
-                            <a:srgbClr val="000000"/>
-                          </a:solidFill>
-                          <a:latin typeface="Calibri" pitchFamily="34" charset="0"/>
-                          <a:ea typeface="Calibri" pitchFamily="34" charset="-122"/>
-                          <a:cs typeface="Calibri" pitchFamily="34" charset="-120"/>
-                        </a:rPr>
-                        <a:t>0.956</a:t>
-                      </a:r>
-                      <a:endParaRPr lang="en-US" sz="1000" dirty="0">
-                        <a:latin typeface="Calibri" charset="0"/>
-                        <a:ea typeface="Calibri" charset="0"/>
-                        <a:cs typeface="Calibri" charset="0"/>
-                      </a:endParaRPr>
-                    </a:p>
-                  </a:txBody>
-                  <a:tcPr marL="91440" marR="91440" marT="45720" marB="45720" anchor="ctr">
-                    <a:lnL w="6350" cap="flat" cmpd="sng" algn="ctr">
-                      <a:solidFill>
-                        <a:srgbClr val="A6A6A6"/>
-                      </a:solidFill>
-                      <a:prstDash val="solid"/>
-                      <a:round/>
-                      <a:headEnd type="none" w="med" len="med"/>
-                      <a:tailEnd type="none" w="med" len="med"/>
-                    </a:lnL>
-                    <a:lnR w="6350" cap="flat" cmpd="sng" algn="ctr">
-                      <a:solidFill>
-                        <a:srgbClr val="A6A6A6"/>
-                      </a:solidFill>
-                      <a:prstDash val="solid"/>
-                      <a:round/>
-                      <a:headEnd type="none" w="med" len="med"/>
-                      <a:tailEnd type="none" w="med" len="med"/>
-                    </a:lnR>
-                    <a:lnT w="6350" cap="flat" cmpd="sng" algn="ctr">
-                      <a:solidFill>
-                        <a:srgbClr val="A6A6A6"/>
-                      </a:solidFill>
-                      <a:prstDash val="solid"/>
-                      <a:round/>
-                      <a:headEnd type="none" w="med" len="med"/>
-                      <a:tailEnd type="none" w="med" len="med"/>
-                    </a:lnT>
-                    <a:lnB w="6350" cap="flat" cmpd="sng" algn="ctr">
-                      <a:solidFill>
-                        <a:srgbClr val="A6A6A6"/>
-                      </a:solidFill>
-                      <a:prstDash val="solid"/>
-                      <a:round/>
-                      <a:headEnd type="none" w="med" len="med"/>
-                      <a:tailEnd type="none" w="med" len="med"/>
-                    </a:lnB>
-                    <a:solidFill>
-                      <a:srgbClr val="F2F2F2"/>
-                    </a:solidFill>
-                  </a:tcPr>
-                </a:tc>
-                <a:tc>
-                  <a:txBody>
-                    <a:bodyPr/>
-                    <a:lstStyle/>
-                    <a:p>
-                      <a:pPr algn="ctr" indent="0" marL="0">
-                        <a:buNone/>
-                      </a:pPr>
-                      <a:r>
-                        <a:rPr lang="en-US" sz="1000" dirty="0">
-                          <a:solidFill>
-                            <a:srgbClr val="000000"/>
-                          </a:solidFill>
-                          <a:latin typeface="Calibri" pitchFamily="34" charset="0"/>
-                          <a:ea typeface="Calibri" pitchFamily="34" charset="-122"/>
-                          <a:cs typeface="Calibri" pitchFamily="34" charset="-120"/>
-                        </a:rPr>
-                        <a:t>0.958</a:t>
-                      </a:r>
-                      <a:endParaRPr lang="en-US" sz="1000" dirty="0">
-                        <a:latin typeface="Calibri" charset="0"/>
-                        <a:ea typeface="Calibri" charset="0"/>
-                        <a:cs typeface="Calibri" charset="0"/>
-                      </a:endParaRPr>
-                    </a:p>
-                  </a:txBody>
-                  <a:tcPr marL="91440" marR="91440" marT="45720" marB="45720" anchor="ctr">
-                    <a:lnL w="6350" cap="flat" cmpd="sng" algn="ctr">
-                      <a:solidFill>
-                        <a:srgbClr val="A6A6A6"/>
-                      </a:solidFill>
-                      <a:prstDash val="solid"/>
-                      <a:round/>
-                      <a:headEnd type="none" w="med" len="med"/>
-                      <a:tailEnd type="none" w="med" len="med"/>
-                    </a:lnL>
-                    <a:lnR w="6350" cap="flat" cmpd="sng" algn="ctr">
-                      <a:solidFill>
-                        <a:srgbClr val="A6A6A6"/>
-                      </a:solidFill>
-                      <a:prstDash val="solid"/>
-                      <a:round/>
-                      <a:headEnd type="none" w="med" len="med"/>
-                      <a:tailEnd type="none" w="med" len="med"/>
-                    </a:lnR>
-                    <a:lnT w="6350" cap="flat" cmpd="sng" algn="ctr">
-                      <a:solidFill>
-                        <a:srgbClr val="A6A6A6"/>
-                      </a:solidFill>
-                      <a:prstDash val="solid"/>
-                      <a:round/>
-                      <a:headEnd type="none" w="med" len="med"/>
-                      <a:tailEnd type="none" w="med" len="med"/>
-                    </a:lnT>
-                    <a:lnB w="6350" cap="flat" cmpd="sng" algn="ctr">
-                      <a:solidFill>
-                        <a:srgbClr val="A6A6A6"/>
-                      </a:solidFill>
-                      <a:prstDash val="solid"/>
-                      <a:round/>
-                      <a:headEnd type="none" w="med" len="med"/>
-                      <a:tailEnd type="none" w="med" len="med"/>
-                    </a:lnB>
-                    <a:solidFill>
-                      <a:srgbClr val="F2F2F2"/>
-                    </a:solidFill>
-                  </a:tcPr>
-                </a:tc>
-                <a:tc>
-                  <a:txBody>
-                    <a:bodyPr/>
-                    <a:lstStyle/>
-                    <a:p>
-                      <a:pPr algn="ctr" indent="0" marL="0">
-                        <a:buNone/>
-                      </a:pPr>
-                      <a:r>
-                        <a:rPr lang="en-US" sz="1000" dirty="0">
-                          <a:solidFill>
-                            <a:srgbClr val="000000"/>
-                          </a:solidFill>
-                          <a:latin typeface="Calibri" pitchFamily="34" charset="0"/>
-                          <a:ea typeface="Calibri" pitchFamily="34" charset="-122"/>
-                          <a:cs typeface="Calibri" pitchFamily="34" charset="-120"/>
-                        </a:rPr>
-                        <a:t>0.59</a:t>
-                      </a:r>
-                      <a:endParaRPr lang="en-US" sz="1000" dirty="0">
-                        <a:latin typeface="Calibri" charset="0"/>
-                        <a:ea typeface="Calibri" charset="0"/>
-                        <a:cs typeface="Calibri" charset="0"/>
-                      </a:endParaRPr>
-                    </a:p>
-                  </a:txBody>
-                  <a:tcPr marL="91440" marR="91440" marT="45720" marB="45720" anchor="ctr">
-                    <a:lnL w="6350" cap="flat" cmpd="sng" algn="ctr">
-                      <a:solidFill>
-                        <a:srgbClr val="A6A6A6"/>
-                      </a:solidFill>
-                      <a:prstDash val="solid"/>
-                      <a:round/>
-                      <a:headEnd type="none" w="med" len="med"/>
-                      <a:tailEnd type="none" w="med" len="med"/>
-                    </a:lnL>
-                    <a:lnR w="6350" cap="flat" cmpd="sng" algn="ctr">
-                      <a:solidFill>
-                        <a:srgbClr val="A6A6A6"/>
-                      </a:solidFill>
-                      <a:prstDash val="solid"/>
-                      <a:round/>
-                      <a:headEnd type="none" w="med" len="med"/>
-                      <a:tailEnd type="none" w="med" len="med"/>
-                    </a:lnR>
-                    <a:lnT w="6350" cap="flat" cmpd="sng" algn="ctr">
-                      <a:solidFill>
-                        <a:srgbClr val="A6A6A6"/>
-                      </a:solidFill>
-                      <a:prstDash val="solid"/>
-                      <a:round/>
-                      <a:headEnd type="none" w="med" len="med"/>
-                      <a:tailEnd type="none" w="med" len="med"/>
-                    </a:lnT>
-                    <a:lnB w="6350" cap="flat" cmpd="sng" algn="ctr">
-                      <a:solidFill>
-                        <a:srgbClr val="A6A6A6"/>
-                      </a:solidFill>
-                      <a:prstDash val="solid"/>
-                      <a:round/>
-                      <a:headEnd type="none" w="med" len="med"/>
-                      <a:tailEnd type="none" w="med" len="med"/>
-                    </a:lnB>
-                    <a:solidFill>
-                      <a:srgbClr val="F2F2F2"/>
-                    </a:solidFill>
-                  </a:tcPr>
-                </a:tc>
-                <a:tc>
-                  <a:txBody>
-                    <a:bodyPr/>
-                    <a:lstStyle/>
-                    <a:p>
-                      <a:pPr algn="ctr" indent="0" marL="0">
-                        <a:buNone/>
-                      </a:pPr>
-                      <a:r>
-                        <a:rPr lang="en-US" sz="1000" dirty="0">
-                          <a:solidFill>
-                            <a:srgbClr val="000000"/>
-                          </a:solidFill>
-                          <a:latin typeface="Calibri" pitchFamily="34" charset="0"/>
-                          <a:ea typeface="Calibri" pitchFamily="34" charset="-122"/>
-                          <a:cs typeface="Calibri" pitchFamily="34" charset="-120"/>
-                        </a:rPr>
-                        <a:t>85.2</a:t>
-                      </a:r>
-                      <a:endParaRPr lang="en-US" sz="1000" dirty="0">
-                        <a:latin typeface="Calibri" charset="0"/>
-                        <a:ea typeface="Calibri" charset="0"/>
-                        <a:cs typeface="Calibri" charset="0"/>
-                      </a:endParaRPr>
-                    </a:p>
-                  </a:txBody>
-                  <a:tcPr marL="91440" marR="91440" marT="45720" marB="45720" anchor="ctr">
-                    <a:lnL w="6350" cap="flat" cmpd="sng" algn="ctr">
-                      <a:solidFill>
-                        <a:srgbClr val="A6A6A6"/>
-                      </a:solidFill>
-                      <a:prstDash val="solid"/>
-                      <a:round/>
-                      <a:headEnd type="none" w="med" len="med"/>
-                      <a:tailEnd type="none" w="med" len="med"/>
-                    </a:lnL>
-                    <a:lnR w="6350" cap="flat" cmpd="sng" algn="ctr">
-                      <a:solidFill>
-                        <a:srgbClr val="A6A6A6"/>
-                      </a:solidFill>
-                      <a:prstDash val="solid"/>
-                      <a:round/>
-                      <a:headEnd type="none" w="med" len="med"/>
-                      <a:tailEnd type="none" w="med" len="med"/>
-                    </a:lnR>
-                    <a:lnT w="6350" cap="flat" cmpd="sng" algn="ctr">
-                      <a:solidFill>
-                        <a:srgbClr val="A6A6A6"/>
-                      </a:solidFill>
-                      <a:prstDash val="solid"/>
-                      <a:round/>
-                      <a:headEnd type="none" w="med" len="med"/>
-                      <a:tailEnd type="none" w="med" len="med"/>
-                    </a:lnT>
-                    <a:lnB w="6350" cap="flat" cmpd="sng" algn="ctr">
-                      <a:solidFill>
-                        <a:srgbClr val="A6A6A6"/>
-                      </a:solidFill>
-                      <a:prstDash val="solid"/>
-                      <a:round/>
-                      <a:headEnd type="none" w="med" len="med"/>
-                      <a:tailEnd type="none" w="med" len="med"/>
-                    </a:lnB>
-                    <a:solidFill>
-                      <a:srgbClr val="F2F2F2"/>
-                    </a:solidFill>
-                  </a:tcPr>
-                </a:tc>
-                <a:tc>
-                  <a:txBody>
-                    <a:bodyPr/>
-                    <a:lstStyle/>
-                    <a:p>
-                      <a:pPr algn="ctr" indent="0" marL="0">
-                        <a:buNone/>
-                      </a:pPr>
-                      <a:r>
-                        <a:rPr lang="en-US" sz="1000" dirty="0">
-                          <a:solidFill>
-                            <a:srgbClr val="000000"/>
-                          </a:solidFill>
-                          <a:latin typeface="Calibri" pitchFamily="34" charset="0"/>
-                          <a:ea typeface="Calibri" pitchFamily="34" charset="-122"/>
-                          <a:cs typeface="Calibri" pitchFamily="34" charset="-120"/>
-                        </a:rPr>
-                        <a:t>1.00</a:t>
-                      </a:r>
-                      <a:endParaRPr lang="en-US" sz="1000" dirty="0">
+                      <a:endParaRPr lang="en-US" sz="1150" dirty="0">
                         <a:latin typeface="Calibri" charset="0"/>
                         <a:ea typeface="Calibri" charset="0"/>
                         <a:cs typeface="Calibri" charset="0"/>
@@ -13489,8 +12533,8 @@
         </p:nvSpPr>
         <p:spPr>
           <a:xfrm>
-            <a:off x="548640" y="4251960"/>
-            <a:ext cx="11064240" cy="365760"/>
+            <a:off x="548640" y="3931920"/>
+            <a:ext cx="11064240" cy="411480"/>
           </a:xfrm>
           <a:prstGeom prst="rect">
             <a:avLst/>
@@ -13506,7 +12550,7 @@
               <a:buNone/>
             </a:pPr>
             <a:r>
-              <a:rPr lang="en-US" sz="1000" i="1" dirty="0">
+              <a:rPr lang="en-US" sz="1050" i="1" dirty="0">
                 <a:solidFill>
                   <a:srgbClr val="595959"/>
                 </a:solidFill>
@@ -13516,7 +12560,7 @@
               </a:rPr>
               <a:t>Coverage phase is decisive: F1 0.953 with it, 0.680 without. Removing the staleness term or the lookahead scores slightly HIGHER and flies less -- once a single look is ~99% reliable, they add flying without adding accuracy.</a:t>
             </a:r>
-            <a:endParaRPr lang="en-US" sz="1000" dirty="0"/>
+            <a:endParaRPr lang="en-US" sz="1050" dirty="0"/>
           </a:p>
         </p:txBody>
       </p:sp>
@@ -13528,7 +12572,7 @@
         </p:nvSpPr>
         <p:spPr>
           <a:xfrm>
-            <a:off x="548640" y="4663440"/>
+            <a:off x="548640" y="4526280"/>
             <a:ext cx="11064240" cy="274320"/>
           </a:xfrm>
           <a:prstGeom prst="rect">
@@ -13553,7 +12597,7 @@
                 <a:ea typeface="Cambria" pitchFamily="34" charset="-122"/>
                 <a:cs typeface="Cambria" pitchFamily="34" charset="-120"/>
               </a:rPr>
-              <a:t>Why uncertainty/temporal show ZERO or near-zero change -- checked in the code, not assumed:</a:t>
+              <a:t>Uncertainty and temporal aren't shown above because their numbers don't move -- checked in the code, not assumed:</a:t>
             </a:r>
             <a:endParaRPr lang="en-US" sz="1150" dirty="0"/>
           </a:p>
@@ -13567,7 +12611,7 @@
         </p:nvSpPr>
         <p:spPr>
           <a:xfrm>
-            <a:off x="640080" y="4956048"/>
+            <a:off x="640080" y="4828032"/>
             <a:ext cx="10881360" cy="4846320"/>
           </a:xfrm>
           <a:prstGeom prst="rect">
@@ -13582,13 +12626,13 @@
           <a:p>
             <a:pPr marL="228600" indent="-228600">
               <a:spcAft>
-                <a:spcPts val="400"/>
+                <a:spcPts val="600"/>
               </a:spcAft>
               <a:buSzPct val="100000"/>
               <a:buChar char="●"/>
             </a:pPr>
             <a:r>
-              <a:rPr lang="en-US" sz="930" dirty="0">
+              <a:rPr lang="en-US" sz="1000" dirty="0">
                 <a:solidFill>
                   <a:srgbClr val="000000"/>
                 </a:solidFill>
@@ -13598,18 +12642,18 @@
               </a:rPr>
               <a:t>The coverage-guarantee phase (~half of every mission's budget) uses neither term at all -- it picks purely by ig-cost until every wall has 1 look; only the remaining budget reaches the full utility where these terms are even evaluated.</a:t>
             </a:r>
-            <a:endParaRPr lang="en-US" sz="930" dirty="0"/>
+            <a:endParaRPr lang="en-US" sz="1000" dirty="0"/>
           </a:p>
           <a:p>
             <a:pPr marL="228600" indent="-228600">
               <a:spcAft>
-                <a:spcPts val="400"/>
+                <a:spcPts val="600"/>
               </a:spcAft>
               <a:buSzPct val="100000"/>
               <a:buChar char="●"/>
             </a:pPr>
             <a:r>
-              <a:rPr lang="en-US" sz="930" dirty="0">
+              <a:rPr lang="en-US" sz="1000" dirty="0">
                 <a:solidFill>
                   <a:srgbClr val="000000"/>
                 </a:solidFill>
@@ -13617,20 +12661,20 @@
                 <a:ea typeface="Calibri" pitchFamily="34" charset="-122"/>
                 <a:cs typeface="Calibri" pitchFamily="34" charset="-120"/>
               </a:rPr>
-              <a:t>Temporal (growth) tracks a defect getting WORSE between visits -- but these 3 scenarios have no real growth (only the excluded "growing" scenario does), so it's just detector noise near zero. Confirmed, not assumed: removing it leaves flight distance bit-identical (125.1m both ways).</a:t>
+              <a:t>Temporal (growth) tracks a defect getting WORSE between visits -- but these 3 scenarios have no real growth (only the excluded "growing" scenario does), so it's just detector noise near zero: removing it leaves every metric, including flight distance, bit-identical to the full planner.</a:t>
             </a:r>
-            <a:endParaRPr lang="en-US" sz="930" dirty="0"/>
+            <a:endParaRPr lang="en-US" sz="1000" dirty="0"/>
           </a:p>
           <a:p>
             <a:pPr marL="228600" indent="-228600">
               <a:spcAft>
-                <a:spcPts val="400"/>
+                <a:spcPts val="600"/>
               </a:spcAft>
               <a:buSzPct val="100000"/>
               <a:buChar char="●"/>
             </a:pPr>
             <a:r>
-              <a:rPr lang="en-US" sz="930" dirty="0">
+              <a:rPr lang="en-US" sz="1000" dirty="0">
                 <a:solidFill>
                   <a:srgbClr val="000000"/>
                 </a:solidFill>
@@ -13638,9 +12682,9 @@
                 <a:ea typeface="Calibri" pitchFamily="34" charset="-122"/>
                 <a:cs typeface="Calibri" pitchFamily="34" charset="-120"/>
               </a:rPr>
-              <a:t>Uncertainty is a real, nonzero signal (TTA confidence spread) -- removing it does shift the path slightly (124.6m vs 125.1m), but its scale is small next to the coverage/staleness/cost terms, so it reorders visits without changing how many total looks each wall ends up with -- which is all confirmed precision/recall depends on.</a:t>
+              <a:t>Uncertainty is a real, nonzero signal (TTA confidence spread), but its scale is small next to the coverage/staleness/cost terms -- removing it shifts the flight path by under 1m with every other metric unchanged, since confirmed precision/recall only depends on how many total looks each wall gets, not the order.</a:t>
             </a:r>
-            <a:endParaRPr lang="en-US" sz="930" dirty="0"/>
+            <a:endParaRPr lang="en-US" sz="1000" dirty="0"/>
           </a:p>
         </p:txBody>
       </p:sp>
@@ -13652,7 +12696,7 @@
         </p:nvSpPr>
         <p:spPr>
           <a:xfrm>
-            <a:off x="548640" y="6263640"/>
+            <a:off x="548640" y="6217920"/>
             <a:ext cx="11064240" cy="365760"/>
           </a:xfrm>
           <a:prstGeom prst="rect">
@@ -13669,7 +12713,7 @@
               <a:buNone/>
             </a:pPr>
             <a:r>
-              <a:rPr lang="en-US" sz="900" dirty="0">
+              <a:rPr lang="en-US" sz="930" dirty="0">
                 <a:solidFill>
                   <a:srgbClr val="808080"/>
                 </a:solidFill>
@@ -13679,7 +12723,7 @@
               </a:rPr>
               <a:t>Every planner's own precision under the pre-fix scoring formula on these same runs was far lower (UW-TIG: 0.668) -- five measurement fixes, not planner changes, lifted every planner above. Not every slice clears 0.90: the "uncertain" scenario's precision is 0.893.</a:t>
             </a:r>
-            <a:endParaRPr lang="en-US" sz="900" dirty="0"/>
+            <a:endParaRPr lang="en-US" sz="930" dirty="0"/>
           </a:p>
         </p:txBody>
       </p:sp>

</xml_diff>

<commit_message>
Frame the work against recent (2023-2026) planners, not a 2016 'base paper'
Dissertation, deck, progress report and docs no longer call Isler et al. 2016 the
base paper. Recent work (Ruckin 2023, GATSBI 2023/24, Moon 2026) is now the
reference point; Isler/Bircher/Alamdari are described as classical building
blocks and baselines. Dissertation references renumbered recent-first.

Co-Authored-By: Claude Sonnet 5.5 <noreply@anthropic.com>
</commit_message>
<xml_diff>
--- a/drone-sim-today/Autonomous_Drone_Inspection_Progress.pptx
+++ b/drone-sim-today/Autonomous_Drone_Inspection_Progress.pptx
@@ -4034,7 +4034,7 @@
                           <a:ea typeface="Calibri" pitchFamily="34" charset="-122"/>
                           <a:cs typeface="Calibri" pitchFamily="34" charset="-120"/>
                         </a:rPr>
-                        <a:t>Isler et al. 2016 (base paper)</a:t>
+                        <a:t>Isler-NBV (classical, 2016)</a:t>
                       </a:r>
                       <a:endParaRPr lang="en-US" sz="1200" dirty="0">
                         <a:latin typeface="Calibri" charset="0"/>
@@ -7739,7 +7739,7 @@
                 <a:ea typeface="Cambria" pitchFamily="34" charset="-122"/>
                 <a:cs typeface="Cambria" pitchFamily="34" charset="-120"/>
               </a:rPr>
-              <a:t>Geometry-only planners</a:t>
+              <a:t>Single-session planners</a:t>
             </a:r>
             <a:endParaRPr lang="en-US" sz="1500" dirty="0"/>
           </a:p>
@@ -7778,7 +7778,7 @@
                 <a:ea typeface="Calibri" pitchFamily="34" charset="-122"/>
                 <a:cs typeface="Calibri" pitchFamily="34" charset="-120"/>
               </a:rPr>
-              <a:t>Next-best-view methods (e.g. Isler et al. 2016) maximise visual coverage, with no notion of a defect.</a:t>
+              <a:t>Recent planners (Rückin 2023, GATSBI 2023/24, Moon 2026) work within one session; none tracks a defect across missions.</a:t>
             </a:r>
             <a:endParaRPr lang="en-US" sz="1300" dirty="0"/>
           </a:p>
@@ -8005,7 +8005,7 @@
                 <a:ea typeface="Calibri" pitchFamily="34" charset="-122"/>
                 <a:cs typeface="Calibri" pitchFamily="34" charset="-120"/>
               </a:rPr>
-              <a:t>This project builds a simulated autonomous drone (PyBullet, gym-pybullet-drones) that inspects an open-air utility yard for surface defects. A YOLOv8 detector trained on 14,471 real UAV photographs (MBDD2025) finds cracks, leakage, abscission, corrosion and bulging, and a test-time-augmentation ensemble estimates each detection's uncertainty. Detections are ray-cast to 3-D positions and stored in a persistent memory (PostgreSQL + pgvector, Neo4j) that tracks each defect across missions. The proposed planner, UW-TIG, extends the information-gain next-best-view formulation of Isler et al. (2016) with a coverage guarantee, detection uncertainty, defect growth, revisit staleness and a two-step lookahead. It is compared on held-out test seeds against random search and five re-implemented published planners.</a:t>
+              <a:t>This project builds a simulated autonomous drone (PyBullet, gym-pybullet-drones) that inspects an open-air utility yard for surface defects. A YOLOv8 detector trained on 14,471 real UAV photographs (MBDD2025) finds cracks, leakage, abscission, corrosion and bulging, and a test-time-augmentation ensemble estimates each detection's uncertainty. Detections are ray-cast to 3-D positions and stored in a persistent memory (PostgreSQL + pgvector, Neo4j) that tracks each defect across missions. The proposed planner, UW-TIG, builds on recent uncertainty-driven informative path planning (Rückin et al. 2023, Moon et al. 2026) and adds a coverage guarantee, detection uncertainty, defect growth, revisit staleness and a two-step lookahead. It is compared on held-out test seeds against random search and five re-implemented published planners.</a:t>
             </a:r>
             <a:endParaRPr lang="en-US" sz="1500" dirty="0"/>
           </a:p>
@@ -8889,301 +8889,6 @@
                           <a:ea typeface="Calibri" pitchFamily="34" charset="-122"/>
                           <a:cs typeface="Calibri" pitchFamily="34" charset="-120"/>
                         </a:rPr>
-                        <a:t>Isler et al., ICRA 2016 -- base paper</a:t>
-                      </a:r>
-                      <a:endParaRPr lang="en-US" sz="1050" dirty="0">
-                        <a:latin typeface="Calibri" charset="0"/>
-                        <a:ea typeface="Calibri" charset="0"/>
-                        <a:cs typeface="Calibri" charset="0"/>
-                      </a:endParaRPr>
-                    </a:p>
-                    <a:p>
-                      <a:pPr algn="l" indent="0" marL="0">
-                        <a:buNone/>
-                      </a:pPr>
-                      <a:r>
-                        <a:rPr lang="en-US" sz="1050" dirty="0">
-                          <a:solidFill>
-                            <a:srgbClr val="000000"/>
-                          </a:solidFill>
-                          <a:latin typeface="Calibri" pitchFamily="34" charset="0"/>
-                          <a:ea typeface="Calibri" pitchFamily="34" charset="-122"/>
-                          <a:cs typeface="Calibri" pitchFamily="34" charset="-120"/>
-                        </a:rPr>
-                        <a:t>Information-gain next-best-view</a:t>
-                      </a:r>
-                      <a:endParaRPr lang="en-US" sz="1050" dirty="0">
-                        <a:latin typeface="Calibri" charset="0"/>
-                        <a:ea typeface="Calibri" charset="0"/>
-                        <a:cs typeface="Calibri" charset="0"/>
-                      </a:endParaRPr>
-                    </a:p>
-                  </a:txBody>
-                  <a:tcPr marL="76200" marR="76200" marT="38100" marB="38100" anchor="ctr">
-                    <a:lnL w="9525" cap="flat" cmpd="sng" algn="ctr">
-                      <a:solidFill>
-                        <a:srgbClr val="D9D9D9"/>
-                      </a:solidFill>
-                      <a:prstDash val="solid"/>
-                      <a:round/>
-                      <a:headEnd type="none" w="med" len="med"/>
-                      <a:tailEnd type="none" w="med" len="med"/>
-                    </a:lnL>
-                    <a:lnR w="9525" cap="flat" cmpd="sng" algn="ctr">
-                      <a:solidFill>
-                        <a:srgbClr val="D9D9D9"/>
-                      </a:solidFill>
-                      <a:prstDash val="solid"/>
-                      <a:round/>
-                      <a:headEnd type="none" w="med" len="med"/>
-                      <a:tailEnd type="none" w="med" len="med"/>
-                    </a:lnR>
-                    <a:lnT w="9525" cap="flat" cmpd="sng" algn="ctr">
-                      <a:solidFill>
-                        <a:srgbClr val="D9D9D9"/>
-                      </a:solidFill>
-                      <a:prstDash val="solid"/>
-                      <a:round/>
-                      <a:headEnd type="none" w="med" len="med"/>
-                      <a:tailEnd type="none" w="med" len="med"/>
-                    </a:lnT>
-                    <a:lnB w="9525" cap="flat" cmpd="sng" algn="ctr">
-                      <a:solidFill>
-                        <a:srgbClr val="D9D9D9"/>
-                      </a:solidFill>
-                      <a:prstDash val="solid"/>
-                      <a:round/>
-                      <a:headEnd type="none" w="med" len="med"/>
-                      <a:tailEnd type="none" w="med" len="med"/>
-                    </a:lnB>
-                    <a:solidFill>
-                      <a:srgbClr val="FFFFFF"/>
-                    </a:solidFill>
-                  </a:tcPr>
-                </a:tc>
-                <a:tc>
-                  <a:txBody>
-                    <a:bodyPr/>
-                    <a:lstStyle/>
-                    <a:p>
-                      <a:pPr algn="l" indent="0" marL="0">
-                        <a:buNone/>
-                      </a:pPr>
-                      <a:r>
-                        <a:rPr lang="en-US" sz="1050" dirty="0">
-                          <a:solidFill>
-                            <a:srgbClr val="000000"/>
-                          </a:solidFill>
-                          <a:latin typeface="Calibri" pitchFamily="34" charset="0"/>
-                          <a:ea typeface="Calibri" pitchFamily="34" charset="-122"/>
-                          <a:cs typeface="Calibri" pitchFamily="34" charset="-120"/>
-                        </a:rPr>
-                        <a:t>Entropy-based, cost-normalised view selection</a:t>
-                      </a:r>
-                      <a:endParaRPr lang="en-US" sz="1050" dirty="0">
-                        <a:latin typeface="Calibri" charset="0"/>
-                        <a:ea typeface="Calibri" charset="0"/>
-                        <a:cs typeface="Calibri" charset="0"/>
-                      </a:endParaRPr>
-                    </a:p>
-                  </a:txBody>
-                  <a:tcPr marL="76200" marR="76200" marT="38100" marB="38100" anchor="ctr">
-                    <a:lnL w="9525" cap="flat" cmpd="sng" algn="ctr">
-                      <a:solidFill>
-                        <a:srgbClr val="D9D9D9"/>
-                      </a:solidFill>
-                      <a:prstDash val="solid"/>
-                      <a:round/>
-                      <a:headEnd type="none" w="med" len="med"/>
-                      <a:tailEnd type="none" w="med" len="med"/>
-                    </a:lnL>
-                    <a:lnR w="9525" cap="flat" cmpd="sng" algn="ctr">
-                      <a:solidFill>
-                        <a:srgbClr val="D9D9D9"/>
-                      </a:solidFill>
-                      <a:prstDash val="solid"/>
-                      <a:round/>
-                      <a:headEnd type="none" w="med" len="med"/>
-                      <a:tailEnd type="none" w="med" len="med"/>
-                    </a:lnR>
-                    <a:lnT w="9525" cap="flat" cmpd="sng" algn="ctr">
-                      <a:solidFill>
-                        <a:srgbClr val="D9D9D9"/>
-                      </a:solidFill>
-                      <a:prstDash val="solid"/>
-                      <a:round/>
-                      <a:headEnd type="none" w="med" len="med"/>
-                      <a:tailEnd type="none" w="med" len="med"/>
-                    </a:lnT>
-                    <a:lnB w="9525" cap="flat" cmpd="sng" algn="ctr">
-                      <a:solidFill>
-                        <a:srgbClr val="D9D9D9"/>
-                      </a:solidFill>
-                      <a:prstDash val="solid"/>
-                      <a:round/>
-                      <a:headEnd type="none" w="med" len="med"/>
-                      <a:tailEnd type="none" w="med" len="med"/>
-                    </a:lnB>
-                    <a:solidFill>
-                      <a:srgbClr val="FFFFFF"/>
-                    </a:solidFill>
-                  </a:tcPr>
-                </a:tc>
-                <a:tc>
-                  <a:txBody>
-                    <a:bodyPr/>
-                    <a:lstStyle/>
-                    <a:p>
-                      <a:pPr algn="l" indent="0" marL="0">
-                        <a:buNone/>
-                      </a:pPr>
-                      <a:r>
-                        <a:rPr lang="en-US" sz="1050" dirty="0">
-                          <a:solidFill>
-                            <a:srgbClr val="000000"/>
-                          </a:solidFill>
-                          <a:latin typeface="Calibri" pitchFamily="34" charset="0"/>
-                          <a:ea typeface="Calibri" pitchFamily="34" charset="-122"/>
-                          <a:cs typeface="Calibri" pitchFamily="34" charset="-120"/>
-                        </a:rPr>
-                        <a:t>Principled view choice; our starting point</a:t>
-                      </a:r>
-                      <a:endParaRPr lang="en-US" sz="1050" dirty="0">
-                        <a:latin typeface="Calibri" charset="0"/>
-                        <a:ea typeface="Calibri" charset="0"/>
-                        <a:cs typeface="Calibri" charset="0"/>
-                      </a:endParaRPr>
-                    </a:p>
-                  </a:txBody>
-                  <a:tcPr marL="76200" marR="76200" marT="38100" marB="38100" anchor="ctr">
-                    <a:lnL w="9525" cap="flat" cmpd="sng" algn="ctr">
-                      <a:solidFill>
-                        <a:srgbClr val="D9D9D9"/>
-                      </a:solidFill>
-                      <a:prstDash val="solid"/>
-                      <a:round/>
-                      <a:headEnd type="none" w="med" len="med"/>
-                      <a:tailEnd type="none" w="med" len="med"/>
-                    </a:lnL>
-                    <a:lnR w="9525" cap="flat" cmpd="sng" algn="ctr">
-                      <a:solidFill>
-                        <a:srgbClr val="D9D9D9"/>
-                      </a:solidFill>
-                      <a:prstDash val="solid"/>
-                      <a:round/>
-                      <a:headEnd type="none" w="med" len="med"/>
-                      <a:tailEnd type="none" w="med" len="med"/>
-                    </a:lnR>
-                    <a:lnT w="9525" cap="flat" cmpd="sng" algn="ctr">
-                      <a:solidFill>
-                        <a:srgbClr val="D9D9D9"/>
-                      </a:solidFill>
-                      <a:prstDash val="solid"/>
-                      <a:round/>
-                      <a:headEnd type="none" w="med" len="med"/>
-                      <a:tailEnd type="none" w="med" len="med"/>
-                    </a:lnT>
-                    <a:lnB w="9525" cap="flat" cmpd="sng" algn="ctr">
-                      <a:solidFill>
-                        <a:srgbClr val="D9D9D9"/>
-                      </a:solidFill>
-                      <a:prstDash val="solid"/>
-                      <a:round/>
-                      <a:headEnd type="none" w="med" len="med"/>
-                      <a:tailEnd type="none" w="med" len="med"/>
-                    </a:lnB>
-                    <a:solidFill>
-                      <a:srgbClr val="FFFFFF"/>
-                    </a:solidFill>
-                  </a:tcPr>
-                </a:tc>
-                <a:tc>
-                  <a:txBody>
-                    <a:bodyPr/>
-                    <a:lstStyle/>
-                    <a:p>
-                      <a:pPr algn="l" indent="0" marL="0">
-                        <a:buNone/>
-                      </a:pPr>
-                      <a:r>
-                        <a:rPr lang="en-US" sz="1050" dirty="0">
-                          <a:solidFill>
-                            <a:srgbClr val="000000"/>
-                          </a:solidFill>
-                          <a:latin typeface="Calibri" pitchFamily="34" charset="0"/>
-                          <a:ea typeface="Calibri" pitchFamily="34" charset="-122"/>
-                          <a:cs typeface="Calibri" pitchFamily="34" charset="-120"/>
-                        </a:rPr>
-                        <a:t>Geometry only; no defects, no memory</a:t>
-                      </a:r>
-                      <a:endParaRPr lang="en-US" sz="1050" dirty="0">
-                        <a:latin typeface="Calibri" charset="0"/>
-                        <a:ea typeface="Calibri" charset="0"/>
-                        <a:cs typeface="Calibri" charset="0"/>
-                      </a:endParaRPr>
-                    </a:p>
-                  </a:txBody>
-                  <a:tcPr marL="76200" marR="76200" marT="38100" marB="38100" anchor="ctr">
-                    <a:lnL w="9525" cap="flat" cmpd="sng" algn="ctr">
-                      <a:solidFill>
-                        <a:srgbClr val="D9D9D9"/>
-                      </a:solidFill>
-                      <a:prstDash val="solid"/>
-                      <a:round/>
-                      <a:headEnd type="none" w="med" len="med"/>
-                      <a:tailEnd type="none" w="med" len="med"/>
-                    </a:lnL>
-                    <a:lnR w="9525" cap="flat" cmpd="sng" algn="ctr">
-                      <a:solidFill>
-                        <a:srgbClr val="D9D9D9"/>
-                      </a:solidFill>
-                      <a:prstDash val="solid"/>
-                      <a:round/>
-                      <a:headEnd type="none" w="med" len="med"/>
-                      <a:tailEnd type="none" w="med" len="med"/>
-                    </a:lnR>
-                    <a:lnT w="9525" cap="flat" cmpd="sng" algn="ctr">
-                      <a:solidFill>
-                        <a:srgbClr val="D9D9D9"/>
-                      </a:solidFill>
-                      <a:prstDash val="solid"/>
-                      <a:round/>
-                      <a:headEnd type="none" w="med" len="med"/>
-                      <a:tailEnd type="none" w="med" len="med"/>
-                    </a:lnT>
-                    <a:lnB w="9525" cap="flat" cmpd="sng" algn="ctr">
-                      <a:solidFill>
-                        <a:srgbClr val="D9D9D9"/>
-                      </a:solidFill>
-                      <a:prstDash val="solid"/>
-                      <a:round/>
-                      <a:headEnd type="none" w="med" len="med"/>
-                      <a:tailEnd type="none" w="med" len="med"/>
-                    </a:lnB>
-                    <a:solidFill>
-                      <a:srgbClr val="FFFFFF"/>
-                    </a:solidFill>
-                  </a:tcPr>
-                </a:tc>
-              </a:tr>
-              <a:tr h="507492">
-                <a:tc>
-                  <a:txBody>
-                    <a:bodyPr/>
-                    <a:lstStyle/>
-                    <a:p>
-                      <a:pPr algn="l" indent="0" marL="0">
-                        <a:buNone/>
-                      </a:pPr>
-                      <a:r>
-                        <a:rPr lang="en-US" sz="1050" dirty="0">
-                          <a:solidFill>
-                            <a:srgbClr val="000000"/>
-                          </a:solidFill>
-                          <a:latin typeface="Calibri" pitchFamily="34" charset="0"/>
-                          <a:ea typeface="Calibri" pitchFamily="34" charset="-122"/>
-                          <a:cs typeface="Calibri" pitchFamily="34" charset="-120"/>
-                        </a:rPr>
                         <a:t>Dhami et al. (GATSBI), ICUAS 2023</a:t>
                       </a:r>
                       <a:endParaRPr lang="en-US" sz="1050" dirty="0">
@@ -9252,7 +8957,7 @@
                       <a:tailEnd type="none" w="med" len="med"/>
                     </a:lnB>
                     <a:solidFill>
-                      <a:srgbClr val="F3F3F3"/>
+                      <a:srgbClr val="FFFFFF"/>
                     </a:solidFill>
                   </a:tcPr>
                 </a:tc>
@@ -9320,7 +9025,7 @@
                       <a:tailEnd type="none" w="med" len="med"/>
                     </a:lnB>
                     <a:solidFill>
-                      <a:srgbClr val="F3F3F3"/>
+                      <a:srgbClr val="FFFFFF"/>
                     </a:solidFill>
                   </a:tcPr>
                 </a:tc>
@@ -9388,7 +9093,7 @@
                       <a:tailEnd type="none" w="med" len="med"/>
                     </a:lnB>
                     <a:solidFill>
-                      <a:srgbClr val="F3F3F3"/>
+                      <a:srgbClr val="FFFFFF"/>
                     </a:solidFill>
                   </a:tcPr>
                 </a:tc>
@@ -9456,7 +9161,7 @@
                       <a:tailEnd type="none" w="med" len="med"/>
                     </a:lnB>
                     <a:solidFill>
-                      <a:srgbClr val="F3F3F3"/>
+                      <a:srgbClr val="FFFFFF"/>
                     </a:solidFill>
                   </a:tcPr>
                 </a:tc>
@@ -9547,7 +9252,7 @@
                       <a:tailEnd type="none" w="med" len="med"/>
                     </a:lnB>
                     <a:solidFill>
-                      <a:srgbClr val="FFFFFF"/>
+                      <a:srgbClr val="F3F3F3"/>
                     </a:solidFill>
                   </a:tcPr>
                 </a:tc>
@@ -9615,7 +9320,7 @@
                       <a:tailEnd type="none" w="med" len="med"/>
                     </a:lnB>
                     <a:solidFill>
-                      <a:srgbClr val="FFFFFF"/>
+                      <a:srgbClr val="F3F3F3"/>
                     </a:solidFill>
                   </a:tcPr>
                 </a:tc>
@@ -9683,7 +9388,7 @@
                       <a:tailEnd type="none" w="med" len="med"/>
                     </a:lnB>
                     <a:solidFill>
-                      <a:srgbClr val="FFFFFF"/>
+                      <a:srgbClr val="F3F3F3"/>
                     </a:solidFill>
                   </a:tcPr>
                 </a:tc>
@@ -9751,7 +9456,7 @@
                       <a:tailEnd type="none" w="med" len="med"/>
                     </a:lnB>
                     <a:solidFill>
-                      <a:srgbClr val="FFFFFF"/>
+                      <a:srgbClr val="F3F3F3"/>
                     </a:solidFill>
                   </a:tcPr>
                 </a:tc>
@@ -9842,7 +9547,7 @@
                       <a:tailEnd type="none" w="med" len="med"/>
                     </a:lnB>
                     <a:solidFill>
-                      <a:srgbClr val="F3F3F3"/>
+                      <a:srgbClr val="FFFFFF"/>
                     </a:solidFill>
                   </a:tcPr>
                 </a:tc>
@@ -9910,7 +9615,7 @@
                       <a:tailEnd type="none" w="med" len="med"/>
                     </a:lnB>
                     <a:solidFill>
-                      <a:srgbClr val="F3F3F3"/>
+                      <a:srgbClr val="FFFFFF"/>
                     </a:solidFill>
                   </a:tcPr>
                 </a:tc>
@@ -9978,7 +9683,7 @@
                       <a:tailEnd type="none" w="med" len="med"/>
                     </a:lnB>
                     <a:solidFill>
-                      <a:srgbClr val="F3F3F3"/>
+                      <a:srgbClr val="FFFFFF"/>
                     </a:solidFill>
                   </a:tcPr>
                 </a:tc>
@@ -10046,7 +9751,7 @@
                       <a:tailEnd type="none" w="med" len="med"/>
                     </a:lnB>
                     <a:solidFill>
-                      <a:srgbClr val="F3F3F3"/>
+                      <a:srgbClr val="FFFFFF"/>
                     </a:solidFill>
                   </a:tcPr>
                 </a:tc>
@@ -10137,7 +9842,7 @@
                       <a:tailEnd type="none" w="med" len="med"/>
                     </a:lnB>
                     <a:solidFill>
-                      <a:srgbClr val="FFFFFF"/>
+                      <a:srgbClr val="F3F3F3"/>
                     </a:solidFill>
                   </a:tcPr>
                 </a:tc>
@@ -10205,7 +9910,7 @@
                       <a:tailEnd type="none" w="med" len="med"/>
                     </a:lnB>
                     <a:solidFill>
-                      <a:srgbClr val="FFFFFF"/>
+                      <a:srgbClr val="F3F3F3"/>
                     </a:solidFill>
                   </a:tcPr>
                 </a:tc>
@@ -10273,7 +9978,7 @@
                       <a:tailEnd type="none" w="med" len="med"/>
                     </a:lnB>
                     <a:solidFill>
-                      <a:srgbClr val="FFFFFF"/>
+                      <a:srgbClr val="F3F3F3"/>
                     </a:solidFill>
                   </a:tcPr>
                 </a:tc>
@@ -10341,7 +10046,7 @@
                       <a:tailEnd type="none" w="med" len="med"/>
                     </a:lnB>
                     <a:solidFill>
-                      <a:srgbClr val="FFFFFF"/>
+                      <a:srgbClr val="F3F3F3"/>
                     </a:solidFill>
                   </a:tcPr>
                 </a:tc>
@@ -10432,7 +10137,7 @@
                       <a:tailEnd type="none" w="med" len="med"/>
                     </a:lnB>
                     <a:solidFill>
-                      <a:srgbClr val="F3F3F3"/>
+                      <a:srgbClr val="FFFFFF"/>
                     </a:solidFill>
                   </a:tcPr>
                 </a:tc>
@@ -10500,7 +10205,7 @@
                       <a:tailEnd type="none" w="med" len="med"/>
                     </a:lnB>
                     <a:solidFill>
-                      <a:srgbClr val="F3F3F3"/>
+                      <a:srgbClr val="FFFFFF"/>
                     </a:solidFill>
                   </a:tcPr>
                 </a:tc>
@@ -10568,7 +10273,7 @@
                       <a:tailEnd type="none" w="med" len="med"/>
                     </a:lnB>
                     <a:solidFill>
-                      <a:srgbClr val="F3F3F3"/>
+                      <a:srgbClr val="FFFFFF"/>
                     </a:solidFill>
                   </a:tcPr>
                 </a:tc>
@@ -10636,7 +10341,7 @@
                       <a:tailEnd type="none" w="med" len="med"/>
                     </a:lnB>
                     <a:solidFill>
-                      <a:srgbClr val="F3F3F3"/>
+                      <a:srgbClr val="FFFFFF"/>
                     </a:solidFill>
                   </a:tcPr>
                 </a:tc>
@@ -10727,7 +10432,7 @@
                       <a:tailEnd type="none" w="med" len="med"/>
                     </a:lnB>
                     <a:solidFill>
-                      <a:srgbClr val="FFFFFF"/>
+                      <a:srgbClr val="F3F3F3"/>
                     </a:solidFill>
                   </a:tcPr>
                 </a:tc>
@@ -10795,7 +10500,7 @@
                       <a:tailEnd type="none" w="med" len="med"/>
                     </a:lnB>
                     <a:solidFill>
-                      <a:srgbClr val="FFFFFF"/>
+                      <a:srgbClr val="F3F3F3"/>
                     </a:solidFill>
                   </a:tcPr>
                 </a:tc>
@@ -10863,7 +10568,7 @@
                       <a:tailEnd type="none" w="med" len="med"/>
                     </a:lnB>
                     <a:solidFill>
-                      <a:srgbClr val="FFFFFF"/>
+                      <a:srgbClr val="F3F3F3"/>
                     </a:solidFill>
                   </a:tcPr>
                 </a:tc>
@@ -10931,7 +10636,7 @@
                       <a:tailEnd type="none" w="med" len="med"/>
                     </a:lnB>
                     <a:solidFill>
-                      <a:srgbClr val="FFFFFF"/>
+                      <a:srgbClr val="F3F3F3"/>
                     </a:solidFill>
                   </a:tcPr>
                 </a:tc>
@@ -11022,7 +10727,7 @@
                       <a:tailEnd type="none" w="med" len="med"/>
                     </a:lnB>
                     <a:solidFill>
-                      <a:srgbClr val="F3F3F3"/>
+                      <a:srgbClr val="FFFFFF"/>
                     </a:solidFill>
                   </a:tcPr>
                 </a:tc>
@@ -11090,7 +10795,7 @@
                       <a:tailEnd type="none" w="med" len="med"/>
                     </a:lnB>
                     <a:solidFill>
-                      <a:srgbClr val="F3F3F3"/>
+                      <a:srgbClr val="FFFFFF"/>
                     </a:solidFill>
                   </a:tcPr>
                 </a:tc>
@@ -11158,7 +10863,7 @@
                       <a:tailEnd type="none" w="med" len="med"/>
                     </a:lnB>
                     <a:solidFill>
-                      <a:srgbClr val="F3F3F3"/>
+                      <a:srgbClr val="FFFFFF"/>
                     </a:solidFill>
                   </a:tcPr>
                 </a:tc>
@@ -11226,7 +10931,7 @@
                       <a:tailEnd type="none" w="med" len="med"/>
                     </a:lnB>
                     <a:solidFill>
-                      <a:srgbClr val="F3F3F3"/>
+                      <a:srgbClr val="FFFFFF"/>
                     </a:solidFill>
                   </a:tcPr>
                 </a:tc>
@@ -11317,7 +11022,7 @@
                       <a:tailEnd type="none" w="med" len="med"/>
                     </a:lnB>
                     <a:solidFill>
-                      <a:srgbClr val="FFFFFF"/>
+                      <a:srgbClr val="F3F3F3"/>
                     </a:solidFill>
                   </a:tcPr>
                 </a:tc>
@@ -11385,7 +11090,7 @@
                       <a:tailEnd type="none" w="med" len="med"/>
                     </a:lnB>
                     <a:solidFill>
-                      <a:srgbClr val="FFFFFF"/>
+                      <a:srgbClr val="F3F3F3"/>
                     </a:solidFill>
                   </a:tcPr>
                 </a:tc>
@@ -11453,7 +11158,7 @@
                       <a:tailEnd type="none" w="med" len="med"/>
                     </a:lnB>
                     <a:solidFill>
-                      <a:srgbClr val="FFFFFF"/>
+                      <a:srgbClr val="F3F3F3"/>
                     </a:solidFill>
                   </a:tcPr>
                 </a:tc>
@@ -11521,7 +11226,7 @@
                       <a:tailEnd type="none" w="med" len="med"/>
                     </a:lnB>
                     <a:solidFill>
-                      <a:srgbClr val="FFFFFF"/>
+                      <a:srgbClr val="F3F3F3"/>
                     </a:solidFill>
                   </a:tcPr>
                 </a:tc>
@@ -11968,7 +11673,7 @@
                 <a:ea typeface="Calibri" pitchFamily="34" charset="-122"/>
                 <a:cs typeface="Calibri" pitchFamily="34" charset="-120"/>
               </a:rPr>
-              <a:t>every wall is seen once before anything else; fixes a recall ceiling shared by the base paper.</a:t>
+              <a:t>every wall is seen once before anything else; fixes the recall ceiling of cost-normalised greedy planners.</a:t>
             </a:r>
             <a:endParaRPr lang="en-US" sz="1400" dirty="0"/>
           </a:p>
@@ -12769,7 +12474,7 @@
                           <a:ea typeface="Calibri" pitchFamily="34" charset="-122"/>
                           <a:cs typeface="Calibri" pitchFamily="34" charset="-120"/>
                         </a:rPr>
-                        <a:t>The base paper's score never pays to fly to the far building -- it stopped at 4 of 9 walls on every seed.</a:t>
+                        <a:t>A plain information-gain score never pays to fly to the far building -- it stopped at 4 of 9 walls on every seed.</a:t>
                       </a:r>
                       <a:endParaRPr lang="en-US" sz="1050" dirty="0">
                         <a:latin typeface="Calibri" charset="0"/>
@@ -14022,7 +13727,7 @@
                 <a:ea typeface="Calibri" pitchFamily="34" charset="-122"/>
                 <a:cs typeface="Calibri" pitchFamily="34" charset="-120"/>
               </a:rPr>
-              <a:t>Setting all new weights to zero and switching off the coverage phase and lookahead gives back the base paper (Isler et al. 2016) exactly -- so every gain is measured against it, not against a different algorithm.</a:t>
+              <a:t>Setting all new weights to zero and switching off the coverage phase and lookahead gives back a plain cost-normalised information-gain planner exactly -- so every gain is measured against it, not against a different algorithm.</a:t>
             </a:r>
             <a:endParaRPr lang="en-US" sz="1100" dirty="0"/>
           </a:p>

</xml_diff>

<commit_message>
Deck and RESULTS: scale-up, multi-dataset detector study
Co-Authored-By: Claude Sonnet 5.5 <noreply@anthropic.com>
</commit_message>
<xml_diff>
--- a/drone-sim-today/Autonomous_Drone_Inspection_Progress.pptx
+++ b/drone-sim-today/Autonomous_Drone_Inspection_Progress.pptx
@@ -16,9 +16,10 @@
     <p:sldId id="264" r:id="rId10"/>
     <p:sldId id="265" r:id="rId11"/>
     <p:sldId id="266" r:id="rId12"/>
+    <p:sldId id="267" r:id="rId13"/>
   </p:sldIdLst>
   <p:notesMasterIdLst>
-    <p:notesMasterId r:id="rId13"/>
+    <p:notesMasterId r:id="rId14"/>
   </p:notesMasterIdLst>
   <p:sldSz cx="12192000" cy="6858000"/>
   <p:notesSz cx="6858000" cy="12192000"/>
@@ -712,6 +713,94 @@
             <a:fld id="{F7021451-1387-4CA6-816F-3879F97B5CBC}" type="slidenum">
               <a:rPr lang="en-US"/>
               <a:t>11</a:t>
+            </a:fld>
+            <a:endParaRPr lang="en-US"/>
+          </a:p>
+        </p:txBody>
+      </p:sp>
+    </p:spTree>
+    <p:extLst>
+      <p:ext uri="{BB962C8B-B14F-4D97-AF65-F5344CB8AC3E}">
+        <p14:creationId xmlns:p14="http://schemas.microsoft.com/office/powerpoint/2010/main" val="1024086991"/>
+      </p:ext>
+    </p:extLst>
+  </p:cSld>
+  <p:clrMapOvr>
+    <a:masterClrMapping/>
+  </p:clrMapOvr>
+</p:notes>
+</file>
+
+<file path=ppt/notesSlides/notesSlide12.xml><?xml version="1.0" encoding="utf-8"?>
+<p:notes xmlns:a="http://schemas.openxmlformats.org/drawingml/2006/main" xmlns:r="http://schemas.openxmlformats.org/officeDocument/2006/relationships" xmlns:p="http://schemas.openxmlformats.org/presentationml/2006/main">
+  <p:cSld>
+    <p:spTree>
+      <p:nvGrpSpPr>
+        <p:cNvPr id="1" name=""/>
+        <p:cNvGrpSpPr/>
+        <p:nvPr/>
+      </p:nvGrpSpPr>
+      <p:grpSpPr>
+        <a:xfrm>
+          <a:off x="0" y="0"/>
+          <a:ext cx="0" cy="0"/>
+          <a:chOff x="0" y="0"/>
+          <a:chExt cx="0" cy="0"/>
+        </a:xfrm>
+      </p:grpSpPr>
+      <p:sp>
+        <p:nvSpPr>
+          <p:cNvPr id="2" name="Slide Image Placeholder 1"/>
+          <p:cNvSpPr>
+            <a:spLocks noGrp="1" noRot="1" noChangeAspect="1"/>
+          </p:cNvSpPr>
+          <p:nvPr>
+            <p:ph type="sldImg"/>
+          </p:nvPr>
+        </p:nvSpPr>
+        <p:spPr/>
+      </p:sp>
+      <p:sp>
+        <p:nvSpPr>
+          <p:cNvPr id="3" name="Notes Placeholder 2"/>
+          <p:cNvSpPr>
+            <a:spLocks noGrp="1"/>
+          </p:cNvSpPr>
+          <p:nvPr>
+            <p:ph type="body" idx="1"/>
+          </p:nvPr>
+        </p:nvSpPr>
+        <p:spPr/>
+        <p:txBody>
+          <a:bodyPr/>
+          <a:lstStyle/>
+          <a:p>
+            <a:r>
+              <a:rPr lang="en-US" dirty="0"/>
+              <a:t/>
+            </a:r>
+            <a:endParaRPr lang="en-US" dirty="0"/>
+          </a:p>
+        </p:txBody>
+      </p:sp>
+      <p:sp>
+        <p:nvSpPr>
+          <p:cNvPr id="4" name="Slide Number Placeholder 3"/>
+          <p:cNvSpPr>
+            <a:spLocks noGrp="1"/>
+          </p:cNvSpPr>
+          <p:nvPr>
+            <p:ph type="sldNum" sz="quarter" idx="10"/>
+          </p:nvPr>
+        </p:nvSpPr>
+        <p:spPr/>
+        <p:txBody>
+          <a:bodyPr/>
+          <a:lstStyle/>
+          <a:p>
+            <a:fld id="{F7021451-1387-4CA6-816F-3879F97B5CBC}" type="slidenum">
+              <a:rPr lang="en-US"/>
+              <a:t>12</a:t>
             </a:fld>
             <a:endParaRPr lang="en-US"/>
           </a:p>
@@ -6772,6 +6861,3698 @@
                 <a:ea typeface="Cambria" pitchFamily="34" charset="-122"/>
                 <a:cs typeface="Cambria" pitchFamily="34" charset="-120"/>
               </a:rPr>
+              <a:t>Scale-up: 31-Wall Yard &amp; Statistics</a:t>
+            </a:r>
+            <a:endParaRPr lang="en-US" sz="2600" dirty="0"/>
+          </a:p>
+        </p:txBody>
+      </p:sp>
+      <p:sp>
+        <p:nvSpPr>
+          <p:cNvPr id="3" name="Text 3"/>
+          <p:cNvSpPr/>
+          <p:nvPr>
+            <p:ph idx="104" type="body" hasCustomPrompt="1"/>
+          </p:nvPr>
+        </p:nvSpPr>
+        <p:spPr>
+          <a:xfrm>
+            <a:off x="11091672" y="6446520"/>
+            <a:ext cx="548640" cy="274320"/>
+          </a:xfrm>
+          <a:prstGeom prst="rect">
+            <a:avLst/>
+          </a:prstGeom>
+          <a:noFill/>
+          <a:ln/>
+        </p:spPr>
+        <p:txBody>
+          <a:bodyPr wrap="square" lIns="0" tIns="0" rIns="0" bIns="0" rtlCol="0" anchor="t"/>
+          <a:lstStyle/>
+          <a:p>
+            <a:pPr algn="r" indent="0" marL="0">
+              <a:buNone/>
+            </a:pPr>
+            <a:r>
+              <a:rPr lang="en-US" sz="900" dirty="0">
+                <a:solidFill>
+                  <a:srgbClr val="808080"/>
+                </a:solidFill>
+                <a:latin typeface="Calibri" pitchFamily="34" charset="0"/>
+                <a:ea typeface="Calibri" pitchFamily="34" charset="-122"/>
+                <a:cs typeface="Calibri" pitchFamily="34" charset="-120"/>
+              </a:rPr>
+              <a:t>11</a:t>
+            </a:r>
+            <a:endParaRPr lang="en-US" sz="900" dirty="0"/>
+          </a:p>
+        </p:txBody>
+      </p:sp>
+      <p:sp>
+        <p:nvSpPr>
+          <p:cNvPr id="4" name="Text 2"/>
+          <p:cNvSpPr txBox="1"/>
+          <p:nvPr/>
+        </p:nvSpPr>
+        <p:spPr>
+          <a:xfrm>
+            <a:off x="548640" y="1188720"/>
+            <a:ext cx="11091672" cy="502920"/>
+          </a:xfrm>
+          <a:prstGeom prst="rect">
+            <a:avLst/>
+          </a:prstGeom>
+          <a:noFill/>
+          <a:ln/>
+        </p:spPr>
+        <p:txBody>
+          <a:bodyPr wrap="square" lIns="0" tIns="0" rIns="0" bIns="0" rtlCol="0" anchor="t"/>
+          <a:lstStyle/>
+          <a:p>
+            <a:pPr indent="0" marL="0">
+              <a:buNone/>
+            </a:pPr>
+            <a:r>
+              <a:rPr lang="en-US" sz="1300" dirty="0">
+                <a:solidFill>
+                  <a:srgbClr val="404040"/>
+                </a:solidFill>
+                <a:latin typeface="Calibri" pitchFamily="34" charset="0"/>
+                <a:ea typeface="Calibri" pitchFamily="34" charset="-122"/>
+                <a:cs typeface="Calibri" pitchFamily="34" charset="-120"/>
+              </a:rPr>
+              <a:t>Yard enlarged from 9 to 31 walls (186 viewpoints, budget 50). Same test seeds 0-4, 3 scored scenarios; F1 interval = 95% bootstrap over seeds.</a:t>
+            </a:r>
+            <a:endParaRPr lang="en-US" sz="1300" dirty="0"/>
+          </a:p>
+        </p:txBody>
+      </p:sp>
+      <p:graphicFrame>
+        <p:nvGraphicFramePr>
+          <p:cNvPr id="12" name="Table 0"/>
+          <p:cNvGraphicFramePr>
+            <a:graphicFrameLocks noGrp="1"/>
+          </p:cNvGraphicFramePr>
+          <p:nvPr>
+            <p:extLst>
+              <p:ext uri="{D42A27DB-BD31-4B8C-83A1-F6EECF244321}">
+                <p14:modId xmlns:p14="http://schemas.microsoft.com/office/powerpoint/2010/main" val="1579011935"/>
+              </p:ext>
+            </p:extLst>
+          </p:nvPr>
+        </p:nvGraphicFramePr>
+        <p:xfrm>
+          <a:off x="548640" y="1783080"/>
+          <a:ext cx="7040880" cy="914400"/>
+        </p:xfrm>
+        <a:graphic>
+          <a:graphicData uri="http://schemas.openxmlformats.org/drawingml/2006/table">
+            <a:tbl>
+              <a:tblPr/>
+              <a:tblGrid>
+                <a:gridCol w="2011680"/>
+                <a:gridCol w="1143000"/>
+                <a:gridCol w="1234440"/>
+                <a:gridCol w="914400"/>
+                <a:gridCol w="868680"/>
+                <a:gridCol w="868680"/>
+              </a:tblGrid>
+              <a:tr h="384048">
+                <a:tc>
+                  <a:txBody>
+                    <a:bodyPr/>
+                    <a:lstStyle/>
+                    <a:p>
+                      <a:pPr algn="l" indent="0" marL="0">
+                        <a:buNone/>
+                      </a:pPr>
+                      <a:r>
+                        <a:rPr lang="en-US" sz="1200" b="1" dirty="0">
+                          <a:solidFill>
+                            <a:srgbClr val="FFFFFF"/>
+                          </a:solidFill>
+                          <a:latin typeface="Calibri" pitchFamily="34" charset="0"/>
+                          <a:ea typeface="Calibri" pitchFamily="34" charset="-122"/>
+                          <a:cs typeface="Calibri" pitchFamily="34" charset="-120"/>
+                        </a:rPr>
+                        <a:t>Planner</a:t>
+                      </a:r>
+                      <a:endParaRPr lang="en-US" sz="1200" dirty="0">
+                        <a:latin typeface="Calibri" charset="0"/>
+                        <a:ea typeface="Calibri" charset="0"/>
+                        <a:cs typeface="Calibri" charset="0"/>
+                      </a:endParaRPr>
+                    </a:p>
+                  </a:txBody>
+                  <a:tcPr marL="76200" marR="76200" marT="38100" marB="38100" anchor="ctr">
+                    <a:lnL w="9525" cap="flat" cmpd="sng" algn="ctr">
+                      <a:solidFill>
+                        <a:srgbClr val="D9D9D9"/>
+                      </a:solidFill>
+                      <a:prstDash val="solid"/>
+                      <a:round/>
+                      <a:headEnd type="none" w="med" len="med"/>
+                      <a:tailEnd type="none" w="med" len="med"/>
+                    </a:lnL>
+                    <a:lnR w="9525" cap="flat" cmpd="sng" algn="ctr">
+                      <a:solidFill>
+                        <a:srgbClr val="D9D9D9"/>
+                      </a:solidFill>
+                      <a:prstDash val="solid"/>
+                      <a:round/>
+                      <a:headEnd type="none" w="med" len="med"/>
+                      <a:tailEnd type="none" w="med" len="med"/>
+                    </a:lnR>
+                    <a:lnT w="9525" cap="flat" cmpd="sng" algn="ctr">
+                      <a:solidFill>
+                        <a:srgbClr val="D9D9D9"/>
+                      </a:solidFill>
+                      <a:prstDash val="solid"/>
+                      <a:round/>
+                      <a:headEnd type="none" w="med" len="med"/>
+                      <a:tailEnd type="none" w="med" len="med"/>
+                    </a:lnT>
+                    <a:lnB w="9525" cap="flat" cmpd="sng" algn="ctr">
+                      <a:solidFill>
+                        <a:srgbClr val="D9D9D9"/>
+                      </a:solidFill>
+                      <a:prstDash val="solid"/>
+                      <a:round/>
+                      <a:headEnd type="none" w="med" len="med"/>
+                      <a:tailEnd type="none" w="med" len="med"/>
+                    </a:lnB>
+                    <a:solidFill>
+                      <a:srgbClr val="000000"/>
+                    </a:solidFill>
+                  </a:tcPr>
+                </a:tc>
+                <a:tc>
+                  <a:txBody>
+                    <a:bodyPr/>
+                    <a:lstStyle/>
+                    <a:p>
+                      <a:pPr algn="ctr" indent="0" marL="0">
+                        <a:buNone/>
+                      </a:pPr>
+                      <a:r>
+                        <a:rPr lang="en-US" sz="1200" b="1" dirty="0">
+                          <a:solidFill>
+                            <a:srgbClr val="FFFFFF"/>
+                          </a:solidFill>
+                          <a:latin typeface="Calibri" pitchFamily="34" charset="0"/>
+                          <a:ea typeface="Calibri" pitchFamily="34" charset="-122"/>
+                          <a:cs typeface="Calibri" pitchFamily="34" charset="-120"/>
+                        </a:rPr>
+                        <a:t>F1 (31 walls)</a:t>
+                      </a:r>
+                      <a:endParaRPr lang="en-US" sz="1200" dirty="0">
+                        <a:latin typeface="Calibri" charset="0"/>
+                        <a:ea typeface="Calibri" charset="0"/>
+                        <a:cs typeface="Calibri" charset="0"/>
+                      </a:endParaRPr>
+                    </a:p>
+                  </a:txBody>
+                  <a:tcPr marL="76200" marR="76200" marT="38100" marB="38100" anchor="ctr">
+                    <a:lnL w="9525" cap="flat" cmpd="sng" algn="ctr">
+                      <a:solidFill>
+                        <a:srgbClr val="D9D9D9"/>
+                      </a:solidFill>
+                      <a:prstDash val="solid"/>
+                      <a:round/>
+                      <a:headEnd type="none" w="med" len="med"/>
+                      <a:tailEnd type="none" w="med" len="med"/>
+                    </a:lnL>
+                    <a:lnR w="9525" cap="flat" cmpd="sng" algn="ctr">
+                      <a:solidFill>
+                        <a:srgbClr val="D9D9D9"/>
+                      </a:solidFill>
+                      <a:prstDash val="solid"/>
+                      <a:round/>
+                      <a:headEnd type="none" w="med" len="med"/>
+                      <a:tailEnd type="none" w="med" len="med"/>
+                    </a:lnR>
+                    <a:lnT w="9525" cap="flat" cmpd="sng" algn="ctr">
+                      <a:solidFill>
+                        <a:srgbClr val="D9D9D9"/>
+                      </a:solidFill>
+                      <a:prstDash val="solid"/>
+                      <a:round/>
+                      <a:headEnd type="none" w="med" len="med"/>
+                      <a:tailEnd type="none" w="med" len="med"/>
+                    </a:lnT>
+                    <a:lnB w="9525" cap="flat" cmpd="sng" algn="ctr">
+                      <a:solidFill>
+                        <a:srgbClr val="D9D9D9"/>
+                      </a:solidFill>
+                      <a:prstDash val="solid"/>
+                      <a:round/>
+                      <a:headEnd type="none" w="med" len="med"/>
+                      <a:tailEnd type="none" w="med" len="med"/>
+                    </a:lnB>
+                    <a:solidFill>
+                      <a:srgbClr val="000000"/>
+                    </a:solidFill>
+                  </a:tcPr>
+                </a:tc>
+                <a:tc>
+                  <a:txBody>
+                    <a:bodyPr/>
+                    <a:lstStyle/>
+                    <a:p>
+                      <a:pPr algn="ctr" indent="0" marL="0">
+                        <a:buNone/>
+                      </a:pPr>
+                      <a:r>
+                        <a:rPr lang="en-US" sz="1200" b="1" dirty="0">
+                          <a:solidFill>
+                            <a:srgbClr val="FFFFFF"/>
+                          </a:solidFill>
+                          <a:latin typeface="Calibri" pitchFamily="34" charset="0"/>
+                          <a:ea typeface="Calibri" pitchFamily="34" charset="-122"/>
+                          <a:cs typeface="Calibri" pitchFamily="34" charset="-120"/>
+                        </a:rPr>
+                        <a:t>95% CI</a:t>
+                      </a:r>
+                      <a:endParaRPr lang="en-US" sz="1200" dirty="0">
+                        <a:latin typeface="Calibri" charset="0"/>
+                        <a:ea typeface="Calibri" charset="0"/>
+                        <a:cs typeface="Calibri" charset="0"/>
+                      </a:endParaRPr>
+                    </a:p>
+                  </a:txBody>
+                  <a:tcPr marL="76200" marR="76200" marT="38100" marB="38100" anchor="ctr">
+                    <a:lnL w="9525" cap="flat" cmpd="sng" algn="ctr">
+                      <a:solidFill>
+                        <a:srgbClr val="D9D9D9"/>
+                      </a:solidFill>
+                      <a:prstDash val="solid"/>
+                      <a:round/>
+                      <a:headEnd type="none" w="med" len="med"/>
+                      <a:tailEnd type="none" w="med" len="med"/>
+                    </a:lnL>
+                    <a:lnR w="9525" cap="flat" cmpd="sng" algn="ctr">
+                      <a:solidFill>
+                        <a:srgbClr val="D9D9D9"/>
+                      </a:solidFill>
+                      <a:prstDash val="solid"/>
+                      <a:round/>
+                      <a:headEnd type="none" w="med" len="med"/>
+                      <a:tailEnd type="none" w="med" len="med"/>
+                    </a:lnR>
+                    <a:lnT w="9525" cap="flat" cmpd="sng" algn="ctr">
+                      <a:solidFill>
+                        <a:srgbClr val="D9D9D9"/>
+                      </a:solidFill>
+                      <a:prstDash val="solid"/>
+                      <a:round/>
+                      <a:headEnd type="none" w="med" len="med"/>
+                      <a:tailEnd type="none" w="med" len="med"/>
+                    </a:lnT>
+                    <a:lnB w="9525" cap="flat" cmpd="sng" algn="ctr">
+                      <a:solidFill>
+                        <a:srgbClr val="D9D9D9"/>
+                      </a:solidFill>
+                      <a:prstDash val="solid"/>
+                      <a:round/>
+                      <a:headEnd type="none" w="med" len="med"/>
+                      <a:tailEnd type="none" w="med" len="med"/>
+                    </a:lnB>
+                    <a:solidFill>
+                      <a:srgbClr val="000000"/>
+                    </a:solidFill>
+                  </a:tcPr>
+                </a:tc>
+                <a:tc>
+                  <a:txBody>
+                    <a:bodyPr/>
+                    <a:lstStyle/>
+                    <a:p>
+                      <a:pPr algn="ctr" indent="0" marL="0">
+                        <a:buNone/>
+                      </a:pPr>
+                      <a:r>
+                        <a:rPr lang="en-US" sz="1200" b="1" dirty="0">
+                          <a:solidFill>
+                            <a:srgbClr val="FFFFFF"/>
+                          </a:solidFill>
+                          <a:latin typeface="Calibri" pitchFamily="34" charset="0"/>
+                          <a:ea typeface="Calibri" pitchFamily="34" charset="-122"/>
+                          <a:cs typeface="Calibri" pitchFamily="34" charset="-120"/>
+                        </a:rPr>
+                        <a:t>Flight (m)</a:t>
+                      </a:r>
+                      <a:endParaRPr lang="en-US" sz="1200" dirty="0">
+                        <a:latin typeface="Calibri" charset="0"/>
+                        <a:ea typeface="Calibri" charset="0"/>
+                        <a:cs typeface="Calibri" charset="0"/>
+                      </a:endParaRPr>
+                    </a:p>
+                  </a:txBody>
+                  <a:tcPr marL="76200" marR="76200" marT="38100" marB="38100" anchor="ctr">
+                    <a:lnL w="9525" cap="flat" cmpd="sng" algn="ctr">
+                      <a:solidFill>
+                        <a:srgbClr val="D9D9D9"/>
+                      </a:solidFill>
+                      <a:prstDash val="solid"/>
+                      <a:round/>
+                      <a:headEnd type="none" w="med" len="med"/>
+                      <a:tailEnd type="none" w="med" len="med"/>
+                    </a:lnL>
+                    <a:lnR w="9525" cap="flat" cmpd="sng" algn="ctr">
+                      <a:solidFill>
+                        <a:srgbClr val="D9D9D9"/>
+                      </a:solidFill>
+                      <a:prstDash val="solid"/>
+                      <a:round/>
+                      <a:headEnd type="none" w="med" len="med"/>
+                      <a:tailEnd type="none" w="med" len="med"/>
+                    </a:lnR>
+                    <a:lnT w="9525" cap="flat" cmpd="sng" algn="ctr">
+                      <a:solidFill>
+                        <a:srgbClr val="D9D9D9"/>
+                      </a:solidFill>
+                      <a:prstDash val="solid"/>
+                      <a:round/>
+                      <a:headEnd type="none" w="med" len="med"/>
+                      <a:tailEnd type="none" w="med" len="med"/>
+                    </a:lnT>
+                    <a:lnB w="9525" cap="flat" cmpd="sng" algn="ctr">
+                      <a:solidFill>
+                        <a:srgbClr val="D9D9D9"/>
+                      </a:solidFill>
+                      <a:prstDash val="solid"/>
+                      <a:round/>
+                      <a:headEnd type="none" w="med" len="med"/>
+                      <a:tailEnd type="none" w="med" len="med"/>
+                    </a:lnB>
+                    <a:solidFill>
+                      <a:srgbClr val="000000"/>
+                    </a:solidFill>
+                  </a:tcPr>
+                </a:tc>
+                <a:tc>
+                  <a:txBody>
+                    <a:bodyPr/>
+                    <a:lstStyle/>
+                    <a:p>
+                      <a:pPr algn="ctr" indent="0" marL="0">
+                        <a:buNone/>
+                      </a:pPr>
+                      <a:r>
+                        <a:rPr lang="en-US" sz="1200" b="1" dirty="0">
+                          <a:solidFill>
+                            <a:srgbClr val="FFFFFF"/>
+                          </a:solidFill>
+                          <a:latin typeface="Calibri" pitchFamily="34" charset="0"/>
+                          <a:ea typeface="Calibri" pitchFamily="34" charset="-122"/>
+                          <a:cs typeface="Calibri" pitchFamily="34" charset="-120"/>
+                        </a:rPr>
+                        <a:t>Coverage</a:t>
+                      </a:r>
+                      <a:endParaRPr lang="en-US" sz="1200" dirty="0">
+                        <a:latin typeface="Calibri" charset="0"/>
+                        <a:ea typeface="Calibri" charset="0"/>
+                        <a:cs typeface="Calibri" charset="0"/>
+                      </a:endParaRPr>
+                    </a:p>
+                  </a:txBody>
+                  <a:tcPr marL="76200" marR="76200" marT="38100" marB="38100" anchor="ctr">
+                    <a:lnL w="9525" cap="flat" cmpd="sng" algn="ctr">
+                      <a:solidFill>
+                        <a:srgbClr val="D9D9D9"/>
+                      </a:solidFill>
+                      <a:prstDash val="solid"/>
+                      <a:round/>
+                      <a:headEnd type="none" w="med" len="med"/>
+                      <a:tailEnd type="none" w="med" len="med"/>
+                    </a:lnL>
+                    <a:lnR w="9525" cap="flat" cmpd="sng" algn="ctr">
+                      <a:solidFill>
+                        <a:srgbClr val="D9D9D9"/>
+                      </a:solidFill>
+                      <a:prstDash val="solid"/>
+                      <a:round/>
+                      <a:headEnd type="none" w="med" len="med"/>
+                      <a:tailEnd type="none" w="med" len="med"/>
+                    </a:lnR>
+                    <a:lnT w="9525" cap="flat" cmpd="sng" algn="ctr">
+                      <a:solidFill>
+                        <a:srgbClr val="D9D9D9"/>
+                      </a:solidFill>
+                      <a:prstDash val="solid"/>
+                      <a:round/>
+                      <a:headEnd type="none" w="med" len="med"/>
+                      <a:tailEnd type="none" w="med" len="med"/>
+                    </a:lnT>
+                    <a:lnB w="9525" cap="flat" cmpd="sng" algn="ctr">
+                      <a:solidFill>
+                        <a:srgbClr val="D9D9D9"/>
+                      </a:solidFill>
+                      <a:prstDash val="solid"/>
+                      <a:round/>
+                      <a:headEnd type="none" w="med" len="med"/>
+                      <a:tailEnd type="none" w="med" len="med"/>
+                    </a:lnB>
+                    <a:solidFill>
+                      <a:srgbClr val="000000"/>
+                    </a:solidFill>
+                  </a:tcPr>
+                </a:tc>
+                <a:tc>
+                  <a:txBody>
+                    <a:bodyPr/>
+                    <a:lstStyle/>
+                    <a:p>
+                      <a:pPr algn="ctr" indent="0" marL="0">
+                        <a:buNone/>
+                      </a:pPr>
+                      <a:r>
+                        <a:rPr lang="en-US" sz="1200" b="1" dirty="0">
+                          <a:solidFill>
+                            <a:srgbClr val="FFFFFF"/>
+                          </a:solidFill>
+                          <a:latin typeface="Calibri" pitchFamily="34" charset="0"/>
+                          <a:ea typeface="Calibri" pitchFamily="34" charset="-122"/>
+                          <a:cs typeface="Calibri" pitchFamily="34" charset="-120"/>
+                        </a:rPr>
+                        <a:t>F1 (9 walls)</a:t>
+                      </a:r>
+                      <a:endParaRPr lang="en-US" sz="1200" dirty="0">
+                        <a:latin typeface="Calibri" charset="0"/>
+                        <a:ea typeface="Calibri" charset="0"/>
+                        <a:cs typeface="Calibri" charset="0"/>
+                      </a:endParaRPr>
+                    </a:p>
+                  </a:txBody>
+                  <a:tcPr marL="76200" marR="76200" marT="38100" marB="38100" anchor="ctr">
+                    <a:lnL w="9525" cap="flat" cmpd="sng" algn="ctr">
+                      <a:solidFill>
+                        <a:srgbClr val="D9D9D9"/>
+                      </a:solidFill>
+                      <a:prstDash val="solid"/>
+                      <a:round/>
+                      <a:headEnd type="none" w="med" len="med"/>
+                      <a:tailEnd type="none" w="med" len="med"/>
+                    </a:lnL>
+                    <a:lnR w="9525" cap="flat" cmpd="sng" algn="ctr">
+                      <a:solidFill>
+                        <a:srgbClr val="D9D9D9"/>
+                      </a:solidFill>
+                      <a:prstDash val="solid"/>
+                      <a:round/>
+                      <a:headEnd type="none" w="med" len="med"/>
+                      <a:tailEnd type="none" w="med" len="med"/>
+                    </a:lnR>
+                    <a:lnT w="9525" cap="flat" cmpd="sng" algn="ctr">
+                      <a:solidFill>
+                        <a:srgbClr val="D9D9D9"/>
+                      </a:solidFill>
+                      <a:prstDash val="solid"/>
+                      <a:round/>
+                      <a:headEnd type="none" w="med" len="med"/>
+                      <a:tailEnd type="none" w="med" len="med"/>
+                    </a:lnT>
+                    <a:lnB w="9525" cap="flat" cmpd="sng" algn="ctr">
+                      <a:solidFill>
+                        <a:srgbClr val="D9D9D9"/>
+                      </a:solidFill>
+                      <a:prstDash val="solid"/>
+                      <a:round/>
+                      <a:headEnd type="none" w="med" len="med"/>
+                      <a:tailEnd type="none" w="med" len="med"/>
+                    </a:lnB>
+                    <a:solidFill>
+                      <a:srgbClr val="000000"/>
+                    </a:solidFill>
+                  </a:tcPr>
+                </a:tc>
+              </a:tr>
+              <a:tr h="384048">
+                <a:tc>
+                  <a:txBody>
+                    <a:bodyPr/>
+                    <a:lstStyle/>
+                    <a:p>
+                      <a:pPr algn="l" indent="0" marL="0">
+                        <a:buNone/>
+                      </a:pPr>
+                      <a:r>
+                        <a:rPr lang="en-US" sz="1200" b="1" dirty="0">
+                          <a:solidFill>
+                            <a:srgbClr val="000000"/>
+                          </a:solidFill>
+                          <a:latin typeface="Calibri" pitchFamily="34" charset="0"/>
+                          <a:ea typeface="Calibri" pitchFamily="34" charset="-122"/>
+                          <a:cs typeface="Calibri" pitchFamily="34" charset="-120"/>
+                        </a:rPr>
+                        <a:t>UW-TIG (ours)</a:t>
+                      </a:r>
+                      <a:endParaRPr lang="en-US" sz="1200" dirty="0">
+                        <a:latin typeface="Calibri" charset="0"/>
+                        <a:ea typeface="Calibri" charset="0"/>
+                        <a:cs typeface="Calibri" charset="0"/>
+                      </a:endParaRPr>
+                    </a:p>
+                  </a:txBody>
+                  <a:tcPr marL="76200" marR="76200" marT="38100" marB="38100" anchor="ctr">
+                    <a:lnL w="9525" cap="flat" cmpd="sng" algn="ctr">
+                      <a:solidFill>
+                        <a:srgbClr val="D9D9D9"/>
+                      </a:solidFill>
+                      <a:prstDash val="solid"/>
+                      <a:round/>
+                      <a:headEnd type="none" w="med" len="med"/>
+                      <a:tailEnd type="none" w="med" len="med"/>
+                    </a:lnL>
+                    <a:lnR w="9525" cap="flat" cmpd="sng" algn="ctr">
+                      <a:solidFill>
+                        <a:srgbClr val="D9D9D9"/>
+                      </a:solidFill>
+                      <a:prstDash val="solid"/>
+                      <a:round/>
+                      <a:headEnd type="none" w="med" len="med"/>
+                      <a:tailEnd type="none" w="med" len="med"/>
+                    </a:lnR>
+                    <a:lnT w="9525" cap="flat" cmpd="sng" algn="ctr">
+                      <a:solidFill>
+                        <a:srgbClr val="D9D9D9"/>
+                      </a:solidFill>
+                      <a:prstDash val="solid"/>
+                      <a:round/>
+                      <a:headEnd type="none" w="med" len="med"/>
+                      <a:tailEnd type="none" w="med" len="med"/>
+                    </a:lnT>
+                    <a:lnB w="9525" cap="flat" cmpd="sng" algn="ctr">
+                      <a:solidFill>
+                        <a:srgbClr val="D9D9D9"/>
+                      </a:solidFill>
+                      <a:prstDash val="solid"/>
+                      <a:round/>
+                      <a:headEnd type="none" w="med" len="med"/>
+                      <a:tailEnd type="none" w="med" len="med"/>
+                    </a:lnB>
+                    <a:solidFill>
+                      <a:srgbClr val="FFFFFF"/>
+                    </a:solidFill>
+                  </a:tcPr>
+                </a:tc>
+                <a:tc>
+                  <a:txBody>
+                    <a:bodyPr/>
+                    <a:lstStyle/>
+                    <a:p>
+                      <a:pPr algn="ctr" indent="0" marL="0">
+                        <a:buNone/>
+                      </a:pPr>
+                      <a:r>
+                        <a:rPr lang="en-US" sz="1200" b="1" dirty="0">
+                          <a:solidFill>
+                            <a:srgbClr val="000000"/>
+                          </a:solidFill>
+                          <a:latin typeface="Calibri" pitchFamily="34" charset="0"/>
+                          <a:ea typeface="Calibri" pitchFamily="34" charset="-122"/>
+                          <a:cs typeface="Calibri" pitchFamily="34" charset="-120"/>
+                        </a:rPr>
+                        <a:t>0.921</a:t>
+                      </a:r>
+                      <a:endParaRPr lang="en-US" sz="1200" dirty="0">
+                        <a:latin typeface="Calibri" charset="0"/>
+                        <a:ea typeface="Calibri" charset="0"/>
+                        <a:cs typeface="Calibri" charset="0"/>
+                      </a:endParaRPr>
+                    </a:p>
+                  </a:txBody>
+                  <a:tcPr marL="76200" marR="76200" marT="38100" marB="38100" anchor="ctr">
+                    <a:lnL w="9525" cap="flat" cmpd="sng" algn="ctr">
+                      <a:solidFill>
+                        <a:srgbClr val="D9D9D9"/>
+                      </a:solidFill>
+                      <a:prstDash val="solid"/>
+                      <a:round/>
+                      <a:headEnd type="none" w="med" len="med"/>
+                      <a:tailEnd type="none" w="med" len="med"/>
+                    </a:lnL>
+                    <a:lnR w="9525" cap="flat" cmpd="sng" algn="ctr">
+                      <a:solidFill>
+                        <a:srgbClr val="D9D9D9"/>
+                      </a:solidFill>
+                      <a:prstDash val="solid"/>
+                      <a:round/>
+                      <a:headEnd type="none" w="med" len="med"/>
+                      <a:tailEnd type="none" w="med" len="med"/>
+                    </a:lnR>
+                    <a:lnT w="9525" cap="flat" cmpd="sng" algn="ctr">
+                      <a:solidFill>
+                        <a:srgbClr val="D9D9D9"/>
+                      </a:solidFill>
+                      <a:prstDash val="solid"/>
+                      <a:round/>
+                      <a:headEnd type="none" w="med" len="med"/>
+                      <a:tailEnd type="none" w="med" len="med"/>
+                    </a:lnT>
+                    <a:lnB w="9525" cap="flat" cmpd="sng" algn="ctr">
+                      <a:solidFill>
+                        <a:srgbClr val="D9D9D9"/>
+                      </a:solidFill>
+                      <a:prstDash val="solid"/>
+                      <a:round/>
+                      <a:headEnd type="none" w="med" len="med"/>
+                      <a:tailEnd type="none" w="med" len="med"/>
+                    </a:lnB>
+                    <a:solidFill>
+                      <a:srgbClr val="FFFFFF"/>
+                    </a:solidFill>
+                  </a:tcPr>
+                </a:tc>
+                <a:tc>
+                  <a:txBody>
+                    <a:bodyPr/>
+                    <a:lstStyle/>
+                    <a:p>
+                      <a:pPr algn="ctr" indent="0" marL="0">
+                        <a:buNone/>
+                      </a:pPr>
+                      <a:r>
+                        <a:rPr lang="en-US" sz="1200" b="1" dirty="0">
+                          <a:solidFill>
+                            <a:srgbClr val="000000"/>
+                          </a:solidFill>
+                          <a:latin typeface="Calibri" pitchFamily="34" charset="0"/>
+                          <a:ea typeface="Calibri" pitchFamily="34" charset="-122"/>
+                          <a:cs typeface="Calibri" pitchFamily="34" charset="-120"/>
+                        </a:rPr>
+                        <a:t>0.906-0.938</a:t>
+                      </a:r>
+                      <a:endParaRPr lang="en-US" sz="1200" dirty="0">
+                        <a:latin typeface="Calibri" charset="0"/>
+                        <a:ea typeface="Calibri" charset="0"/>
+                        <a:cs typeface="Calibri" charset="0"/>
+                      </a:endParaRPr>
+                    </a:p>
+                  </a:txBody>
+                  <a:tcPr marL="76200" marR="76200" marT="38100" marB="38100" anchor="ctr">
+                    <a:lnL w="9525" cap="flat" cmpd="sng" algn="ctr">
+                      <a:solidFill>
+                        <a:srgbClr val="D9D9D9"/>
+                      </a:solidFill>
+                      <a:prstDash val="solid"/>
+                      <a:round/>
+                      <a:headEnd type="none" w="med" len="med"/>
+                      <a:tailEnd type="none" w="med" len="med"/>
+                    </a:lnL>
+                    <a:lnR w="9525" cap="flat" cmpd="sng" algn="ctr">
+                      <a:solidFill>
+                        <a:srgbClr val="D9D9D9"/>
+                      </a:solidFill>
+                      <a:prstDash val="solid"/>
+                      <a:round/>
+                      <a:headEnd type="none" w="med" len="med"/>
+                      <a:tailEnd type="none" w="med" len="med"/>
+                    </a:lnR>
+                    <a:lnT w="9525" cap="flat" cmpd="sng" algn="ctr">
+                      <a:solidFill>
+                        <a:srgbClr val="D9D9D9"/>
+                      </a:solidFill>
+                      <a:prstDash val="solid"/>
+                      <a:round/>
+                      <a:headEnd type="none" w="med" len="med"/>
+                      <a:tailEnd type="none" w="med" len="med"/>
+                    </a:lnT>
+                    <a:lnB w="9525" cap="flat" cmpd="sng" algn="ctr">
+                      <a:solidFill>
+                        <a:srgbClr val="D9D9D9"/>
+                      </a:solidFill>
+                      <a:prstDash val="solid"/>
+                      <a:round/>
+                      <a:headEnd type="none" w="med" len="med"/>
+                      <a:tailEnd type="none" w="med" len="med"/>
+                    </a:lnB>
+                    <a:solidFill>
+                      <a:srgbClr val="FFFFFF"/>
+                    </a:solidFill>
+                  </a:tcPr>
+                </a:tc>
+                <a:tc>
+                  <a:txBody>
+                    <a:bodyPr/>
+                    <a:lstStyle/>
+                    <a:p>
+                      <a:pPr algn="ctr" indent="0" marL="0">
+                        <a:buNone/>
+                      </a:pPr>
+                      <a:r>
+                        <a:rPr lang="en-US" sz="1200" b="1" dirty="0">
+                          <a:solidFill>
+                            <a:srgbClr val="000000"/>
+                          </a:solidFill>
+                          <a:latin typeface="Calibri" pitchFamily="34" charset="0"/>
+                          <a:ea typeface="Calibri" pitchFamily="34" charset="-122"/>
+                          <a:cs typeface="Calibri" pitchFamily="34" charset="-120"/>
+                        </a:rPr>
+                        <a:t>480</a:t>
+                      </a:r>
+                      <a:endParaRPr lang="en-US" sz="1200" dirty="0">
+                        <a:latin typeface="Calibri" charset="0"/>
+                        <a:ea typeface="Calibri" charset="0"/>
+                        <a:cs typeface="Calibri" charset="0"/>
+                      </a:endParaRPr>
+                    </a:p>
+                  </a:txBody>
+                  <a:tcPr marL="76200" marR="76200" marT="38100" marB="38100" anchor="ctr">
+                    <a:lnL w="9525" cap="flat" cmpd="sng" algn="ctr">
+                      <a:solidFill>
+                        <a:srgbClr val="D9D9D9"/>
+                      </a:solidFill>
+                      <a:prstDash val="solid"/>
+                      <a:round/>
+                      <a:headEnd type="none" w="med" len="med"/>
+                      <a:tailEnd type="none" w="med" len="med"/>
+                    </a:lnL>
+                    <a:lnR w="9525" cap="flat" cmpd="sng" algn="ctr">
+                      <a:solidFill>
+                        <a:srgbClr val="D9D9D9"/>
+                      </a:solidFill>
+                      <a:prstDash val="solid"/>
+                      <a:round/>
+                      <a:headEnd type="none" w="med" len="med"/>
+                      <a:tailEnd type="none" w="med" len="med"/>
+                    </a:lnR>
+                    <a:lnT w="9525" cap="flat" cmpd="sng" algn="ctr">
+                      <a:solidFill>
+                        <a:srgbClr val="D9D9D9"/>
+                      </a:solidFill>
+                      <a:prstDash val="solid"/>
+                      <a:round/>
+                      <a:headEnd type="none" w="med" len="med"/>
+                      <a:tailEnd type="none" w="med" len="med"/>
+                    </a:lnT>
+                    <a:lnB w="9525" cap="flat" cmpd="sng" algn="ctr">
+                      <a:solidFill>
+                        <a:srgbClr val="D9D9D9"/>
+                      </a:solidFill>
+                      <a:prstDash val="solid"/>
+                      <a:round/>
+                      <a:headEnd type="none" w="med" len="med"/>
+                      <a:tailEnd type="none" w="med" len="med"/>
+                    </a:lnB>
+                    <a:solidFill>
+                      <a:srgbClr val="FFFFFF"/>
+                    </a:solidFill>
+                  </a:tcPr>
+                </a:tc>
+                <a:tc>
+                  <a:txBody>
+                    <a:bodyPr/>
+                    <a:lstStyle/>
+                    <a:p>
+                      <a:pPr algn="ctr" indent="0" marL="0">
+                        <a:buNone/>
+                      </a:pPr>
+                      <a:r>
+                        <a:rPr lang="en-US" sz="1200" b="1" dirty="0">
+                          <a:solidFill>
+                            <a:srgbClr val="000000"/>
+                          </a:solidFill>
+                          <a:latin typeface="Calibri" pitchFamily="34" charset="0"/>
+                          <a:ea typeface="Calibri" pitchFamily="34" charset="-122"/>
+                          <a:cs typeface="Calibri" pitchFamily="34" charset="-120"/>
+                        </a:rPr>
+                        <a:t>1.00</a:t>
+                      </a:r>
+                      <a:endParaRPr lang="en-US" sz="1200" dirty="0">
+                        <a:latin typeface="Calibri" charset="0"/>
+                        <a:ea typeface="Calibri" charset="0"/>
+                        <a:cs typeface="Calibri" charset="0"/>
+                      </a:endParaRPr>
+                    </a:p>
+                  </a:txBody>
+                  <a:tcPr marL="76200" marR="76200" marT="38100" marB="38100" anchor="ctr">
+                    <a:lnL w="9525" cap="flat" cmpd="sng" algn="ctr">
+                      <a:solidFill>
+                        <a:srgbClr val="D9D9D9"/>
+                      </a:solidFill>
+                      <a:prstDash val="solid"/>
+                      <a:round/>
+                      <a:headEnd type="none" w="med" len="med"/>
+                      <a:tailEnd type="none" w="med" len="med"/>
+                    </a:lnL>
+                    <a:lnR w="9525" cap="flat" cmpd="sng" algn="ctr">
+                      <a:solidFill>
+                        <a:srgbClr val="D9D9D9"/>
+                      </a:solidFill>
+                      <a:prstDash val="solid"/>
+                      <a:round/>
+                      <a:headEnd type="none" w="med" len="med"/>
+                      <a:tailEnd type="none" w="med" len="med"/>
+                    </a:lnR>
+                    <a:lnT w="9525" cap="flat" cmpd="sng" algn="ctr">
+                      <a:solidFill>
+                        <a:srgbClr val="D9D9D9"/>
+                      </a:solidFill>
+                      <a:prstDash val="solid"/>
+                      <a:round/>
+                      <a:headEnd type="none" w="med" len="med"/>
+                      <a:tailEnd type="none" w="med" len="med"/>
+                    </a:lnT>
+                    <a:lnB w="9525" cap="flat" cmpd="sng" algn="ctr">
+                      <a:solidFill>
+                        <a:srgbClr val="D9D9D9"/>
+                      </a:solidFill>
+                      <a:prstDash val="solid"/>
+                      <a:round/>
+                      <a:headEnd type="none" w="med" len="med"/>
+                      <a:tailEnd type="none" w="med" len="med"/>
+                    </a:lnB>
+                    <a:solidFill>
+                      <a:srgbClr val="FFFFFF"/>
+                    </a:solidFill>
+                  </a:tcPr>
+                </a:tc>
+                <a:tc>
+                  <a:txBody>
+                    <a:bodyPr/>
+                    <a:lstStyle/>
+                    <a:p>
+                      <a:pPr algn="ctr" indent="0" marL="0">
+                        <a:buNone/>
+                      </a:pPr>
+                      <a:r>
+                        <a:rPr lang="en-US" sz="1200" b="1" dirty="0">
+                          <a:solidFill>
+                            <a:srgbClr val="000000"/>
+                          </a:solidFill>
+                          <a:latin typeface="Calibri" pitchFamily="34" charset="0"/>
+                          <a:ea typeface="Calibri" pitchFamily="34" charset="-122"/>
+                          <a:cs typeface="Calibri" pitchFamily="34" charset="-120"/>
+                        </a:rPr>
+                        <a:t>0.953</a:t>
+                      </a:r>
+                      <a:endParaRPr lang="en-US" sz="1200" dirty="0">
+                        <a:latin typeface="Calibri" charset="0"/>
+                        <a:ea typeface="Calibri" charset="0"/>
+                        <a:cs typeface="Calibri" charset="0"/>
+                      </a:endParaRPr>
+                    </a:p>
+                  </a:txBody>
+                  <a:tcPr marL="76200" marR="76200" marT="38100" marB="38100" anchor="ctr">
+                    <a:lnL w="9525" cap="flat" cmpd="sng" algn="ctr">
+                      <a:solidFill>
+                        <a:srgbClr val="D9D9D9"/>
+                      </a:solidFill>
+                      <a:prstDash val="solid"/>
+                      <a:round/>
+                      <a:headEnd type="none" w="med" len="med"/>
+                      <a:tailEnd type="none" w="med" len="med"/>
+                    </a:lnL>
+                    <a:lnR w="9525" cap="flat" cmpd="sng" algn="ctr">
+                      <a:solidFill>
+                        <a:srgbClr val="D9D9D9"/>
+                      </a:solidFill>
+                      <a:prstDash val="solid"/>
+                      <a:round/>
+                      <a:headEnd type="none" w="med" len="med"/>
+                      <a:tailEnd type="none" w="med" len="med"/>
+                    </a:lnR>
+                    <a:lnT w="9525" cap="flat" cmpd="sng" algn="ctr">
+                      <a:solidFill>
+                        <a:srgbClr val="D9D9D9"/>
+                      </a:solidFill>
+                      <a:prstDash val="solid"/>
+                      <a:round/>
+                      <a:headEnd type="none" w="med" len="med"/>
+                      <a:tailEnd type="none" w="med" len="med"/>
+                    </a:lnT>
+                    <a:lnB w="9525" cap="flat" cmpd="sng" algn="ctr">
+                      <a:solidFill>
+                        <a:srgbClr val="D9D9D9"/>
+                      </a:solidFill>
+                      <a:prstDash val="solid"/>
+                      <a:round/>
+                      <a:headEnd type="none" w="med" len="med"/>
+                      <a:tailEnd type="none" w="med" len="med"/>
+                    </a:lnB>
+                    <a:solidFill>
+                      <a:srgbClr val="FFFFFF"/>
+                    </a:solidFill>
+                  </a:tcPr>
+                </a:tc>
+              </a:tr>
+              <a:tr h="384048">
+                <a:tc>
+                  <a:txBody>
+                    <a:bodyPr/>
+                    <a:lstStyle/>
+                    <a:p>
+                      <a:pPr algn="l" indent="0" marL="0">
+                        <a:buNone/>
+                      </a:pPr>
+                      <a:r>
+                        <a:rPr lang="en-US" sz="1200" dirty="0">
+                          <a:solidFill>
+                            <a:srgbClr val="000000"/>
+                          </a:solidFill>
+                          <a:latin typeface="Calibri" pitchFamily="34" charset="0"/>
+                          <a:ea typeface="Calibri" pitchFamily="34" charset="-122"/>
+                          <a:cs typeface="Calibri" pitchFamily="34" charset="-120"/>
+                        </a:rPr>
+                        <a:t>Alamdari 2014</a:t>
+                      </a:r>
+                      <a:endParaRPr lang="en-US" sz="1200" dirty="0">
+                        <a:latin typeface="Calibri" charset="0"/>
+                        <a:ea typeface="Calibri" charset="0"/>
+                        <a:cs typeface="Calibri" charset="0"/>
+                      </a:endParaRPr>
+                    </a:p>
+                  </a:txBody>
+                  <a:tcPr marL="76200" marR="76200" marT="38100" marB="38100" anchor="ctr">
+                    <a:lnL w="9525" cap="flat" cmpd="sng" algn="ctr">
+                      <a:solidFill>
+                        <a:srgbClr val="D9D9D9"/>
+                      </a:solidFill>
+                      <a:prstDash val="solid"/>
+                      <a:round/>
+                      <a:headEnd type="none" w="med" len="med"/>
+                      <a:tailEnd type="none" w="med" len="med"/>
+                    </a:lnL>
+                    <a:lnR w="9525" cap="flat" cmpd="sng" algn="ctr">
+                      <a:solidFill>
+                        <a:srgbClr val="D9D9D9"/>
+                      </a:solidFill>
+                      <a:prstDash val="solid"/>
+                      <a:round/>
+                      <a:headEnd type="none" w="med" len="med"/>
+                      <a:tailEnd type="none" w="med" len="med"/>
+                    </a:lnR>
+                    <a:lnT w="9525" cap="flat" cmpd="sng" algn="ctr">
+                      <a:solidFill>
+                        <a:srgbClr val="D9D9D9"/>
+                      </a:solidFill>
+                      <a:prstDash val="solid"/>
+                      <a:round/>
+                      <a:headEnd type="none" w="med" len="med"/>
+                      <a:tailEnd type="none" w="med" len="med"/>
+                    </a:lnT>
+                    <a:lnB w="9525" cap="flat" cmpd="sng" algn="ctr">
+                      <a:solidFill>
+                        <a:srgbClr val="D9D9D9"/>
+                      </a:solidFill>
+                      <a:prstDash val="solid"/>
+                      <a:round/>
+                      <a:headEnd type="none" w="med" len="med"/>
+                      <a:tailEnd type="none" w="med" len="med"/>
+                    </a:lnB>
+                    <a:solidFill>
+                      <a:srgbClr val="F3F3F3"/>
+                    </a:solidFill>
+                  </a:tcPr>
+                </a:tc>
+                <a:tc>
+                  <a:txBody>
+                    <a:bodyPr/>
+                    <a:lstStyle/>
+                    <a:p>
+                      <a:pPr algn="ctr" indent="0" marL="0">
+                        <a:buNone/>
+                      </a:pPr>
+                      <a:r>
+                        <a:rPr lang="en-US" sz="1200" dirty="0">
+                          <a:solidFill>
+                            <a:srgbClr val="000000"/>
+                          </a:solidFill>
+                          <a:latin typeface="Calibri" pitchFamily="34" charset="0"/>
+                          <a:ea typeface="Calibri" pitchFamily="34" charset="-122"/>
+                          <a:cs typeface="Calibri" pitchFamily="34" charset="-120"/>
+                        </a:rPr>
+                        <a:t>0.928</a:t>
+                      </a:r>
+                      <a:endParaRPr lang="en-US" sz="1200" dirty="0">
+                        <a:latin typeface="Calibri" charset="0"/>
+                        <a:ea typeface="Calibri" charset="0"/>
+                        <a:cs typeface="Calibri" charset="0"/>
+                      </a:endParaRPr>
+                    </a:p>
+                  </a:txBody>
+                  <a:tcPr marL="76200" marR="76200" marT="38100" marB="38100" anchor="ctr">
+                    <a:lnL w="9525" cap="flat" cmpd="sng" algn="ctr">
+                      <a:solidFill>
+                        <a:srgbClr val="D9D9D9"/>
+                      </a:solidFill>
+                      <a:prstDash val="solid"/>
+                      <a:round/>
+                      <a:headEnd type="none" w="med" len="med"/>
+                      <a:tailEnd type="none" w="med" len="med"/>
+                    </a:lnL>
+                    <a:lnR w="9525" cap="flat" cmpd="sng" algn="ctr">
+                      <a:solidFill>
+                        <a:srgbClr val="D9D9D9"/>
+                      </a:solidFill>
+                      <a:prstDash val="solid"/>
+                      <a:round/>
+                      <a:headEnd type="none" w="med" len="med"/>
+                      <a:tailEnd type="none" w="med" len="med"/>
+                    </a:lnR>
+                    <a:lnT w="9525" cap="flat" cmpd="sng" algn="ctr">
+                      <a:solidFill>
+                        <a:srgbClr val="D9D9D9"/>
+                      </a:solidFill>
+                      <a:prstDash val="solid"/>
+                      <a:round/>
+                      <a:headEnd type="none" w="med" len="med"/>
+                      <a:tailEnd type="none" w="med" len="med"/>
+                    </a:lnT>
+                    <a:lnB w="9525" cap="flat" cmpd="sng" algn="ctr">
+                      <a:solidFill>
+                        <a:srgbClr val="D9D9D9"/>
+                      </a:solidFill>
+                      <a:prstDash val="solid"/>
+                      <a:round/>
+                      <a:headEnd type="none" w="med" len="med"/>
+                      <a:tailEnd type="none" w="med" len="med"/>
+                    </a:lnB>
+                    <a:solidFill>
+                      <a:srgbClr val="F3F3F3"/>
+                    </a:solidFill>
+                  </a:tcPr>
+                </a:tc>
+                <a:tc>
+                  <a:txBody>
+                    <a:bodyPr/>
+                    <a:lstStyle/>
+                    <a:p>
+                      <a:pPr algn="ctr" indent="0" marL="0">
+                        <a:buNone/>
+                      </a:pPr>
+                      <a:r>
+                        <a:rPr lang="en-US" sz="1200" dirty="0">
+                          <a:solidFill>
+                            <a:srgbClr val="000000"/>
+                          </a:solidFill>
+                          <a:latin typeface="Calibri" pitchFamily="34" charset="0"/>
+                          <a:ea typeface="Calibri" pitchFamily="34" charset="-122"/>
+                          <a:cs typeface="Calibri" pitchFamily="34" charset="-120"/>
+                        </a:rPr>
+                        <a:t>0.912-0.947</a:t>
+                      </a:r>
+                      <a:endParaRPr lang="en-US" sz="1200" dirty="0">
+                        <a:latin typeface="Calibri" charset="0"/>
+                        <a:ea typeface="Calibri" charset="0"/>
+                        <a:cs typeface="Calibri" charset="0"/>
+                      </a:endParaRPr>
+                    </a:p>
+                  </a:txBody>
+                  <a:tcPr marL="76200" marR="76200" marT="38100" marB="38100" anchor="ctr">
+                    <a:lnL w="9525" cap="flat" cmpd="sng" algn="ctr">
+                      <a:solidFill>
+                        <a:srgbClr val="D9D9D9"/>
+                      </a:solidFill>
+                      <a:prstDash val="solid"/>
+                      <a:round/>
+                      <a:headEnd type="none" w="med" len="med"/>
+                      <a:tailEnd type="none" w="med" len="med"/>
+                    </a:lnL>
+                    <a:lnR w="9525" cap="flat" cmpd="sng" algn="ctr">
+                      <a:solidFill>
+                        <a:srgbClr val="D9D9D9"/>
+                      </a:solidFill>
+                      <a:prstDash val="solid"/>
+                      <a:round/>
+                      <a:headEnd type="none" w="med" len="med"/>
+                      <a:tailEnd type="none" w="med" len="med"/>
+                    </a:lnR>
+                    <a:lnT w="9525" cap="flat" cmpd="sng" algn="ctr">
+                      <a:solidFill>
+                        <a:srgbClr val="D9D9D9"/>
+                      </a:solidFill>
+                      <a:prstDash val="solid"/>
+                      <a:round/>
+                      <a:headEnd type="none" w="med" len="med"/>
+                      <a:tailEnd type="none" w="med" len="med"/>
+                    </a:lnT>
+                    <a:lnB w="9525" cap="flat" cmpd="sng" algn="ctr">
+                      <a:solidFill>
+                        <a:srgbClr val="D9D9D9"/>
+                      </a:solidFill>
+                      <a:prstDash val="solid"/>
+                      <a:round/>
+                      <a:headEnd type="none" w="med" len="med"/>
+                      <a:tailEnd type="none" w="med" len="med"/>
+                    </a:lnB>
+                    <a:solidFill>
+                      <a:srgbClr val="F3F3F3"/>
+                    </a:solidFill>
+                  </a:tcPr>
+                </a:tc>
+                <a:tc>
+                  <a:txBody>
+                    <a:bodyPr/>
+                    <a:lstStyle/>
+                    <a:p>
+                      <a:pPr algn="ctr" indent="0" marL="0">
+                        <a:buNone/>
+                      </a:pPr>
+                      <a:r>
+                        <a:rPr lang="en-US" sz="1200" dirty="0">
+                          <a:solidFill>
+                            <a:srgbClr val="000000"/>
+                          </a:solidFill>
+                          <a:latin typeface="Calibri" pitchFamily="34" charset="0"/>
+                          <a:ea typeface="Calibri" pitchFamily="34" charset="-122"/>
+                          <a:cs typeface="Calibri" pitchFamily="34" charset="-120"/>
+                        </a:rPr>
+                        <a:t>570</a:t>
+                      </a:r>
+                      <a:endParaRPr lang="en-US" sz="1200" dirty="0">
+                        <a:latin typeface="Calibri" charset="0"/>
+                        <a:ea typeface="Calibri" charset="0"/>
+                        <a:cs typeface="Calibri" charset="0"/>
+                      </a:endParaRPr>
+                    </a:p>
+                  </a:txBody>
+                  <a:tcPr marL="76200" marR="76200" marT="38100" marB="38100" anchor="ctr">
+                    <a:lnL w="9525" cap="flat" cmpd="sng" algn="ctr">
+                      <a:solidFill>
+                        <a:srgbClr val="D9D9D9"/>
+                      </a:solidFill>
+                      <a:prstDash val="solid"/>
+                      <a:round/>
+                      <a:headEnd type="none" w="med" len="med"/>
+                      <a:tailEnd type="none" w="med" len="med"/>
+                    </a:lnL>
+                    <a:lnR w="9525" cap="flat" cmpd="sng" algn="ctr">
+                      <a:solidFill>
+                        <a:srgbClr val="D9D9D9"/>
+                      </a:solidFill>
+                      <a:prstDash val="solid"/>
+                      <a:round/>
+                      <a:headEnd type="none" w="med" len="med"/>
+                      <a:tailEnd type="none" w="med" len="med"/>
+                    </a:lnR>
+                    <a:lnT w="9525" cap="flat" cmpd="sng" algn="ctr">
+                      <a:solidFill>
+                        <a:srgbClr val="D9D9D9"/>
+                      </a:solidFill>
+                      <a:prstDash val="solid"/>
+                      <a:round/>
+                      <a:headEnd type="none" w="med" len="med"/>
+                      <a:tailEnd type="none" w="med" len="med"/>
+                    </a:lnT>
+                    <a:lnB w="9525" cap="flat" cmpd="sng" algn="ctr">
+                      <a:solidFill>
+                        <a:srgbClr val="D9D9D9"/>
+                      </a:solidFill>
+                      <a:prstDash val="solid"/>
+                      <a:round/>
+                      <a:headEnd type="none" w="med" len="med"/>
+                      <a:tailEnd type="none" w="med" len="med"/>
+                    </a:lnB>
+                    <a:solidFill>
+                      <a:srgbClr val="F3F3F3"/>
+                    </a:solidFill>
+                  </a:tcPr>
+                </a:tc>
+                <a:tc>
+                  <a:txBody>
+                    <a:bodyPr/>
+                    <a:lstStyle/>
+                    <a:p>
+                      <a:pPr algn="ctr" indent="0" marL="0">
+                        <a:buNone/>
+                      </a:pPr>
+                      <a:r>
+                        <a:rPr lang="en-US" sz="1200" dirty="0">
+                          <a:solidFill>
+                            <a:srgbClr val="000000"/>
+                          </a:solidFill>
+                          <a:latin typeface="Calibri" pitchFamily="34" charset="0"/>
+                          <a:ea typeface="Calibri" pitchFamily="34" charset="-122"/>
+                          <a:cs typeface="Calibri" pitchFamily="34" charset="-120"/>
+                        </a:rPr>
+                        <a:t>1.00</a:t>
+                      </a:r>
+                      <a:endParaRPr lang="en-US" sz="1200" dirty="0">
+                        <a:latin typeface="Calibri" charset="0"/>
+                        <a:ea typeface="Calibri" charset="0"/>
+                        <a:cs typeface="Calibri" charset="0"/>
+                      </a:endParaRPr>
+                    </a:p>
+                  </a:txBody>
+                  <a:tcPr marL="76200" marR="76200" marT="38100" marB="38100" anchor="ctr">
+                    <a:lnL w="9525" cap="flat" cmpd="sng" algn="ctr">
+                      <a:solidFill>
+                        <a:srgbClr val="D9D9D9"/>
+                      </a:solidFill>
+                      <a:prstDash val="solid"/>
+                      <a:round/>
+                      <a:headEnd type="none" w="med" len="med"/>
+                      <a:tailEnd type="none" w="med" len="med"/>
+                    </a:lnL>
+                    <a:lnR w="9525" cap="flat" cmpd="sng" algn="ctr">
+                      <a:solidFill>
+                        <a:srgbClr val="D9D9D9"/>
+                      </a:solidFill>
+                      <a:prstDash val="solid"/>
+                      <a:round/>
+                      <a:headEnd type="none" w="med" len="med"/>
+                      <a:tailEnd type="none" w="med" len="med"/>
+                    </a:lnR>
+                    <a:lnT w="9525" cap="flat" cmpd="sng" algn="ctr">
+                      <a:solidFill>
+                        <a:srgbClr val="D9D9D9"/>
+                      </a:solidFill>
+                      <a:prstDash val="solid"/>
+                      <a:round/>
+                      <a:headEnd type="none" w="med" len="med"/>
+                      <a:tailEnd type="none" w="med" len="med"/>
+                    </a:lnT>
+                    <a:lnB w="9525" cap="flat" cmpd="sng" algn="ctr">
+                      <a:solidFill>
+                        <a:srgbClr val="D9D9D9"/>
+                      </a:solidFill>
+                      <a:prstDash val="solid"/>
+                      <a:round/>
+                      <a:headEnd type="none" w="med" len="med"/>
+                      <a:tailEnd type="none" w="med" len="med"/>
+                    </a:lnB>
+                    <a:solidFill>
+                      <a:srgbClr val="F3F3F3"/>
+                    </a:solidFill>
+                  </a:tcPr>
+                </a:tc>
+                <a:tc>
+                  <a:txBody>
+                    <a:bodyPr/>
+                    <a:lstStyle/>
+                    <a:p>
+                      <a:pPr algn="ctr" indent="0" marL="0">
+                        <a:buNone/>
+                      </a:pPr>
+                      <a:r>
+                        <a:rPr lang="en-US" sz="1200" dirty="0">
+                          <a:solidFill>
+                            <a:srgbClr val="000000"/>
+                          </a:solidFill>
+                          <a:latin typeface="Calibri" pitchFamily="34" charset="0"/>
+                          <a:ea typeface="Calibri" pitchFamily="34" charset="-122"/>
+                          <a:cs typeface="Calibri" pitchFamily="34" charset="-120"/>
+                        </a:rPr>
+                        <a:t>0.941</a:t>
+                      </a:r>
+                      <a:endParaRPr lang="en-US" sz="1200" dirty="0">
+                        <a:latin typeface="Calibri" charset="0"/>
+                        <a:ea typeface="Calibri" charset="0"/>
+                        <a:cs typeface="Calibri" charset="0"/>
+                      </a:endParaRPr>
+                    </a:p>
+                  </a:txBody>
+                  <a:tcPr marL="76200" marR="76200" marT="38100" marB="38100" anchor="ctr">
+                    <a:lnL w="9525" cap="flat" cmpd="sng" algn="ctr">
+                      <a:solidFill>
+                        <a:srgbClr val="D9D9D9"/>
+                      </a:solidFill>
+                      <a:prstDash val="solid"/>
+                      <a:round/>
+                      <a:headEnd type="none" w="med" len="med"/>
+                      <a:tailEnd type="none" w="med" len="med"/>
+                    </a:lnL>
+                    <a:lnR w="9525" cap="flat" cmpd="sng" algn="ctr">
+                      <a:solidFill>
+                        <a:srgbClr val="D9D9D9"/>
+                      </a:solidFill>
+                      <a:prstDash val="solid"/>
+                      <a:round/>
+                      <a:headEnd type="none" w="med" len="med"/>
+                      <a:tailEnd type="none" w="med" len="med"/>
+                    </a:lnR>
+                    <a:lnT w="9525" cap="flat" cmpd="sng" algn="ctr">
+                      <a:solidFill>
+                        <a:srgbClr val="D9D9D9"/>
+                      </a:solidFill>
+                      <a:prstDash val="solid"/>
+                      <a:round/>
+                      <a:headEnd type="none" w="med" len="med"/>
+                      <a:tailEnd type="none" w="med" len="med"/>
+                    </a:lnT>
+                    <a:lnB w="9525" cap="flat" cmpd="sng" algn="ctr">
+                      <a:solidFill>
+                        <a:srgbClr val="D9D9D9"/>
+                      </a:solidFill>
+                      <a:prstDash val="solid"/>
+                      <a:round/>
+                      <a:headEnd type="none" w="med" len="med"/>
+                      <a:tailEnd type="none" w="med" len="med"/>
+                    </a:lnB>
+                    <a:solidFill>
+                      <a:srgbClr val="F3F3F3"/>
+                    </a:solidFill>
+                  </a:tcPr>
+                </a:tc>
+              </a:tr>
+              <a:tr h="384048">
+                <a:tc>
+                  <a:txBody>
+                    <a:bodyPr/>
+                    <a:lstStyle/>
+                    <a:p>
+                      <a:pPr algn="l" indent="0" marL="0">
+                        <a:buNone/>
+                      </a:pPr>
+                      <a:r>
+                        <a:rPr lang="en-US" sz="1200" dirty="0">
+                          <a:solidFill>
+                            <a:srgbClr val="000000"/>
+                          </a:solidFill>
+                          <a:latin typeface="Calibri" pitchFamily="34" charset="0"/>
+                          <a:ea typeface="Calibri" pitchFamily="34" charset="-122"/>
+                          <a:cs typeface="Calibri" pitchFamily="34" charset="-120"/>
+                        </a:rPr>
+                        <a:t>GATSBI</a:t>
+                      </a:r>
+                      <a:endParaRPr lang="en-US" sz="1200" dirty="0">
+                        <a:latin typeface="Calibri" charset="0"/>
+                        <a:ea typeface="Calibri" charset="0"/>
+                        <a:cs typeface="Calibri" charset="0"/>
+                      </a:endParaRPr>
+                    </a:p>
+                  </a:txBody>
+                  <a:tcPr marL="76200" marR="76200" marT="38100" marB="38100" anchor="ctr">
+                    <a:lnL w="9525" cap="flat" cmpd="sng" algn="ctr">
+                      <a:solidFill>
+                        <a:srgbClr val="D9D9D9"/>
+                      </a:solidFill>
+                      <a:prstDash val="solid"/>
+                      <a:round/>
+                      <a:headEnd type="none" w="med" len="med"/>
+                      <a:tailEnd type="none" w="med" len="med"/>
+                    </a:lnL>
+                    <a:lnR w="9525" cap="flat" cmpd="sng" algn="ctr">
+                      <a:solidFill>
+                        <a:srgbClr val="D9D9D9"/>
+                      </a:solidFill>
+                      <a:prstDash val="solid"/>
+                      <a:round/>
+                      <a:headEnd type="none" w="med" len="med"/>
+                      <a:tailEnd type="none" w="med" len="med"/>
+                    </a:lnR>
+                    <a:lnT w="9525" cap="flat" cmpd="sng" algn="ctr">
+                      <a:solidFill>
+                        <a:srgbClr val="D9D9D9"/>
+                      </a:solidFill>
+                      <a:prstDash val="solid"/>
+                      <a:round/>
+                      <a:headEnd type="none" w="med" len="med"/>
+                      <a:tailEnd type="none" w="med" len="med"/>
+                    </a:lnT>
+                    <a:lnB w="9525" cap="flat" cmpd="sng" algn="ctr">
+                      <a:solidFill>
+                        <a:srgbClr val="D9D9D9"/>
+                      </a:solidFill>
+                      <a:prstDash val="solid"/>
+                      <a:round/>
+                      <a:headEnd type="none" w="med" len="med"/>
+                      <a:tailEnd type="none" w="med" len="med"/>
+                    </a:lnB>
+                    <a:solidFill>
+                      <a:srgbClr val="FFFFFF"/>
+                    </a:solidFill>
+                  </a:tcPr>
+                </a:tc>
+                <a:tc>
+                  <a:txBody>
+                    <a:bodyPr/>
+                    <a:lstStyle/>
+                    <a:p>
+                      <a:pPr algn="ctr" indent="0" marL="0">
+                        <a:buNone/>
+                      </a:pPr>
+                      <a:r>
+                        <a:rPr lang="en-US" sz="1200" dirty="0">
+                          <a:solidFill>
+                            <a:srgbClr val="000000"/>
+                          </a:solidFill>
+                          <a:latin typeface="Calibri" pitchFamily="34" charset="0"/>
+                          <a:ea typeface="Calibri" pitchFamily="34" charset="-122"/>
+                          <a:cs typeface="Calibri" pitchFamily="34" charset="-120"/>
+                        </a:rPr>
+                        <a:t>0.912</a:t>
+                      </a:r>
+                      <a:endParaRPr lang="en-US" sz="1200" dirty="0">
+                        <a:latin typeface="Calibri" charset="0"/>
+                        <a:ea typeface="Calibri" charset="0"/>
+                        <a:cs typeface="Calibri" charset="0"/>
+                      </a:endParaRPr>
+                    </a:p>
+                  </a:txBody>
+                  <a:tcPr marL="76200" marR="76200" marT="38100" marB="38100" anchor="ctr">
+                    <a:lnL w="9525" cap="flat" cmpd="sng" algn="ctr">
+                      <a:solidFill>
+                        <a:srgbClr val="D9D9D9"/>
+                      </a:solidFill>
+                      <a:prstDash val="solid"/>
+                      <a:round/>
+                      <a:headEnd type="none" w="med" len="med"/>
+                      <a:tailEnd type="none" w="med" len="med"/>
+                    </a:lnL>
+                    <a:lnR w="9525" cap="flat" cmpd="sng" algn="ctr">
+                      <a:solidFill>
+                        <a:srgbClr val="D9D9D9"/>
+                      </a:solidFill>
+                      <a:prstDash val="solid"/>
+                      <a:round/>
+                      <a:headEnd type="none" w="med" len="med"/>
+                      <a:tailEnd type="none" w="med" len="med"/>
+                    </a:lnR>
+                    <a:lnT w="9525" cap="flat" cmpd="sng" algn="ctr">
+                      <a:solidFill>
+                        <a:srgbClr val="D9D9D9"/>
+                      </a:solidFill>
+                      <a:prstDash val="solid"/>
+                      <a:round/>
+                      <a:headEnd type="none" w="med" len="med"/>
+                      <a:tailEnd type="none" w="med" len="med"/>
+                    </a:lnT>
+                    <a:lnB w="9525" cap="flat" cmpd="sng" algn="ctr">
+                      <a:solidFill>
+                        <a:srgbClr val="D9D9D9"/>
+                      </a:solidFill>
+                      <a:prstDash val="solid"/>
+                      <a:round/>
+                      <a:headEnd type="none" w="med" len="med"/>
+                      <a:tailEnd type="none" w="med" len="med"/>
+                    </a:lnB>
+                    <a:solidFill>
+                      <a:srgbClr val="FFFFFF"/>
+                    </a:solidFill>
+                  </a:tcPr>
+                </a:tc>
+                <a:tc>
+                  <a:txBody>
+                    <a:bodyPr/>
+                    <a:lstStyle/>
+                    <a:p>
+                      <a:pPr algn="ctr" indent="0" marL="0">
+                        <a:buNone/>
+                      </a:pPr>
+                      <a:r>
+                        <a:rPr lang="en-US" sz="1200" dirty="0">
+                          <a:solidFill>
+                            <a:srgbClr val="000000"/>
+                          </a:solidFill>
+                          <a:latin typeface="Calibri" pitchFamily="34" charset="0"/>
+                          <a:ea typeface="Calibri" pitchFamily="34" charset="-122"/>
+                          <a:cs typeface="Calibri" pitchFamily="34" charset="-120"/>
+                        </a:rPr>
+                        <a:t>0.894-0.927</a:t>
+                      </a:r>
+                      <a:endParaRPr lang="en-US" sz="1200" dirty="0">
+                        <a:latin typeface="Calibri" charset="0"/>
+                        <a:ea typeface="Calibri" charset="0"/>
+                        <a:cs typeface="Calibri" charset="0"/>
+                      </a:endParaRPr>
+                    </a:p>
+                  </a:txBody>
+                  <a:tcPr marL="76200" marR="76200" marT="38100" marB="38100" anchor="ctr">
+                    <a:lnL w="9525" cap="flat" cmpd="sng" algn="ctr">
+                      <a:solidFill>
+                        <a:srgbClr val="D9D9D9"/>
+                      </a:solidFill>
+                      <a:prstDash val="solid"/>
+                      <a:round/>
+                      <a:headEnd type="none" w="med" len="med"/>
+                      <a:tailEnd type="none" w="med" len="med"/>
+                    </a:lnL>
+                    <a:lnR w="9525" cap="flat" cmpd="sng" algn="ctr">
+                      <a:solidFill>
+                        <a:srgbClr val="D9D9D9"/>
+                      </a:solidFill>
+                      <a:prstDash val="solid"/>
+                      <a:round/>
+                      <a:headEnd type="none" w="med" len="med"/>
+                      <a:tailEnd type="none" w="med" len="med"/>
+                    </a:lnR>
+                    <a:lnT w="9525" cap="flat" cmpd="sng" algn="ctr">
+                      <a:solidFill>
+                        <a:srgbClr val="D9D9D9"/>
+                      </a:solidFill>
+                      <a:prstDash val="solid"/>
+                      <a:round/>
+                      <a:headEnd type="none" w="med" len="med"/>
+                      <a:tailEnd type="none" w="med" len="med"/>
+                    </a:lnT>
+                    <a:lnB w="9525" cap="flat" cmpd="sng" algn="ctr">
+                      <a:solidFill>
+                        <a:srgbClr val="D9D9D9"/>
+                      </a:solidFill>
+                      <a:prstDash val="solid"/>
+                      <a:round/>
+                      <a:headEnd type="none" w="med" len="med"/>
+                      <a:tailEnd type="none" w="med" len="med"/>
+                    </a:lnB>
+                    <a:solidFill>
+                      <a:srgbClr val="FFFFFF"/>
+                    </a:solidFill>
+                  </a:tcPr>
+                </a:tc>
+                <a:tc>
+                  <a:txBody>
+                    <a:bodyPr/>
+                    <a:lstStyle/>
+                    <a:p>
+                      <a:pPr algn="ctr" indent="0" marL="0">
+                        <a:buNone/>
+                      </a:pPr>
+                      <a:r>
+                        <a:rPr lang="en-US" sz="1200" dirty="0">
+                          <a:solidFill>
+                            <a:srgbClr val="000000"/>
+                          </a:solidFill>
+                          <a:latin typeface="Calibri" pitchFamily="34" charset="0"/>
+                          <a:ea typeface="Calibri" pitchFamily="34" charset="-122"/>
+                          <a:cs typeface="Calibri" pitchFamily="34" charset="-120"/>
+                        </a:rPr>
+                        <a:t>471</a:t>
+                      </a:r>
+                      <a:endParaRPr lang="en-US" sz="1200" dirty="0">
+                        <a:latin typeface="Calibri" charset="0"/>
+                        <a:ea typeface="Calibri" charset="0"/>
+                        <a:cs typeface="Calibri" charset="0"/>
+                      </a:endParaRPr>
+                    </a:p>
+                  </a:txBody>
+                  <a:tcPr marL="76200" marR="76200" marT="38100" marB="38100" anchor="ctr">
+                    <a:lnL w="9525" cap="flat" cmpd="sng" algn="ctr">
+                      <a:solidFill>
+                        <a:srgbClr val="D9D9D9"/>
+                      </a:solidFill>
+                      <a:prstDash val="solid"/>
+                      <a:round/>
+                      <a:headEnd type="none" w="med" len="med"/>
+                      <a:tailEnd type="none" w="med" len="med"/>
+                    </a:lnL>
+                    <a:lnR w="9525" cap="flat" cmpd="sng" algn="ctr">
+                      <a:solidFill>
+                        <a:srgbClr val="D9D9D9"/>
+                      </a:solidFill>
+                      <a:prstDash val="solid"/>
+                      <a:round/>
+                      <a:headEnd type="none" w="med" len="med"/>
+                      <a:tailEnd type="none" w="med" len="med"/>
+                    </a:lnR>
+                    <a:lnT w="9525" cap="flat" cmpd="sng" algn="ctr">
+                      <a:solidFill>
+                        <a:srgbClr val="D9D9D9"/>
+                      </a:solidFill>
+                      <a:prstDash val="solid"/>
+                      <a:round/>
+                      <a:headEnd type="none" w="med" len="med"/>
+                      <a:tailEnd type="none" w="med" len="med"/>
+                    </a:lnT>
+                    <a:lnB w="9525" cap="flat" cmpd="sng" algn="ctr">
+                      <a:solidFill>
+                        <a:srgbClr val="D9D9D9"/>
+                      </a:solidFill>
+                      <a:prstDash val="solid"/>
+                      <a:round/>
+                      <a:headEnd type="none" w="med" len="med"/>
+                      <a:tailEnd type="none" w="med" len="med"/>
+                    </a:lnB>
+                    <a:solidFill>
+                      <a:srgbClr val="FFFFFF"/>
+                    </a:solidFill>
+                  </a:tcPr>
+                </a:tc>
+                <a:tc>
+                  <a:txBody>
+                    <a:bodyPr/>
+                    <a:lstStyle/>
+                    <a:p>
+                      <a:pPr algn="ctr" indent="0" marL="0">
+                        <a:buNone/>
+                      </a:pPr>
+                      <a:r>
+                        <a:rPr lang="en-US" sz="1200" dirty="0">
+                          <a:solidFill>
+                            <a:srgbClr val="000000"/>
+                          </a:solidFill>
+                          <a:latin typeface="Calibri" pitchFamily="34" charset="0"/>
+                          <a:ea typeface="Calibri" pitchFamily="34" charset="-122"/>
+                          <a:cs typeface="Calibri" pitchFamily="34" charset="-120"/>
+                        </a:rPr>
+                        <a:t>1.00</a:t>
+                      </a:r>
+                      <a:endParaRPr lang="en-US" sz="1200" dirty="0">
+                        <a:latin typeface="Calibri" charset="0"/>
+                        <a:ea typeface="Calibri" charset="0"/>
+                        <a:cs typeface="Calibri" charset="0"/>
+                      </a:endParaRPr>
+                    </a:p>
+                  </a:txBody>
+                  <a:tcPr marL="76200" marR="76200" marT="38100" marB="38100" anchor="ctr">
+                    <a:lnL w="9525" cap="flat" cmpd="sng" algn="ctr">
+                      <a:solidFill>
+                        <a:srgbClr val="D9D9D9"/>
+                      </a:solidFill>
+                      <a:prstDash val="solid"/>
+                      <a:round/>
+                      <a:headEnd type="none" w="med" len="med"/>
+                      <a:tailEnd type="none" w="med" len="med"/>
+                    </a:lnL>
+                    <a:lnR w="9525" cap="flat" cmpd="sng" algn="ctr">
+                      <a:solidFill>
+                        <a:srgbClr val="D9D9D9"/>
+                      </a:solidFill>
+                      <a:prstDash val="solid"/>
+                      <a:round/>
+                      <a:headEnd type="none" w="med" len="med"/>
+                      <a:tailEnd type="none" w="med" len="med"/>
+                    </a:lnR>
+                    <a:lnT w="9525" cap="flat" cmpd="sng" algn="ctr">
+                      <a:solidFill>
+                        <a:srgbClr val="D9D9D9"/>
+                      </a:solidFill>
+                      <a:prstDash val="solid"/>
+                      <a:round/>
+                      <a:headEnd type="none" w="med" len="med"/>
+                      <a:tailEnd type="none" w="med" len="med"/>
+                    </a:lnT>
+                    <a:lnB w="9525" cap="flat" cmpd="sng" algn="ctr">
+                      <a:solidFill>
+                        <a:srgbClr val="D9D9D9"/>
+                      </a:solidFill>
+                      <a:prstDash val="solid"/>
+                      <a:round/>
+                      <a:headEnd type="none" w="med" len="med"/>
+                      <a:tailEnd type="none" w="med" len="med"/>
+                    </a:lnB>
+                    <a:solidFill>
+                      <a:srgbClr val="FFFFFF"/>
+                    </a:solidFill>
+                  </a:tcPr>
+                </a:tc>
+                <a:tc>
+                  <a:txBody>
+                    <a:bodyPr/>
+                    <a:lstStyle/>
+                    <a:p>
+                      <a:pPr algn="ctr" indent="0" marL="0">
+                        <a:buNone/>
+                      </a:pPr>
+                      <a:r>
+                        <a:rPr lang="en-US" sz="1200" dirty="0">
+                          <a:solidFill>
+                            <a:srgbClr val="000000"/>
+                          </a:solidFill>
+                          <a:latin typeface="Calibri" pitchFamily="34" charset="0"/>
+                          <a:ea typeface="Calibri" pitchFamily="34" charset="-122"/>
+                          <a:cs typeface="Calibri" pitchFamily="34" charset="-120"/>
+                        </a:rPr>
+                        <a:t>0.900</a:t>
+                      </a:r>
+                      <a:endParaRPr lang="en-US" sz="1200" dirty="0">
+                        <a:latin typeface="Calibri" charset="0"/>
+                        <a:ea typeface="Calibri" charset="0"/>
+                        <a:cs typeface="Calibri" charset="0"/>
+                      </a:endParaRPr>
+                    </a:p>
+                  </a:txBody>
+                  <a:tcPr marL="76200" marR="76200" marT="38100" marB="38100" anchor="ctr">
+                    <a:lnL w="9525" cap="flat" cmpd="sng" algn="ctr">
+                      <a:solidFill>
+                        <a:srgbClr val="D9D9D9"/>
+                      </a:solidFill>
+                      <a:prstDash val="solid"/>
+                      <a:round/>
+                      <a:headEnd type="none" w="med" len="med"/>
+                      <a:tailEnd type="none" w="med" len="med"/>
+                    </a:lnL>
+                    <a:lnR w="9525" cap="flat" cmpd="sng" algn="ctr">
+                      <a:solidFill>
+                        <a:srgbClr val="D9D9D9"/>
+                      </a:solidFill>
+                      <a:prstDash val="solid"/>
+                      <a:round/>
+                      <a:headEnd type="none" w="med" len="med"/>
+                      <a:tailEnd type="none" w="med" len="med"/>
+                    </a:lnR>
+                    <a:lnT w="9525" cap="flat" cmpd="sng" algn="ctr">
+                      <a:solidFill>
+                        <a:srgbClr val="D9D9D9"/>
+                      </a:solidFill>
+                      <a:prstDash val="solid"/>
+                      <a:round/>
+                      <a:headEnd type="none" w="med" len="med"/>
+                      <a:tailEnd type="none" w="med" len="med"/>
+                    </a:lnT>
+                    <a:lnB w="9525" cap="flat" cmpd="sng" algn="ctr">
+                      <a:solidFill>
+                        <a:srgbClr val="D9D9D9"/>
+                      </a:solidFill>
+                      <a:prstDash val="solid"/>
+                      <a:round/>
+                      <a:headEnd type="none" w="med" len="med"/>
+                      <a:tailEnd type="none" w="med" len="med"/>
+                    </a:lnB>
+                    <a:solidFill>
+                      <a:srgbClr val="FFFFFF"/>
+                    </a:solidFill>
+                  </a:tcPr>
+                </a:tc>
+              </a:tr>
+              <a:tr h="384048">
+                <a:tc>
+                  <a:txBody>
+                    <a:bodyPr/>
+                    <a:lstStyle/>
+                    <a:p>
+                      <a:pPr algn="l" indent="0" marL="0">
+                        <a:buNone/>
+                      </a:pPr>
+                      <a:r>
+                        <a:rPr lang="en-US" sz="1200" dirty="0">
+                          <a:solidFill>
+                            <a:srgbClr val="000000"/>
+                          </a:solidFill>
+                          <a:latin typeface="Calibri" pitchFamily="34" charset="0"/>
+                          <a:ea typeface="Calibri" pitchFamily="34" charset="-122"/>
+                          <a:cs typeface="Calibri" pitchFamily="34" charset="-120"/>
+                        </a:rPr>
+                        <a:t>Rückin 2023</a:t>
+                      </a:r>
+                      <a:endParaRPr lang="en-US" sz="1200" dirty="0">
+                        <a:latin typeface="Calibri" charset="0"/>
+                        <a:ea typeface="Calibri" charset="0"/>
+                        <a:cs typeface="Calibri" charset="0"/>
+                      </a:endParaRPr>
+                    </a:p>
+                  </a:txBody>
+                  <a:tcPr marL="76200" marR="76200" marT="38100" marB="38100" anchor="ctr">
+                    <a:lnL w="9525" cap="flat" cmpd="sng" algn="ctr">
+                      <a:solidFill>
+                        <a:srgbClr val="D9D9D9"/>
+                      </a:solidFill>
+                      <a:prstDash val="solid"/>
+                      <a:round/>
+                      <a:headEnd type="none" w="med" len="med"/>
+                      <a:tailEnd type="none" w="med" len="med"/>
+                    </a:lnL>
+                    <a:lnR w="9525" cap="flat" cmpd="sng" algn="ctr">
+                      <a:solidFill>
+                        <a:srgbClr val="D9D9D9"/>
+                      </a:solidFill>
+                      <a:prstDash val="solid"/>
+                      <a:round/>
+                      <a:headEnd type="none" w="med" len="med"/>
+                      <a:tailEnd type="none" w="med" len="med"/>
+                    </a:lnR>
+                    <a:lnT w="9525" cap="flat" cmpd="sng" algn="ctr">
+                      <a:solidFill>
+                        <a:srgbClr val="D9D9D9"/>
+                      </a:solidFill>
+                      <a:prstDash val="solid"/>
+                      <a:round/>
+                      <a:headEnd type="none" w="med" len="med"/>
+                      <a:tailEnd type="none" w="med" len="med"/>
+                    </a:lnT>
+                    <a:lnB w="9525" cap="flat" cmpd="sng" algn="ctr">
+                      <a:solidFill>
+                        <a:srgbClr val="D9D9D9"/>
+                      </a:solidFill>
+                      <a:prstDash val="solid"/>
+                      <a:round/>
+                      <a:headEnd type="none" w="med" len="med"/>
+                      <a:tailEnd type="none" w="med" len="med"/>
+                    </a:lnB>
+                    <a:solidFill>
+                      <a:srgbClr val="F3F3F3"/>
+                    </a:solidFill>
+                  </a:tcPr>
+                </a:tc>
+                <a:tc>
+                  <a:txBody>
+                    <a:bodyPr/>
+                    <a:lstStyle/>
+                    <a:p>
+                      <a:pPr algn="ctr" indent="0" marL="0">
+                        <a:buNone/>
+                      </a:pPr>
+                      <a:r>
+                        <a:rPr lang="en-US" sz="1200" dirty="0">
+                          <a:solidFill>
+                            <a:srgbClr val="000000"/>
+                          </a:solidFill>
+                          <a:latin typeface="Calibri" pitchFamily="34" charset="0"/>
+                          <a:ea typeface="Calibri" pitchFamily="34" charset="-122"/>
+                          <a:cs typeface="Calibri" pitchFamily="34" charset="-120"/>
+                        </a:rPr>
+                        <a:t>0.903</a:t>
+                      </a:r>
+                      <a:endParaRPr lang="en-US" sz="1200" dirty="0">
+                        <a:latin typeface="Calibri" charset="0"/>
+                        <a:ea typeface="Calibri" charset="0"/>
+                        <a:cs typeface="Calibri" charset="0"/>
+                      </a:endParaRPr>
+                    </a:p>
+                  </a:txBody>
+                  <a:tcPr marL="76200" marR="76200" marT="38100" marB="38100" anchor="ctr">
+                    <a:lnL w="9525" cap="flat" cmpd="sng" algn="ctr">
+                      <a:solidFill>
+                        <a:srgbClr val="D9D9D9"/>
+                      </a:solidFill>
+                      <a:prstDash val="solid"/>
+                      <a:round/>
+                      <a:headEnd type="none" w="med" len="med"/>
+                      <a:tailEnd type="none" w="med" len="med"/>
+                    </a:lnL>
+                    <a:lnR w="9525" cap="flat" cmpd="sng" algn="ctr">
+                      <a:solidFill>
+                        <a:srgbClr val="D9D9D9"/>
+                      </a:solidFill>
+                      <a:prstDash val="solid"/>
+                      <a:round/>
+                      <a:headEnd type="none" w="med" len="med"/>
+                      <a:tailEnd type="none" w="med" len="med"/>
+                    </a:lnR>
+                    <a:lnT w="9525" cap="flat" cmpd="sng" algn="ctr">
+                      <a:solidFill>
+                        <a:srgbClr val="D9D9D9"/>
+                      </a:solidFill>
+                      <a:prstDash val="solid"/>
+                      <a:round/>
+                      <a:headEnd type="none" w="med" len="med"/>
+                      <a:tailEnd type="none" w="med" len="med"/>
+                    </a:lnT>
+                    <a:lnB w="9525" cap="flat" cmpd="sng" algn="ctr">
+                      <a:solidFill>
+                        <a:srgbClr val="D9D9D9"/>
+                      </a:solidFill>
+                      <a:prstDash val="solid"/>
+                      <a:round/>
+                      <a:headEnd type="none" w="med" len="med"/>
+                      <a:tailEnd type="none" w="med" len="med"/>
+                    </a:lnB>
+                    <a:solidFill>
+                      <a:srgbClr val="F3F3F3"/>
+                    </a:solidFill>
+                  </a:tcPr>
+                </a:tc>
+                <a:tc>
+                  <a:txBody>
+                    <a:bodyPr/>
+                    <a:lstStyle/>
+                    <a:p>
+                      <a:pPr algn="ctr" indent="0" marL="0">
+                        <a:buNone/>
+                      </a:pPr>
+                      <a:r>
+                        <a:rPr lang="en-US" sz="1200" dirty="0">
+                          <a:solidFill>
+                            <a:srgbClr val="000000"/>
+                          </a:solidFill>
+                          <a:latin typeface="Calibri" pitchFamily="34" charset="0"/>
+                          <a:ea typeface="Calibri" pitchFamily="34" charset="-122"/>
+                          <a:cs typeface="Calibri" pitchFamily="34" charset="-120"/>
+                        </a:rPr>
+                        <a:t>0.881-0.925</a:t>
+                      </a:r>
+                      <a:endParaRPr lang="en-US" sz="1200" dirty="0">
+                        <a:latin typeface="Calibri" charset="0"/>
+                        <a:ea typeface="Calibri" charset="0"/>
+                        <a:cs typeface="Calibri" charset="0"/>
+                      </a:endParaRPr>
+                    </a:p>
+                  </a:txBody>
+                  <a:tcPr marL="76200" marR="76200" marT="38100" marB="38100" anchor="ctr">
+                    <a:lnL w="9525" cap="flat" cmpd="sng" algn="ctr">
+                      <a:solidFill>
+                        <a:srgbClr val="D9D9D9"/>
+                      </a:solidFill>
+                      <a:prstDash val="solid"/>
+                      <a:round/>
+                      <a:headEnd type="none" w="med" len="med"/>
+                      <a:tailEnd type="none" w="med" len="med"/>
+                    </a:lnL>
+                    <a:lnR w="9525" cap="flat" cmpd="sng" algn="ctr">
+                      <a:solidFill>
+                        <a:srgbClr val="D9D9D9"/>
+                      </a:solidFill>
+                      <a:prstDash val="solid"/>
+                      <a:round/>
+                      <a:headEnd type="none" w="med" len="med"/>
+                      <a:tailEnd type="none" w="med" len="med"/>
+                    </a:lnR>
+                    <a:lnT w="9525" cap="flat" cmpd="sng" algn="ctr">
+                      <a:solidFill>
+                        <a:srgbClr val="D9D9D9"/>
+                      </a:solidFill>
+                      <a:prstDash val="solid"/>
+                      <a:round/>
+                      <a:headEnd type="none" w="med" len="med"/>
+                      <a:tailEnd type="none" w="med" len="med"/>
+                    </a:lnT>
+                    <a:lnB w="9525" cap="flat" cmpd="sng" algn="ctr">
+                      <a:solidFill>
+                        <a:srgbClr val="D9D9D9"/>
+                      </a:solidFill>
+                      <a:prstDash val="solid"/>
+                      <a:round/>
+                      <a:headEnd type="none" w="med" len="med"/>
+                      <a:tailEnd type="none" w="med" len="med"/>
+                    </a:lnB>
+                    <a:solidFill>
+                      <a:srgbClr val="F3F3F3"/>
+                    </a:solidFill>
+                  </a:tcPr>
+                </a:tc>
+                <a:tc>
+                  <a:txBody>
+                    <a:bodyPr/>
+                    <a:lstStyle/>
+                    <a:p>
+                      <a:pPr algn="ctr" indent="0" marL="0">
+                        <a:buNone/>
+                      </a:pPr>
+                      <a:r>
+                        <a:rPr lang="en-US" sz="1200" dirty="0">
+                          <a:solidFill>
+                            <a:srgbClr val="000000"/>
+                          </a:solidFill>
+                          <a:latin typeface="Calibri" pitchFamily="34" charset="0"/>
+                          <a:ea typeface="Calibri" pitchFamily="34" charset="-122"/>
+                          <a:cs typeface="Calibri" pitchFamily="34" charset="-120"/>
+                        </a:rPr>
+                        <a:t>860</a:t>
+                      </a:r>
+                      <a:endParaRPr lang="en-US" sz="1200" dirty="0">
+                        <a:latin typeface="Calibri" charset="0"/>
+                        <a:ea typeface="Calibri" charset="0"/>
+                        <a:cs typeface="Calibri" charset="0"/>
+                      </a:endParaRPr>
+                    </a:p>
+                  </a:txBody>
+                  <a:tcPr marL="76200" marR="76200" marT="38100" marB="38100" anchor="ctr">
+                    <a:lnL w="9525" cap="flat" cmpd="sng" algn="ctr">
+                      <a:solidFill>
+                        <a:srgbClr val="D9D9D9"/>
+                      </a:solidFill>
+                      <a:prstDash val="solid"/>
+                      <a:round/>
+                      <a:headEnd type="none" w="med" len="med"/>
+                      <a:tailEnd type="none" w="med" len="med"/>
+                    </a:lnL>
+                    <a:lnR w="9525" cap="flat" cmpd="sng" algn="ctr">
+                      <a:solidFill>
+                        <a:srgbClr val="D9D9D9"/>
+                      </a:solidFill>
+                      <a:prstDash val="solid"/>
+                      <a:round/>
+                      <a:headEnd type="none" w="med" len="med"/>
+                      <a:tailEnd type="none" w="med" len="med"/>
+                    </a:lnR>
+                    <a:lnT w="9525" cap="flat" cmpd="sng" algn="ctr">
+                      <a:solidFill>
+                        <a:srgbClr val="D9D9D9"/>
+                      </a:solidFill>
+                      <a:prstDash val="solid"/>
+                      <a:round/>
+                      <a:headEnd type="none" w="med" len="med"/>
+                      <a:tailEnd type="none" w="med" len="med"/>
+                    </a:lnT>
+                    <a:lnB w="9525" cap="flat" cmpd="sng" algn="ctr">
+                      <a:solidFill>
+                        <a:srgbClr val="D9D9D9"/>
+                      </a:solidFill>
+                      <a:prstDash val="solid"/>
+                      <a:round/>
+                      <a:headEnd type="none" w="med" len="med"/>
+                      <a:tailEnd type="none" w="med" len="med"/>
+                    </a:lnB>
+                    <a:solidFill>
+                      <a:srgbClr val="F3F3F3"/>
+                    </a:solidFill>
+                  </a:tcPr>
+                </a:tc>
+                <a:tc>
+                  <a:txBody>
+                    <a:bodyPr/>
+                    <a:lstStyle/>
+                    <a:p>
+                      <a:pPr algn="ctr" indent="0" marL="0">
+                        <a:buNone/>
+                      </a:pPr>
+                      <a:r>
+                        <a:rPr lang="en-US" sz="1200" dirty="0">
+                          <a:solidFill>
+                            <a:srgbClr val="000000"/>
+                          </a:solidFill>
+                          <a:latin typeface="Calibri" pitchFamily="34" charset="0"/>
+                          <a:ea typeface="Calibri" pitchFamily="34" charset="-122"/>
+                          <a:cs typeface="Calibri" pitchFamily="34" charset="-120"/>
+                        </a:rPr>
+                        <a:t>1.00</a:t>
+                      </a:r>
+                      <a:endParaRPr lang="en-US" sz="1200" dirty="0">
+                        <a:latin typeface="Calibri" charset="0"/>
+                        <a:ea typeface="Calibri" charset="0"/>
+                        <a:cs typeface="Calibri" charset="0"/>
+                      </a:endParaRPr>
+                    </a:p>
+                  </a:txBody>
+                  <a:tcPr marL="76200" marR="76200" marT="38100" marB="38100" anchor="ctr">
+                    <a:lnL w="9525" cap="flat" cmpd="sng" algn="ctr">
+                      <a:solidFill>
+                        <a:srgbClr val="D9D9D9"/>
+                      </a:solidFill>
+                      <a:prstDash val="solid"/>
+                      <a:round/>
+                      <a:headEnd type="none" w="med" len="med"/>
+                      <a:tailEnd type="none" w="med" len="med"/>
+                    </a:lnL>
+                    <a:lnR w="9525" cap="flat" cmpd="sng" algn="ctr">
+                      <a:solidFill>
+                        <a:srgbClr val="D9D9D9"/>
+                      </a:solidFill>
+                      <a:prstDash val="solid"/>
+                      <a:round/>
+                      <a:headEnd type="none" w="med" len="med"/>
+                      <a:tailEnd type="none" w="med" len="med"/>
+                    </a:lnR>
+                    <a:lnT w="9525" cap="flat" cmpd="sng" algn="ctr">
+                      <a:solidFill>
+                        <a:srgbClr val="D9D9D9"/>
+                      </a:solidFill>
+                      <a:prstDash val="solid"/>
+                      <a:round/>
+                      <a:headEnd type="none" w="med" len="med"/>
+                      <a:tailEnd type="none" w="med" len="med"/>
+                    </a:lnT>
+                    <a:lnB w="9525" cap="flat" cmpd="sng" algn="ctr">
+                      <a:solidFill>
+                        <a:srgbClr val="D9D9D9"/>
+                      </a:solidFill>
+                      <a:prstDash val="solid"/>
+                      <a:round/>
+                      <a:headEnd type="none" w="med" len="med"/>
+                      <a:tailEnd type="none" w="med" len="med"/>
+                    </a:lnB>
+                    <a:solidFill>
+                      <a:srgbClr val="F3F3F3"/>
+                    </a:solidFill>
+                  </a:tcPr>
+                </a:tc>
+                <a:tc>
+                  <a:txBody>
+                    <a:bodyPr/>
+                    <a:lstStyle/>
+                    <a:p>
+                      <a:pPr algn="ctr" indent="0" marL="0">
+                        <a:buNone/>
+                      </a:pPr>
+                      <a:r>
+                        <a:rPr lang="en-US" sz="1200" dirty="0">
+                          <a:solidFill>
+                            <a:srgbClr val="000000"/>
+                          </a:solidFill>
+                          <a:latin typeface="Calibri" pitchFamily="34" charset="0"/>
+                          <a:ea typeface="Calibri" pitchFamily="34" charset="-122"/>
+                          <a:cs typeface="Calibri" pitchFamily="34" charset="-120"/>
+                        </a:rPr>
+                        <a:t>0.950</a:t>
+                      </a:r>
+                      <a:endParaRPr lang="en-US" sz="1200" dirty="0">
+                        <a:latin typeface="Calibri" charset="0"/>
+                        <a:ea typeface="Calibri" charset="0"/>
+                        <a:cs typeface="Calibri" charset="0"/>
+                      </a:endParaRPr>
+                    </a:p>
+                  </a:txBody>
+                  <a:tcPr marL="76200" marR="76200" marT="38100" marB="38100" anchor="ctr">
+                    <a:lnL w="9525" cap="flat" cmpd="sng" algn="ctr">
+                      <a:solidFill>
+                        <a:srgbClr val="D9D9D9"/>
+                      </a:solidFill>
+                      <a:prstDash val="solid"/>
+                      <a:round/>
+                      <a:headEnd type="none" w="med" len="med"/>
+                      <a:tailEnd type="none" w="med" len="med"/>
+                    </a:lnL>
+                    <a:lnR w="9525" cap="flat" cmpd="sng" algn="ctr">
+                      <a:solidFill>
+                        <a:srgbClr val="D9D9D9"/>
+                      </a:solidFill>
+                      <a:prstDash val="solid"/>
+                      <a:round/>
+                      <a:headEnd type="none" w="med" len="med"/>
+                      <a:tailEnd type="none" w="med" len="med"/>
+                    </a:lnR>
+                    <a:lnT w="9525" cap="flat" cmpd="sng" algn="ctr">
+                      <a:solidFill>
+                        <a:srgbClr val="D9D9D9"/>
+                      </a:solidFill>
+                      <a:prstDash val="solid"/>
+                      <a:round/>
+                      <a:headEnd type="none" w="med" len="med"/>
+                      <a:tailEnd type="none" w="med" len="med"/>
+                    </a:lnT>
+                    <a:lnB w="9525" cap="flat" cmpd="sng" algn="ctr">
+                      <a:solidFill>
+                        <a:srgbClr val="D9D9D9"/>
+                      </a:solidFill>
+                      <a:prstDash val="solid"/>
+                      <a:round/>
+                      <a:headEnd type="none" w="med" len="med"/>
+                      <a:tailEnd type="none" w="med" len="med"/>
+                    </a:lnB>
+                    <a:solidFill>
+                      <a:srgbClr val="F3F3F3"/>
+                    </a:solidFill>
+                  </a:tcPr>
+                </a:tc>
+              </a:tr>
+              <a:tr h="384048">
+                <a:tc>
+                  <a:txBody>
+                    <a:bodyPr/>
+                    <a:lstStyle/>
+                    <a:p>
+                      <a:pPr algn="l" indent="0" marL="0">
+                        <a:buNone/>
+                      </a:pPr>
+                      <a:r>
+                        <a:rPr lang="en-US" sz="1200" dirty="0">
+                          <a:solidFill>
+                            <a:srgbClr val="000000"/>
+                          </a:solidFill>
+                          <a:latin typeface="Calibri" pitchFamily="34" charset="0"/>
+                          <a:ea typeface="Calibri" pitchFamily="34" charset="-122"/>
+                          <a:cs typeface="Calibri" pitchFamily="34" charset="-120"/>
+                        </a:rPr>
+                        <a:t>Random</a:t>
+                      </a:r>
+                      <a:endParaRPr lang="en-US" sz="1200" dirty="0">
+                        <a:latin typeface="Calibri" charset="0"/>
+                        <a:ea typeface="Calibri" charset="0"/>
+                        <a:cs typeface="Calibri" charset="0"/>
+                      </a:endParaRPr>
+                    </a:p>
+                  </a:txBody>
+                  <a:tcPr marL="76200" marR="76200" marT="38100" marB="38100" anchor="ctr">
+                    <a:lnL w="9525" cap="flat" cmpd="sng" algn="ctr">
+                      <a:solidFill>
+                        <a:srgbClr val="D9D9D9"/>
+                      </a:solidFill>
+                      <a:prstDash val="solid"/>
+                      <a:round/>
+                      <a:headEnd type="none" w="med" len="med"/>
+                      <a:tailEnd type="none" w="med" len="med"/>
+                    </a:lnL>
+                    <a:lnR w="9525" cap="flat" cmpd="sng" algn="ctr">
+                      <a:solidFill>
+                        <a:srgbClr val="D9D9D9"/>
+                      </a:solidFill>
+                      <a:prstDash val="solid"/>
+                      <a:round/>
+                      <a:headEnd type="none" w="med" len="med"/>
+                      <a:tailEnd type="none" w="med" len="med"/>
+                    </a:lnR>
+                    <a:lnT w="9525" cap="flat" cmpd="sng" algn="ctr">
+                      <a:solidFill>
+                        <a:srgbClr val="D9D9D9"/>
+                      </a:solidFill>
+                      <a:prstDash val="solid"/>
+                      <a:round/>
+                      <a:headEnd type="none" w="med" len="med"/>
+                      <a:tailEnd type="none" w="med" len="med"/>
+                    </a:lnT>
+                    <a:lnB w="9525" cap="flat" cmpd="sng" algn="ctr">
+                      <a:solidFill>
+                        <a:srgbClr val="D9D9D9"/>
+                      </a:solidFill>
+                      <a:prstDash val="solid"/>
+                      <a:round/>
+                      <a:headEnd type="none" w="med" len="med"/>
+                      <a:tailEnd type="none" w="med" len="med"/>
+                    </a:lnB>
+                    <a:solidFill>
+                      <a:srgbClr val="FFFFFF"/>
+                    </a:solidFill>
+                  </a:tcPr>
+                </a:tc>
+                <a:tc>
+                  <a:txBody>
+                    <a:bodyPr/>
+                    <a:lstStyle/>
+                    <a:p>
+                      <a:pPr algn="ctr" indent="0" marL="0">
+                        <a:buNone/>
+                      </a:pPr>
+                      <a:r>
+                        <a:rPr lang="en-US" sz="1200" dirty="0">
+                          <a:solidFill>
+                            <a:srgbClr val="000000"/>
+                          </a:solidFill>
+                          <a:latin typeface="Calibri" pitchFamily="34" charset="0"/>
+                          <a:ea typeface="Calibri" pitchFamily="34" charset="-122"/>
+                          <a:cs typeface="Calibri" pitchFamily="34" charset="-120"/>
+                        </a:rPr>
+                        <a:t>0.801</a:t>
+                      </a:r>
+                      <a:endParaRPr lang="en-US" sz="1200" dirty="0">
+                        <a:latin typeface="Calibri" charset="0"/>
+                        <a:ea typeface="Calibri" charset="0"/>
+                        <a:cs typeface="Calibri" charset="0"/>
+                      </a:endParaRPr>
+                    </a:p>
+                  </a:txBody>
+                  <a:tcPr marL="76200" marR="76200" marT="38100" marB="38100" anchor="ctr">
+                    <a:lnL w="9525" cap="flat" cmpd="sng" algn="ctr">
+                      <a:solidFill>
+                        <a:srgbClr val="D9D9D9"/>
+                      </a:solidFill>
+                      <a:prstDash val="solid"/>
+                      <a:round/>
+                      <a:headEnd type="none" w="med" len="med"/>
+                      <a:tailEnd type="none" w="med" len="med"/>
+                    </a:lnL>
+                    <a:lnR w="9525" cap="flat" cmpd="sng" algn="ctr">
+                      <a:solidFill>
+                        <a:srgbClr val="D9D9D9"/>
+                      </a:solidFill>
+                      <a:prstDash val="solid"/>
+                      <a:round/>
+                      <a:headEnd type="none" w="med" len="med"/>
+                      <a:tailEnd type="none" w="med" len="med"/>
+                    </a:lnR>
+                    <a:lnT w="9525" cap="flat" cmpd="sng" algn="ctr">
+                      <a:solidFill>
+                        <a:srgbClr val="D9D9D9"/>
+                      </a:solidFill>
+                      <a:prstDash val="solid"/>
+                      <a:round/>
+                      <a:headEnd type="none" w="med" len="med"/>
+                      <a:tailEnd type="none" w="med" len="med"/>
+                    </a:lnT>
+                    <a:lnB w="9525" cap="flat" cmpd="sng" algn="ctr">
+                      <a:solidFill>
+                        <a:srgbClr val="D9D9D9"/>
+                      </a:solidFill>
+                      <a:prstDash val="solid"/>
+                      <a:round/>
+                      <a:headEnd type="none" w="med" len="med"/>
+                      <a:tailEnd type="none" w="med" len="med"/>
+                    </a:lnB>
+                    <a:solidFill>
+                      <a:srgbClr val="FFFFFF"/>
+                    </a:solidFill>
+                  </a:tcPr>
+                </a:tc>
+                <a:tc>
+                  <a:txBody>
+                    <a:bodyPr/>
+                    <a:lstStyle/>
+                    <a:p>
+                      <a:pPr algn="ctr" indent="0" marL="0">
+                        <a:buNone/>
+                      </a:pPr>
+                      <a:r>
+                        <a:rPr lang="en-US" sz="1200" dirty="0">
+                          <a:solidFill>
+                            <a:srgbClr val="000000"/>
+                          </a:solidFill>
+                          <a:latin typeface="Calibri" pitchFamily="34" charset="0"/>
+                          <a:ea typeface="Calibri" pitchFamily="34" charset="-122"/>
+                          <a:cs typeface="Calibri" pitchFamily="34" charset="-120"/>
+                        </a:rPr>
+                        <a:t>0.772-0.836</a:t>
+                      </a:r>
+                      <a:endParaRPr lang="en-US" sz="1200" dirty="0">
+                        <a:latin typeface="Calibri" charset="0"/>
+                        <a:ea typeface="Calibri" charset="0"/>
+                        <a:cs typeface="Calibri" charset="0"/>
+                      </a:endParaRPr>
+                    </a:p>
+                  </a:txBody>
+                  <a:tcPr marL="76200" marR="76200" marT="38100" marB="38100" anchor="ctr">
+                    <a:lnL w="9525" cap="flat" cmpd="sng" algn="ctr">
+                      <a:solidFill>
+                        <a:srgbClr val="D9D9D9"/>
+                      </a:solidFill>
+                      <a:prstDash val="solid"/>
+                      <a:round/>
+                      <a:headEnd type="none" w="med" len="med"/>
+                      <a:tailEnd type="none" w="med" len="med"/>
+                    </a:lnL>
+                    <a:lnR w="9525" cap="flat" cmpd="sng" algn="ctr">
+                      <a:solidFill>
+                        <a:srgbClr val="D9D9D9"/>
+                      </a:solidFill>
+                      <a:prstDash val="solid"/>
+                      <a:round/>
+                      <a:headEnd type="none" w="med" len="med"/>
+                      <a:tailEnd type="none" w="med" len="med"/>
+                    </a:lnR>
+                    <a:lnT w="9525" cap="flat" cmpd="sng" algn="ctr">
+                      <a:solidFill>
+                        <a:srgbClr val="D9D9D9"/>
+                      </a:solidFill>
+                      <a:prstDash val="solid"/>
+                      <a:round/>
+                      <a:headEnd type="none" w="med" len="med"/>
+                      <a:tailEnd type="none" w="med" len="med"/>
+                    </a:lnT>
+                    <a:lnB w="9525" cap="flat" cmpd="sng" algn="ctr">
+                      <a:solidFill>
+                        <a:srgbClr val="D9D9D9"/>
+                      </a:solidFill>
+                      <a:prstDash val="solid"/>
+                      <a:round/>
+                      <a:headEnd type="none" w="med" len="med"/>
+                      <a:tailEnd type="none" w="med" len="med"/>
+                    </a:lnB>
+                    <a:solidFill>
+                      <a:srgbClr val="FFFFFF"/>
+                    </a:solidFill>
+                  </a:tcPr>
+                </a:tc>
+                <a:tc>
+                  <a:txBody>
+                    <a:bodyPr/>
+                    <a:lstStyle/>
+                    <a:p>
+                      <a:pPr algn="ctr" indent="0" marL="0">
+                        <a:buNone/>
+                      </a:pPr>
+                      <a:r>
+                        <a:rPr lang="en-US" sz="1200" dirty="0">
+                          <a:solidFill>
+                            <a:srgbClr val="000000"/>
+                          </a:solidFill>
+                          <a:latin typeface="Calibri" pitchFamily="34" charset="0"/>
+                          <a:ea typeface="Calibri" pitchFamily="34" charset="-122"/>
+                          <a:cs typeface="Calibri" pitchFamily="34" charset="-120"/>
+                        </a:rPr>
+                        <a:t>2396</a:t>
+                      </a:r>
+                      <a:endParaRPr lang="en-US" sz="1200" dirty="0">
+                        <a:latin typeface="Calibri" charset="0"/>
+                        <a:ea typeface="Calibri" charset="0"/>
+                        <a:cs typeface="Calibri" charset="0"/>
+                      </a:endParaRPr>
+                    </a:p>
+                  </a:txBody>
+                  <a:tcPr marL="76200" marR="76200" marT="38100" marB="38100" anchor="ctr">
+                    <a:lnL w="9525" cap="flat" cmpd="sng" algn="ctr">
+                      <a:solidFill>
+                        <a:srgbClr val="D9D9D9"/>
+                      </a:solidFill>
+                      <a:prstDash val="solid"/>
+                      <a:round/>
+                      <a:headEnd type="none" w="med" len="med"/>
+                      <a:tailEnd type="none" w="med" len="med"/>
+                    </a:lnL>
+                    <a:lnR w="9525" cap="flat" cmpd="sng" algn="ctr">
+                      <a:solidFill>
+                        <a:srgbClr val="D9D9D9"/>
+                      </a:solidFill>
+                      <a:prstDash val="solid"/>
+                      <a:round/>
+                      <a:headEnd type="none" w="med" len="med"/>
+                      <a:tailEnd type="none" w="med" len="med"/>
+                    </a:lnR>
+                    <a:lnT w="9525" cap="flat" cmpd="sng" algn="ctr">
+                      <a:solidFill>
+                        <a:srgbClr val="D9D9D9"/>
+                      </a:solidFill>
+                      <a:prstDash val="solid"/>
+                      <a:round/>
+                      <a:headEnd type="none" w="med" len="med"/>
+                      <a:tailEnd type="none" w="med" len="med"/>
+                    </a:lnT>
+                    <a:lnB w="9525" cap="flat" cmpd="sng" algn="ctr">
+                      <a:solidFill>
+                        <a:srgbClr val="D9D9D9"/>
+                      </a:solidFill>
+                      <a:prstDash val="solid"/>
+                      <a:round/>
+                      <a:headEnd type="none" w="med" len="med"/>
+                      <a:tailEnd type="none" w="med" len="med"/>
+                    </a:lnB>
+                    <a:solidFill>
+                      <a:srgbClr val="FFFFFF"/>
+                    </a:solidFill>
+                  </a:tcPr>
+                </a:tc>
+                <a:tc>
+                  <a:txBody>
+                    <a:bodyPr/>
+                    <a:lstStyle/>
+                    <a:p>
+                      <a:pPr algn="ctr" indent="0" marL="0">
+                        <a:buNone/>
+                      </a:pPr>
+                      <a:r>
+                        <a:rPr lang="en-US" sz="1200" dirty="0">
+                          <a:solidFill>
+                            <a:srgbClr val="000000"/>
+                          </a:solidFill>
+                          <a:latin typeface="Calibri" pitchFamily="34" charset="0"/>
+                          <a:ea typeface="Calibri" pitchFamily="34" charset="-122"/>
+                          <a:cs typeface="Calibri" pitchFamily="34" charset="-120"/>
+                        </a:rPr>
+                        <a:t>0.99</a:t>
+                      </a:r>
+                      <a:endParaRPr lang="en-US" sz="1200" dirty="0">
+                        <a:latin typeface="Calibri" charset="0"/>
+                        <a:ea typeface="Calibri" charset="0"/>
+                        <a:cs typeface="Calibri" charset="0"/>
+                      </a:endParaRPr>
+                    </a:p>
+                  </a:txBody>
+                  <a:tcPr marL="76200" marR="76200" marT="38100" marB="38100" anchor="ctr">
+                    <a:lnL w="9525" cap="flat" cmpd="sng" algn="ctr">
+                      <a:solidFill>
+                        <a:srgbClr val="D9D9D9"/>
+                      </a:solidFill>
+                      <a:prstDash val="solid"/>
+                      <a:round/>
+                      <a:headEnd type="none" w="med" len="med"/>
+                      <a:tailEnd type="none" w="med" len="med"/>
+                    </a:lnL>
+                    <a:lnR w="9525" cap="flat" cmpd="sng" algn="ctr">
+                      <a:solidFill>
+                        <a:srgbClr val="D9D9D9"/>
+                      </a:solidFill>
+                      <a:prstDash val="solid"/>
+                      <a:round/>
+                      <a:headEnd type="none" w="med" len="med"/>
+                      <a:tailEnd type="none" w="med" len="med"/>
+                    </a:lnR>
+                    <a:lnT w="9525" cap="flat" cmpd="sng" algn="ctr">
+                      <a:solidFill>
+                        <a:srgbClr val="D9D9D9"/>
+                      </a:solidFill>
+                      <a:prstDash val="solid"/>
+                      <a:round/>
+                      <a:headEnd type="none" w="med" len="med"/>
+                      <a:tailEnd type="none" w="med" len="med"/>
+                    </a:lnT>
+                    <a:lnB w="9525" cap="flat" cmpd="sng" algn="ctr">
+                      <a:solidFill>
+                        <a:srgbClr val="D9D9D9"/>
+                      </a:solidFill>
+                      <a:prstDash val="solid"/>
+                      <a:round/>
+                      <a:headEnd type="none" w="med" len="med"/>
+                      <a:tailEnd type="none" w="med" len="med"/>
+                    </a:lnB>
+                    <a:solidFill>
+                      <a:srgbClr val="FFFFFF"/>
+                    </a:solidFill>
+                  </a:tcPr>
+                </a:tc>
+                <a:tc>
+                  <a:txBody>
+                    <a:bodyPr/>
+                    <a:lstStyle/>
+                    <a:p>
+                      <a:pPr algn="ctr" indent="0" marL="0">
+                        <a:buNone/>
+                      </a:pPr>
+                      <a:r>
+                        <a:rPr lang="en-US" sz="1200" dirty="0">
+                          <a:solidFill>
+                            <a:srgbClr val="000000"/>
+                          </a:solidFill>
+                          <a:latin typeface="Calibri" pitchFamily="34" charset="0"/>
+                          <a:ea typeface="Calibri" pitchFamily="34" charset="-122"/>
+                          <a:cs typeface="Calibri" pitchFamily="34" charset="-120"/>
+                        </a:rPr>
+                        <a:t>0.873</a:t>
+                      </a:r>
+                      <a:endParaRPr lang="en-US" sz="1200" dirty="0">
+                        <a:latin typeface="Calibri" charset="0"/>
+                        <a:ea typeface="Calibri" charset="0"/>
+                        <a:cs typeface="Calibri" charset="0"/>
+                      </a:endParaRPr>
+                    </a:p>
+                  </a:txBody>
+                  <a:tcPr marL="76200" marR="76200" marT="38100" marB="38100" anchor="ctr">
+                    <a:lnL w="9525" cap="flat" cmpd="sng" algn="ctr">
+                      <a:solidFill>
+                        <a:srgbClr val="D9D9D9"/>
+                      </a:solidFill>
+                      <a:prstDash val="solid"/>
+                      <a:round/>
+                      <a:headEnd type="none" w="med" len="med"/>
+                      <a:tailEnd type="none" w="med" len="med"/>
+                    </a:lnL>
+                    <a:lnR w="9525" cap="flat" cmpd="sng" algn="ctr">
+                      <a:solidFill>
+                        <a:srgbClr val="D9D9D9"/>
+                      </a:solidFill>
+                      <a:prstDash val="solid"/>
+                      <a:round/>
+                      <a:headEnd type="none" w="med" len="med"/>
+                      <a:tailEnd type="none" w="med" len="med"/>
+                    </a:lnR>
+                    <a:lnT w="9525" cap="flat" cmpd="sng" algn="ctr">
+                      <a:solidFill>
+                        <a:srgbClr val="D9D9D9"/>
+                      </a:solidFill>
+                      <a:prstDash val="solid"/>
+                      <a:round/>
+                      <a:headEnd type="none" w="med" len="med"/>
+                      <a:tailEnd type="none" w="med" len="med"/>
+                    </a:lnT>
+                    <a:lnB w="9525" cap="flat" cmpd="sng" algn="ctr">
+                      <a:solidFill>
+                        <a:srgbClr val="D9D9D9"/>
+                      </a:solidFill>
+                      <a:prstDash val="solid"/>
+                      <a:round/>
+                      <a:headEnd type="none" w="med" len="med"/>
+                      <a:tailEnd type="none" w="med" len="med"/>
+                    </a:lnB>
+                    <a:solidFill>
+                      <a:srgbClr val="FFFFFF"/>
+                    </a:solidFill>
+                  </a:tcPr>
+                </a:tc>
+              </a:tr>
+              <a:tr h="384048">
+                <a:tc>
+                  <a:txBody>
+                    <a:bodyPr/>
+                    <a:lstStyle/>
+                    <a:p>
+                      <a:pPr algn="l" indent="0" marL="0">
+                        <a:buNone/>
+                      </a:pPr>
+                      <a:r>
+                        <a:rPr lang="en-US" sz="1200" dirty="0">
+                          <a:solidFill>
+                            <a:srgbClr val="000000"/>
+                          </a:solidFill>
+                          <a:latin typeface="Calibri" pitchFamily="34" charset="0"/>
+                          <a:ea typeface="Calibri" pitchFamily="34" charset="-122"/>
+                          <a:cs typeface="Calibri" pitchFamily="34" charset="-120"/>
+                        </a:rPr>
+                        <a:t>Bircher 2016</a:t>
+                      </a:r>
+                      <a:endParaRPr lang="en-US" sz="1200" dirty="0">
+                        <a:latin typeface="Calibri" charset="0"/>
+                        <a:ea typeface="Calibri" charset="0"/>
+                        <a:cs typeface="Calibri" charset="0"/>
+                      </a:endParaRPr>
+                    </a:p>
+                  </a:txBody>
+                  <a:tcPr marL="76200" marR="76200" marT="38100" marB="38100" anchor="ctr">
+                    <a:lnL w="9525" cap="flat" cmpd="sng" algn="ctr">
+                      <a:solidFill>
+                        <a:srgbClr val="D9D9D9"/>
+                      </a:solidFill>
+                      <a:prstDash val="solid"/>
+                      <a:round/>
+                      <a:headEnd type="none" w="med" len="med"/>
+                      <a:tailEnd type="none" w="med" len="med"/>
+                    </a:lnL>
+                    <a:lnR w="9525" cap="flat" cmpd="sng" algn="ctr">
+                      <a:solidFill>
+                        <a:srgbClr val="D9D9D9"/>
+                      </a:solidFill>
+                      <a:prstDash val="solid"/>
+                      <a:round/>
+                      <a:headEnd type="none" w="med" len="med"/>
+                      <a:tailEnd type="none" w="med" len="med"/>
+                    </a:lnR>
+                    <a:lnT w="9525" cap="flat" cmpd="sng" algn="ctr">
+                      <a:solidFill>
+                        <a:srgbClr val="D9D9D9"/>
+                      </a:solidFill>
+                      <a:prstDash val="solid"/>
+                      <a:round/>
+                      <a:headEnd type="none" w="med" len="med"/>
+                      <a:tailEnd type="none" w="med" len="med"/>
+                    </a:lnT>
+                    <a:lnB w="9525" cap="flat" cmpd="sng" algn="ctr">
+                      <a:solidFill>
+                        <a:srgbClr val="D9D9D9"/>
+                      </a:solidFill>
+                      <a:prstDash val="solid"/>
+                      <a:round/>
+                      <a:headEnd type="none" w="med" len="med"/>
+                      <a:tailEnd type="none" w="med" len="med"/>
+                    </a:lnB>
+                    <a:solidFill>
+                      <a:srgbClr val="F3F3F3"/>
+                    </a:solidFill>
+                  </a:tcPr>
+                </a:tc>
+                <a:tc>
+                  <a:txBody>
+                    <a:bodyPr/>
+                    <a:lstStyle/>
+                    <a:p>
+                      <a:pPr algn="ctr" indent="0" marL="0">
+                        <a:buNone/>
+                      </a:pPr>
+                      <a:r>
+                        <a:rPr lang="en-US" sz="1200" dirty="0">
+                          <a:solidFill>
+                            <a:srgbClr val="000000"/>
+                          </a:solidFill>
+                          <a:latin typeface="Calibri" pitchFamily="34" charset="0"/>
+                          <a:ea typeface="Calibri" pitchFamily="34" charset="-122"/>
+                          <a:cs typeface="Calibri" pitchFamily="34" charset="-120"/>
+                        </a:rPr>
+                        <a:t>0.661</a:t>
+                      </a:r>
+                      <a:endParaRPr lang="en-US" sz="1200" dirty="0">
+                        <a:latin typeface="Calibri" charset="0"/>
+                        <a:ea typeface="Calibri" charset="0"/>
+                        <a:cs typeface="Calibri" charset="0"/>
+                      </a:endParaRPr>
+                    </a:p>
+                  </a:txBody>
+                  <a:tcPr marL="76200" marR="76200" marT="38100" marB="38100" anchor="ctr">
+                    <a:lnL w="9525" cap="flat" cmpd="sng" algn="ctr">
+                      <a:solidFill>
+                        <a:srgbClr val="D9D9D9"/>
+                      </a:solidFill>
+                      <a:prstDash val="solid"/>
+                      <a:round/>
+                      <a:headEnd type="none" w="med" len="med"/>
+                      <a:tailEnd type="none" w="med" len="med"/>
+                    </a:lnL>
+                    <a:lnR w="9525" cap="flat" cmpd="sng" algn="ctr">
+                      <a:solidFill>
+                        <a:srgbClr val="D9D9D9"/>
+                      </a:solidFill>
+                      <a:prstDash val="solid"/>
+                      <a:round/>
+                      <a:headEnd type="none" w="med" len="med"/>
+                      <a:tailEnd type="none" w="med" len="med"/>
+                    </a:lnR>
+                    <a:lnT w="9525" cap="flat" cmpd="sng" algn="ctr">
+                      <a:solidFill>
+                        <a:srgbClr val="D9D9D9"/>
+                      </a:solidFill>
+                      <a:prstDash val="solid"/>
+                      <a:round/>
+                      <a:headEnd type="none" w="med" len="med"/>
+                      <a:tailEnd type="none" w="med" len="med"/>
+                    </a:lnT>
+                    <a:lnB w="9525" cap="flat" cmpd="sng" algn="ctr">
+                      <a:solidFill>
+                        <a:srgbClr val="D9D9D9"/>
+                      </a:solidFill>
+                      <a:prstDash val="solid"/>
+                      <a:round/>
+                      <a:headEnd type="none" w="med" len="med"/>
+                      <a:tailEnd type="none" w="med" len="med"/>
+                    </a:lnB>
+                    <a:solidFill>
+                      <a:srgbClr val="F3F3F3"/>
+                    </a:solidFill>
+                  </a:tcPr>
+                </a:tc>
+                <a:tc>
+                  <a:txBody>
+                    <a:bodyPr/>
+                    <a:lstStyle/>
+                    <a:p>
+                      <a:pPr algn="ctr" indent="0" marL="0">
+                        <a:buNone/>
+                      </a:pPr>
+                      <a:r>
+                        <a:rPr lang="en-US" sz="1200" dirty="0">
+                          <a:solidFill>
+                            <a:srgbClr val="000000"/>
+                          </a:solidFill>
+                          <a:latin typeface="Calibri" pitchFamily="34" charset="0"/>
+                          <a:ea typeface="Calibri" pitchFamily="34" charset="-122"/>
+                          <a:cs typeface="Calibri" pitchFamily="34" charset="-120"/>
+                        </a:rPr>
+                        <a:t>0.630-0.688</a:t>
+                      </a:r>
+                      <a:endParaRPr lang="en-US" sz="1200" dirty="0">
+                        <a:latin typeface="Calibri" charset="0"/>
+                        <a:ea typeface="Calibri" charset="0"/>
+                        <a:cs typeface="Calibri" charset="0"/>
+                      </a:endParaRPr>
+                    </a:p>
+                  </a:txBody>
+                  <a:tcPr marL="76200" marR="76200" marT="38100" marB="38100" anchor="ctr">
+                    <a:lnL w="9525" cap="flat" cmpd="sng" algn="ctr">
+                      <a:solidFill>
+                        <a:srgbClr val="D9D9D9"/>
+                      </a:solidFill>
+                      <a:prstDash val="solid"/>
+                      <a:round/>
+                      <a:headEnd type="none" w="med" len="med"/>
+                      <a:tailEnd type="none" w="med" len="med"/>
+                    </a:lnL>
+                    <a:lnR w="9525" cap="flat" cmpd="sng" algn="ctr">
+                      <a:solidFill>
+                        <a:srgbClr val="D9D9D9"/>
+                      </a:solidFill>
+                      <a:prstDash val="solid"/>
+                      <a:round/>
+                      <a:headEnd type="none" w="med" len="med"/>
+                      <a:tailEnd type="none" w="med" len="med"/>
+                    </a:lnR>
+                    <a:lnT w="9525" cap="flat" cmpd="sng" algn="ctr">
+                      <a:solidFill>
+                        <a:srgbClr val="D9D9D9"/>
+                      </a:solidFill>
+                      <a:prstDash val="solid"/>
+                      <a:round/>
+                      <a:headEnd type="none" w="med" len="med"/>
+                      <a:tailEnd type="none" w="med" len="med"/>
+                    </a:lnT>
+                    <a:lnB w="9525" cap="flat" cmpd="sng" algn="ctr">
+                      <a:solidFill>
+                        <a:srgbClr val="D9D9D9"/>
+                      </a:solidFill>
+                      <a:prstDash val="solid"/>
+                      <a:round/>
+                      <a:headEnd type="none" w="med" len="med"/>
+                      <a:tailEnd type="none" w="med" len="med"/>
+                    </a:lnB>
+                    <a:solidFill>
+                      <a:srgbClr val="F3F3F3"/>
+                    </a:solidFill>
+                  </a:tcPr>
+                </a:tc>
+                <a:tc>
+                  <a:txBody>
+                    <a:bodyPr/>
+                    <a:lstStyle/>
+                    <a:p>
+                      <a:pPr algn="ctr" indent="0" marL="0">
+                        <a:buNone/>
+                      </a:pPr>
+                      <a:r>
+                        <a:rPr lang="en-US" sz="1200" dirty="0">
+                          <a:solidFill>
+                            <a:srgbClr val="000000"/>
+                          </a:solidFill>
+                          <a:latin typeface="Calibri" pitchFamily="34" charset="0"/>
+                          <a:ea typeface="Calibri" pitchFamily="34" charset="-122"/>
+                          <a:cs typeface="Calibri" pitchFamily="34" charset="-120"/>
+                        </a:rPr>
+                        <a:t>209</a:t>
+                      </a:r>
+                      <a:endParaRPr lang="en-US" sz="1200" dirty="0">
+                        <a:latin typeface="Calibri" charset="0"/>
+                        <a:ea typeface="Calibri" charset="0"/>
+                        <a:cs typeface="Calibri" charset="0"/>
+                      </a:endParaRPr>
+                    </a:p>
+                  </a:txBody>
+                  <a:tcPr marL="76200" marR="76200" marT="38100" marB="38100" anchor="ctr">
+                    <a:lnL w="9525" cap="flat" cmpd="sng" algn="ctr">
+                      <a:solidFill>
+                        <a:srgbClr val="D9D9D9"/>
+                      </a:solidFill>
+                      <a:prstDash val="solid"/>
+                      <a:round/>
+                      <a:headEnd type="none" w="med" len="med"/>
+                      <a:tailEnd type="none" w="med" len="med"/>
+                    </a:lnL>
+                    <a:lnR w="9525" cap="flat" cmpd="sng" algn="ctr">
+                      <a:solidFill>
+                        <a:srgbClr val="D9D9D9"/>
+                      </a:solidFill>
+                      <a:prstDash val="solid"/>
+                      <a:round/>
+                      <a:headEnd type="none" w="med" len="med"/>
+                      <a:tailEnd type="none" w="med" len="med"/>
+                    </a:lnR>
+                    <a:lnT w="9525" cap="flat" cmpd="sng" algn="ctr">
+                      <a:solidFill>
+                        <a:srgbClr val="D9D9D9"/>
+                      </a:solidFill>
+                      <a:prstDash val="solid"/>
+                      <a:round/>
+                      <a:headEnd type="none" w="med" len="med"/>
+                      <a:tailEnd type="none" w="med" len="med"/>
+                    </a:lnT>
+                    <a:lnB w="9525" cap="flat" cmpd="sng" algn="ctr">
+                      <a:solidFill>
+                        <a:srgbClr val="D9D9D9"/>
+                      </a:solidFill>
+                      <a:prstDash val="solid"/>
+                      <a:round/>
+                      <a:headEnd type="none" w="med" len="med"/>
+                      <a:tailEnd type="none" w="med" len="med"/>
+                    </a:lnB>
+                    <a:solidFill>
+                      <a:srgbClr val="F3F3F3"/>
+                    </a:solidFill>
+                  </a:tcPr>
+                </a:tc>
+                <a:tc>
+                  <a:txBody>
+                    <a:bodyPr/>
+                    <a:lstStyle/>
+                    <a:p>
+                      <a:pPr algn="ctr" indent="0" marL="0">
+                        <a:buNone/>
+                      </a:pPr>
+                      <a:r>
+                        <a:rPr lang="en-US" sz="1200" dirty="0">
+                          <a:solidFill>
+                            <a:srgbClr val="000000"/>
+                          </a:solidFill>
+                          <a:latin typeface="Calibri" pitchFamily="34" charset="0"/>
+                          <a:ea typeface="Calibri" pitchFamily="34" charset="-122"/>
+                          <a:cs typeface="Calibri" pitchFamily="34" charset="-120"/>
+                        </a:rPr>
+                        <a:t>0.52</a:t>
+                      </a:r>
+                      <a:endParaRPr lang="en-US" sz="1200" dirty="0">
+                        <a:latin typeface="Calibri" charset="0"/>
+                        <a:ea typeface="Calibri" charset="0"/>
+                        <a:cs typeface="Calibri" charset="0"/>
+                      </a:endParaRPr>
+                    </a:p>
+                  </a:txBody>
+                  <a:tcPr marL="76200" marR="76200" marT="38100" marB="38100" anchor="ctr">
+                    <a:lnL w="9525" cap="flat" cmpd="sng" algn="ctr">
+                      <a:solidFill>
+                        <a:srgbClr val="D9D9D9"/>
+                      </a:solidFill>
+                      <a:prstDash val="solid"/>
+                      <a:round/>
+                      <a:headEnd type="none" w="med" len="med"/>
+                      <a:tailEnd type="none" w="med" len="med"/>
+                    </a:lnL>
+                    <a:lnR w="9525" cap="flat" cmpd="sng" algn="ctr">
+                      <a:solidFill>
+                        <a:srgbClr val="D9D9D9"/>
+                      </a:solidFill>
+                      <a:prstDash val="solid"/>
+                      <a:round/>
+                      <a:headEnd type="none" w="med" len="med"/>
+                      <a:tailEnd type="none" w="med" len="med"/>
+                    </a:lnR>
+                    <a:lnT w="9525" cap="flat" cmpd="sng" algn="ctr">
+                      <a:solidFill>
+                        <a:srgbClr val="D9D9D9"/>
+                      </a:solidFill>
+                      <a:prstDash val="solid"/>
+                      <a:round/>
+                      <a:headEnd type="none" w="med" len="med"/>
+                      <a:tailEnd type="none" w="med" len="med"/>
+                    </a:lnT>
+                    <a:lnB w="9525" cap="flat" cmpd="sng" algn="ctr">
+                      <a:solidFill>
+                        <a:srgbClr val="D9D9D9"/>
+                      </a:solidFill>
+                      <a:prstDash val="solid"/>
+                      <a:round/>
+                      <a:headEnd type="none" w="med" len="med"/>
+                      <a:tailEnd type="none" w="med" len="med"/>
+                    </a:lnB>
+                    <a:solidFill>
+                      <a:srgbClr val="F3F3F3"/>
+                    </a:solidFill>
+                  </a:tcPr>
+                </a:tc>
+                <a:tc>
+                  <a:txBody>
+                    <a:bodyPr/>
+                    <a:lstStyle/>
+                    <a:p>
+                      <a:pPr algn="ctr" indent="0" marL="0">
+                        <a:buNone/>
+                      </a:pPr>
+                      <a:r>
+                        <a:rPr lang="en-US" sz="1200" dirty="0">
+                          <a:solidFill>
+                            <a:srgbClr val="000000"/>
+                          </a:solidFill>
+                          <a:latin typeface="Calibri" pitchFamily="34" charset="0"/>
+                          <a:ea typeface="Calibri" pitchFamily="34" charset="-122"/>
+                          <a:cs typeface="Calibri" pitchFamily="34" charset="-120"/>
+                        </a:rPr>
+                        <a:t>0.814</a:t>
+                      </a:r>
+                      <a:endParaRPr lang="en-US" sz="1200" dirty="0">
+                        <a:latin typeface="Calibri" charset="0"/>
+                        <a:ea typeface="Calibri" charset="0"/>
+                        <a:cs typeface="Calibri" charset="0"/>
+                      </a:endParaRPr>
+                    </a:p>
+                  </a:txBody>
+                  <a:tcPr marL="76200" marR="76200" marT="38100" marB="38100" anchor="ctr">
+                    <a:lnL w="9525" cap="flat" cmpd="sng" algn="ctr">
+                      <a:solidFill>
+                        <a:srgbClr val="D9D9D9"/>
+                      </a:solidFill>
+                      <a:prstDash val="solid"/>
+                      <a:round/>
+                      <a:headEnd type="none" w="med" len="med"/>
+                      <a:tailEnd type="none" w="med" len="med"/>
+                    </a:lnL>
+                    <a:lnR w="9525" cap="flat" cmpd="sng" algn="ctr">
+                      <a:solidFill>
+                        <a:srgbClr val="D9D9D9"/>
+                      </a:solidFill>
+                      <a:prstDash val="solid"/>
+                      <a:round/>
+                      <a:headEnd type="none" w="med" len="med"/>
+                      <a:tailEnd type="none" w="med" len="med"/>
+                    </a:lnR>
+                    <a:lnT w="9525" cap="flat" cmpd="sng" algn="ctr">
+                      <a:solidFill>
+                        <a:srgbClr val="D9D9D9"/>
+                      </a:solidFill>
+                      <a:prstDash val="solid"/>
+                      <a:round/>
+                      <a:headEnd type="none" w="med" len="med"/>
+                      <a:tailEnd type="none" w="med" len="med"/>
+                    </a:lnT>
+                    <a:lnB w="9525" cap="flat" cmpd="sng" algn="ctr">
+                      <a:solidFill>
+                        <a:srgbClr val="D9D9D9"/>
+                      </a:solidFill>
+                      <a:prstDash val="solid"/>
+                      <a:round/>
+                      <a:headEnd type="none" w="med" len="med"/>
+                      <a:tailEnd type="none" w="med" len="med"/>
+                    </a:lnB>
+                    <a:solidFill>
+                      <a:srgbClr val="F3F3F3"/>
+                    </a:solidFill>
+                  </a:tcPr>
+                </a:tc>
+              </a:tr>
+              <a:tr h="384048">
+                <a:tc>
+                  <a:txBody>
+                    <a:bodyPr/>
+                    <a:lstStyle/>
+                    <a:p>
+                      <a:pPr algn="l" indent="0" marL="0">
+                        <a:buNone/>
+                      </a:pPr>
+                      <a:r>
+                        <a:rPr lang="en-US" sz="1200" dirty="0">
+                          <a:solidFill>
+                            <a:srgbClr val="000000"/>
+                          </a:solidFill>
+                          <a:latin typeface="Calibri" pitchFamily="34" charset="0"/>
+                          <a:ea typeface="Calibri" pitchFamily="34" charset="-122"/>
+                          <a:cs typeface="Calibri" pitchFamily="34" charset="-120"/>
+                        </a:rPr>
+                        <a:t>Isler-NBV</a:t>
+                      </a:r>
+                      <a:endParaRPr lang="en-US" sz="1200" dirty="0">
+                        <a:latin typeface="Calibri" charset="0"/>
+                        <a:ea typeface="Calibri" charset="0"/>
+                        <a:cs typeface="Calibri" charset="0"/>
+                      </a:endParaRPr>
+                    </a:p>
+                  </a:txBody>
+                  <a:tcPr marL="76200" marR="76200" marT="38100" marB="38100" anchor="ctr">
+                    <a:lnL w="9525" cap="flat" cmpd="sng" algn="ctr">
+                      <a:solidFill>
+                        <a:srgbClr val="D9D9D9"/>
+                      </a:solidFill>
+                      <a:prstDash val="solid"/>
+                      <a:round/>
+                      <a:headEnd type="none" w="med" len="med"/>
+                      <a:tailEnd type="none" w="med" len="med"/>
+                    </a:lnL>
+                    <a:lnR w="9525" cap="flat" cmpd="sng" algn="ctr">
+                      <a:solidFill>
+                        <a:srgbClr val="D9D9D9"/>
+                      </a:solidFill>
+                      <a:prstDash val="solid"/>
+                      <a:round/>
+                      <a:headEnd type="none" w="med" len="med"/>
+                      <a:tailEnd type="none" w="med" len="med"/>
+                    </a:lnR>
+                    <a:lnT w="9525" cap="flat" cmpd="sng" algn="ctr">
+                      <a:solidFill>
+                        <a:srgbClr val="D9D9D9"/>
+                      </a:solidFill>
+                      <a:prstDash val="solid"/>
+                      <a:round/>
+                      <a:headEnd type="none" w="med" len="med"/>
+                      <a:tailEnd type="none" w="med" len="med"/>
+                    </a:lnT>
+                    <a:lnB w="9525" cap="flat" cmpd="sng" algn="ctr">
+                      <a:solidFill>
+                        <a:srgbClr val="D9D9D9"/>
+                      </a:solidFill>
+                      <a:prstDash val="solid"/>
+                      <a:round/>
+                      <a:headEnd type="none" w="med" len="med"/>
+                      <a:tailEnd type="none" w="med" len="med"/>
+                    </a:lnB>
+                    <a:solidFill>
+                      <a:srgbClr val="FFFFFF"/>
+                    </a:solidFill>
+                  </a:tcPr>
+                </a:tc>
+                <a:tc>
+                  <a:txBody>
+                    <a:bodyPr/>
+                    <a:lstStyle/>
+                    <a:p>
+                      <a:pPr algn="ctr" indent="0" marL="0">
+                        <a:buNone/>
+                      </a:pPr>
+                      <a:r>
+                        <a:rPr lang="en-US" sz="1200" dirty="0">
+                          <a:solidFill>
+                            <a:srgbClr val="000000"/>
+                          </a:solidFill>
+                          <a:latin typeface="Calibri" pitchFamily="34" charset="0"/>
+                          <a:ea typeface="Calibri" pitchFamily="34" charset="-122"/>
+                          <a:cs typeface="Calibri" pitchFamily="34" charset="-120"/>
+                        </a:rPr>
+                        <a:t>0.466</a:t>
+                      </a:r>
+                      <a:endParaRPr lang="en-US" sz="1200" dirty="0">
+                        <a:latin typeface="Calibri" charset="0"/>
+                        <a:ea typeface="Calibri" charset="0"/>
+                        <a:cs typeface="Calibri" charset="0"/>
+                      </a:endParaRPr>
+                    </a:p>
+                  </a:txBody>
+                  <a:tcPr marL="76200" marR="76200" marT="38100" marB="38100" anchor="ctr">
+                    <a:lnL w="9525" cap="flat" cmpd="sng" algn="ctr">
+                      <a:solidFill>
+                        <a:srgbClr val="D9D9D9"/>
+                      </a:solidFill>
+                      <a:prstDash val="solid"/>
+                      <a:round/>
+                      <a:headEnd type="none" w="med" len="med"/>
+                      <a:tailEnd type="none" w="med" len="med"/>
+                    </a:lnL>
+                    <a:lnR w="9525" cap="flat" cmpd="sng" algn="ctr">
+                      <a:solidFill>
+                        <a:srgbClr val="D9D9D9"/>
+                      </a:solidFill>
+                      <a:prstDash val="solid"/>
+                      <a:round/>
+                      <a:headEnd type="none" w="med" len="med"/>
+                      <a:tailEnd type="none" w="med" len="med"/>
+                    </a:lnR>
+                    <a:lnT w="9525" cap="flat" cmpd="sng" algn="ctr">
+                      <a:solidFill>
+                        <a:srgbClr val="D9D9D9"/>
+                      </a:solidFill>
+                      <a:prstDash val="solid"/>
+                      <a:round/>
+                      <a:headEnd type="none" w="med" len="med"/>
+                      <a:tailEnd type="none" w="med" len="med"/>
+                    </a:lnT>
+                    <a:lnB w="9525" cap="flat" cmpd="sng" algn="ctr">
+                      <a:solidFill>
+                        <a:srgbClr val="D9D9D9"/>
+                      </a:solidFill>
+                      <a:prstDash val="solid"/>
+                      <a:round/>
+                      <a:headEnd type="none" w="med" len="med"/>
+                      <a:tailEnd type="none" w="med" len="med"/>
+                    </a:lnB>
+                    <a:solidFill>
+                      <a:srgbClr val="FFFFFF"/>
+                    </a:solidFill>
+                  </a:tcPr>
+                </a:tc>
+                <a:tc>
+                  <a:txBody>
+                    <a:bodyPr/>
+                    <a:lstStyle/>
+                    <a:p>
+                      <a:pPr algn="ctr" indent="0" marL="0">
+                        <a:buNone/>
+                      </a:pPr>
+                      <a:r>
+                        <a:rPr lang="en-US" sz="1200" dirty="0">
+                          <a:solidFill>
+                            <a:srgbClr val="000000"/>
+                          </a:solidFill>
+                          <a:latin typeface="Calibri" pitchFamily="34" charset="0"/>
+                          <a:ea typeface="Calibri" pitchFamily="34" charset="-122"/>
+                          <a:cs typeface="Calibri" pitchFamily="34" charset="-120"/>
+                        </a:rPr>
+                        <a:t>0.394-0.519</a:t>
+                      </a:r>
+                      <a:endParaRPr lang="en-US" sz="1200" dirty="0">
+                        <a:latin typeface="Calibri" charset="0"/>
+                        <a:ea typeface="Calibri" charset="0"/>
+                        <a:cs typeface="Calibri" charset="0"/>
+                      </a:endParaRPr>
+                    </a:p>
+                  </a:txBody>
+                  <a:tcPr marL="76200" marR="76200" marT="38100" marB="38100" anchor="ctr">
+                    <a:lnL w="9525" cap="flat" cmpd="sng" algn="ctr">
+                      <a:solidFill>
+                        <a:srgbClr val="D9D9D9"/>
+                      </a:solidFill>
+                      <a:prstDash val="solid"/>
+                      <a:round/>
+                      <a:headEnd type="none" w="med" len="med"/>
+                      <a:tailEnd type="none" w="med" len="med"/>
+                    </a:lnL>
+                    <a:lnR w="9525" cap="flat" cmpd="sng" algn="ctr">
+                      <a:solidFill>
+                        <a:srgbClr val="D9D9D9"/>
+                      </a:solidFill>
+                      <a:prstDash val="solid"/>
+                      <a:round/>
+                      <a:headEnd type="none" w="med" len="med"/>
+                      <a:tailEnd type="none" w="med" len="med"/>
+                    </a:lnR>
+                    <a:lnT w="9525" cap="flat" cmpd="sng" algn="ctr">
+                      <a:solidFill>
+                        <a:srgbClr val="D9D9D9"/>
+                      </a:solidFill>
+                      <a:prstDash val="solid"/>
+                      <a:round/>
+                      <a:headEnd type="none" w="med" len="med"/>
+                      <a:tailEnd type="none" w="med" len="med"/>
+                    </a:lnT>
+                    <a:lnB w="9525" cap="flat" cmpd="sng" algn="ctr">
+                      <a:solidFill>
+                        <a:srgbClr val="D9D9D9"/>
+                      </a:solidFill>
+                      <a:prstDash val="solid"/>
+                      <a:round/>
+                      <a:headEnd type="none" w="med" len="med"/>
+                      <a:tailEnd type="none" w="med" len="med"/>
+                    </a:lnB>
+                    <a:solidFill>
+                      <a:srgbClr val="FFFFFF"/>
+                    </a:solidFill>
+                  </a:tcPr>
+                </a:tc>
+                <a:tc>
+                  <a:txBody>
+                    <a:bodyPr/>
+                    <a:lstStyle/>
+                    <a:p>
+                      <a:pPr algn="ctr" indent="0" marL="0">
+                        <a:buNone/>
+                      </a:pPr>
+                      <a:r>
+                        <a:rPr lang="en-US" sz="1200" dirty="0">
+                          <a:solidFill>
+                            <a:srgbClr val="000000"/>
+                          </a:solidFill>
+                          <a:latin typeface="Calibri" pitchFamily="34" charset="0"/>
+                          <a:ea typeface="Calibri" pitchFamily="34" charset="-122"/>
+                          <a:cs typeface="Calibri" pitchFamily="34" charset="-120"/>
+                        </a:rPr>
+                        <a:t>177</a:t>
+                      </a:r>
+                      <a:endParaRPr lang="en-US" sz="1200" dirty="0">
+                        <a:latin typeface="Calibri" charset="0"/>
+                        <a:ea typeface="Calibri" charset="0"/>
+                        <a:cs typeface="Calibri" charset="0"/>
+                      </a:endParaRPr>
+                    </a:p>
+                  </a:txBody>
+                  <a:tcPr marL="76200" marR="76200" marT="38100" marB="38100" anchor="ctr">
+                    <a:lnL w="9525" cap="flat" cmpd="sng" algn="ctr">
+                      <a:solidFill>
+                        <a:srgbClr val="D9D9D9"/>
+                      </a:solidFill>
+                      <a:prstDash val="solid"/>
+                      <a:round/>
+                      <a:headEnd type="none" w="med" len="med"/>
+                      <a:tailEnd type="none" w="med" len="med"/>
+                    </a:lnL>
+                    <a:lnR w="9525" cap="flat" cmpd="sng" algn="ctr">
+                      <a:solidFill>
+                        <a:srgbClr val="D9D9D9"/>
+                      </a:solidFill>
+                      <a:prstDash val="solid"/>
+                      <a:round/>
+                      <a:headEnd type="none" w="med" len="med"/>
+                      <a:tailEnd type="none" w="med" len="med"/>
+                    </a:lnR>
+                    <a:lnT w="9525" cap="flat" cmpd="sng" algn="ctr">
+                      <a:solidFill>
+                        <a:srgbClr val="D9D9D9"/>
+                      </a:solidFill>
+                      <a:prstDash val="solid"/>
+                      <a:round/>
+                      <a:headEnd type="none" w="med" len="med"/>
+                      <a:tailEnd type="none" w="med" len="med"/>
+                    </a:lnT>
+                    <a:lnB w="9525" cap="flat" cmpd="sng" algn="ctr">
+                      <a:solidFill>
+                        <a:srgbClr val="D9D9D9"/>
+                      </a:solidFill>
+                      <a:prstDash val="solid"/>
+                      <a:round/>
+                      <a:headEnd type="none" w="med" len="med"/>
+                      <a:tailEnd type="none" w="med" len="med"/>
+                    </a:lnB>
+                    <a:solidFill>
+                      <a:srgbClr val="FFFFFF"/>
+                    </a:solidFill>
+                  </a:tcPr>
+                </a:tc>
+                <a:tc>
+                  <a:txBody>
+                    <a:bodyPr/>
+                    <a:lstStyle/>
+                    <a:p>
+                      <a:pPr algn="ctr" indent="0" marL="0">
+                        <a:buNone/>
+                      </a:pPr>
+                      <a:r>
+                        <a:rPr lang="en-US" sz="1200" dirty="0">
+                          <a:solidFill>
+                            <a:srgbClr val="000000"/>
+                          </a:solidFill>
+                          <a:latin typeface="Calibri" pitchFamily="34" charset="0"/>
+                          <a:ea typeface="Calibri" pitchFamily="34" charset="-122"/>
+                          <a:cs typeface="Calibri" pitchFamily="34" charset="-120"/>
+                        </a:rPr>
+                        <a:t>0.32</a:t>
+                      </a:r>
+                      <a:endParaRPr lang="en-US" sz="1200" dirty="0">
+                        <a:latin typeface="Calibri" charset="0"/>
+                        <a:ea typeface="Calibri" charset="0"/>
+                        <a:cs typeface="Calibri" charset="0"/>
+                      </a:endParaRPr>
+                    </a:p>
+                  </a:txBody>
+                  <a:tcPr marL="76200" marR="76200" marT="38100" marB="38100" anchor="ctr">
+                    <a:lnL w="9525" cap="flat" cmpd="sng" algn="ctr">
+                      <a:solidFill>
+                        <a:srgbClr val="D9D9D9"/>
+                      </a:solidFill>
+                      <a:prstDash val="solid"/>
+                      <a:round/>
+                      <a:headEnd type="none" w="med" len="med"/>
+                      <a:tailEnd type="none" w="med" len="med"/>
+                    </a:lnL>
+                    <a:lnR w="9525" cap="flat" cmpd="sng" algn="ctr">
+                      <a:solidFill>
+                        <a:srgbClr val="D9D9D9"/>
+                      </a:solidFill>
+                      <a:prstDash val="solid"/>
+                      <a:round/>
+                      <a:headEnd type="none" w="med" len="med"/>
+                      <a:tailEnd type="none" w="med" len="med"/>
+                    </a:lnR>
+                    <a:lnT w="9525" cap="flat" cmpd="sng" algn="ctr">
+                      <a:solidFill>
+                        <a:srgbClr val="D9D9D9"/>
+                      </a:solidFill>
+                      <a:prstDash val="solid"/>
+                      <a:round/>
+                      <a:headEnd type="none" w="med" len="med"/>
+                      <a:tailEnd type="none" w="med" len="med"/>
+                    </a:lnT>
+                    <a:lnB w="9525" cap="flat" cmpd="sng" algn="ctr">
+                      <a:solidFill>
+                        <a:srgbClr val="D9D9D9"/>
+                      </a:solidFill>
+                      <a:prstDash val="solid"/>
+                      <a:round/>
+                      <a:headEnd type="none" w="med" len="med"/>
+                      <a:tailEnd type="none" w="med" len="med"/>
+                    </a:lnB>
+                    <a:solidFill>
+                      <a:srgbClr val="FFFFFF"/>
+                    </a:solidFill>
+                  </a:tcPr>
+                </a:tc>
+                <a:tc>
+                  <a:txBody>
+                    <a:bodyPr/>
+                    <a:lstStyle/>
+                    <a:p>
+                      <a:pPr algn="ctr" indent="0" marL="0">
+                        <a:buNone/>
+                      </a:pPr>
+                      <a:r>
+                        <a:rPr lang="en-US" sz="1200" dirty="0">
+                          <a:solidFill>
+                            <a:srgbClr val="000000"/>
+                          </a:solidFill>
+                          <a:latin typeface="Calibri" pitchFamily="34" charset="0"/>
+                          <a:ea typeface="Calibri" pitchFamily="34" charset="-122"/>
+                          <a:cs typeface="Calibri" pitchFamily="34" charset="-120"/>
+                        </a:rPr>
+                        <a:t>0.671</a:t>
+                      </a:r>
+                      <a:endParaRPr lang="en-US" sz="1200" dirty="0">
+                        <a:latin typeface="Calibri" charset="0"/>
+                        <a:ea typeface="Calibri" charset="0"/>
+                        <a:cs typeface="Calibri" charset="0"/>
+                      </a:endParaRPr>
+                    </a:p>
+                  </a:txBody>
+                  <a:tcPr marL="76200" marR="76200" marT="38100" marB="38100" anchor="ctr">
+                    <a:lnL w="9525" cap="flat" cmpd="sng" algn="ctr">
+                      <a:solidFill>
+                        <a:srgbClr val="D9D9D9"/>
+                      </a:solidFill>
+                      <a:prstDash val="solid"/>
+                      <a:round/>
+                      <a:headEnd type="none" w="med" len="med"/>
+                      <a:tailEnd type="none" w="med" len="med"/>
+                    </a:lnL>
+                    <a:lnR w="9525" cap="flat" cmpd="sng" algn="ctr">
+                      <a:solidFill>
+                        <a:srgbClr val="D9D9D9"/>
+                      </a:solidFill>
+                      <a:prstDash val="solid"/>
+                      <a:round/>
+                      <a:headEnd type="none" w="med" len="med"/>
+                      <a:tailEnd type="none" w="med" len="med"/>
+                    </a:lnR>
+                    <a:lnT w="9525" cap="flat" cmpd="sng" algn="ctr">
+                      <a:solidFill>
+                        <a:srgbClr val="D9D9D9"/>
+                      </a:solidFill>
+                      <a:prstDash val="solid"/>
+                      <a:round/>
+                      <a:headEnd type="none" w="med" len="med"/>
+                      <a:tailEnd type="none" w="med" len="med"/>
+                    </a:lnT>
+                    <a:lnB w="9525" cap="flat" cmpd="sng" algn="ctr">
+                      <a:solidFill>
+                        <a:srgbClr val="D9D9D9"/>
+                      </a:solidFill>
+                      <a:prstDash val="solid"/>
+                      <a:round/>
+                      <a:headEnd type="none" w="med" len="med"/>
+                      <a:tailEnd type="none" w="med" len="med"/>
+                    </a:lnB>
+                    <a:solidFill>
+                      <a:srgbClr val="FFFFFF"/>
+                    </a:solidFill>
+                  </a:tcPr>
+                </a:tc>
+              </a:tr>
+            </a:tbl>
+          </a:graphicData>
+        </a:graphic>
+      </p:graphicFrame>
+      <p:sp>
+        <p:nvSpPr>
+          <p:cNvPr id="6" name="Shape 3"/>
+          <p:cNvSpPr/>
+          <p:nvPr/>
+        </p:nvSpPr>
+        <p:spPr>
+          <a:xfrm>
+            <a:off x="7818120" y="1783080"/>
+            <a:ext cx="3822192" cy="3566160"/>
+          </a:xfrm>
+          <a:prstGeom prst="rect">
+            <a:avLst/>
+          </a:prstGeom>
+          <a:solidFill>
+            <a:srgbClr val="F3F3F3"/>
+          </a:solidFill>
+          <a:ln w="12700">
+            <a:solidFill>
+              <a:srgbClr val="F3F3F3"/>
+            </a:solidFill>
+            <a:prstDash val="solid"/>
+          </a:ln>
+        </p:spPr>
+      </p:sp>
+      <p:sp>
+        <p:nvSpPr>
+          <p:cNvPr id="7" name="Text 4"/>
+          <p:cNvSpPr txBox="1"/>
+          <p:nvPr/>
+        </p:nvSpPr>
+        <p:spPr>
+          <a:xfrm>
+            <a:off x="8046720" y="1947672"/>
+            <a:ext cx="3364992" cy="365760"/>
+          </a:xfrm>
+          <a:prstGeom prst="rect">
+            <a:avLst/>
+          </a:prstGeom>
+          <a:noFill/>
+          <a:ln/>
+        </p:spPr>
+        <p:txBody>
+          <a:bodyPr wrap="square" lIns="0" tIns="0" rIns="0" bIns="0" rtlCol="0" anchor="t"/>
+          <a:lstStyle/>
+          <a:p>
+            <a:pPr indent="0" marL="0">
+              <a:buNone/>
+            </a:pPr>
+            <a:r>
+              <a:rPr lang="en-US" sz="1500" b="1" dirty="0">
+                <a:solidFill>
+                  <a:srgbClr val="000000"/>
+                </a:solidFill>
+                <a:latin typeface="Cambria" pitchFamily="34" charset="0"/>
+                <a:ea typeface="Cambria" pitchFamily="34" charset="-122"/>
+                <a:cs typeface="Cambria" pitchFamily="34" charset="-120"/>
+              </a:rPr>
+              <a:t>Reading the numbers</a:t>
+            </a:r>
+            <a:endParaRPr lang="en-US" sz="1500" dirty="0"/>
+          </a:p>
+        </p:txBody>
+      </p:sp>
+      <p:sp>
+        <p:nvSpPr>
+          <p:cNvPr id="8" name="Shape 5"/>
+          <p:cNvSpPr/>
+          <p:nvPr/>
+        </p:nvSpPr>
+        <p:spPr>
+          <a:xfrm>
+            <a:off x="8046720" y="2350008"/>
+            <a:ext cx="548640" cy="0"/>
+          </a:xfrm>
+          <a:prstGeom prst="line">
+            <a:avLst/>
+          </a:prstGeom>
+          <a:noFill/>
+          <a:ln w="25400">
+            <a:solidFill>
+              <a:srgbClr val="000000"/>
+            </a:solidFill>
+            <a:prstDash val="solid"/>
+          </a:ln>
+        </p:spPr>
+      </p:sp>
+      <p:sp>
+        <p:nvSpPr>
+          <p:cNvPr id="9" name="Text 6"/>
+          <p:cNvSpPr txBox="1"/>
+          <p:nvPr/>
+        </p:nvSpPr>
+        <p:spPr>
+          <a:xfrm>
+            <a:off x="8046720" y="2560320"/>
+            <a:ext cx="3410712" cy="2743200"/>
+          </a:xfrm>
+          <a:prstGeom prst="rect">
+            <a:avLst/>
+          </a:prstGeom>
+          <a:noFill/>
+          <a:ln/>
+        </p:spPr>
+        <p:txBody>
+          <a:bodyPr wrap="square" lIns="0" tIns="0" rIns="0" bIns="0" rtlCol="0" anchor="t"/>
+          <a:lstStyle/>
+          <a:p>
+            <a:pPr marL="203200" indent="-203200">
+              <a:spcAft>
+                <a:spcPts val="700"/>
+              </a:spcAft>
+              <a:buSzPct val="100000"/>
+              <a:buChar char="▪"/>
+            </a:pPr>
+            <a:r>
+              <a:rPr lang="en-US" sz="1200" dirty="0">
+                <a:solidFill>
+                  <a:srgbClr val="000000"/>
+                </a:solidFill>
+                <a:latin typeface="Calibri" pitchFamily="34" charset="0"/>
+                <a:ea typeface="Calibri" pitchFamily="34" charset="-122"/>
+                <a:cs typeface="Calibri" pitchFamily="34" charset="-120"/>
+              </a:rPr>
+              <a:t>UW-TIG vs Alamdari: -0.007 (CI -0.020 to 0.007) -- a tie.</a:t>
+            </a:r>
+            <a:endParaRPr lang="en-US" sz="1200" dirty="0"/>
+          </a:p>
+          <a:p>
+            <a:pPr marL="203200" indent="-203200">
+              <a:spcAft>
+                <a:spcPts val="700"/>
+              </a:spcAft>
+              <a:buSzPct val="100000"/>
+              <a:buChar char="▪"/>
+            </a:pPr>
+            <a:r>
+              <a:rPr lang="en-US" sz="1200" dirty="0">
+                <a:solidFill>
+                  <a:srgbClr val="000000"/>
+                </a:solidFill>
+                <a:latin typeface="Calibri" pitchFamily="34" charset="0"/>
+                <a:ea typeface="Calibri" pitchFamily="34" charset="-122"/>
+                <a:cs typeface="Calibri" pitchFamily="34" charset="-120"/>
+              </a:rPr>
+              <a:t>vs Rückin: +0.018, interval excludes 0; flies 480 m vs 860 m.</a:t>
+            </a:r>
+            <a:endParaRPr lang="en-US" sz="1200" dirty="0"/>
+          </a:p>
+          <a:p>
+            <a:pPr marL="203200" indent="-203200">
+              <a:spcAft>
+                <a:spcPts val="700"/>
+              </a:spcAft>
+              <a:buSzPct val="100000"/>
+              <a:buChar char="▪"/>
+            </a:pPr>
+            <a:r>
+              <a:rPr lang="en-US" sz="1200" dirty="0">
+                <a:solidFill>
+                  <a:srgbClr val="000000"/>
+                </a:solidFill>
+                <a:latin typeface="Calibri" pitchFamily="34" charset="0"/>
+                <a:ea typeface="Calibri" pitchFamily="34" charset="-122"/>
+                <a:cs typeface="Calibri" pitchFamily="34" charset="-120"/>
+              </a:rPr>
+              <a:t>Margins shrink as the yard grows; the coverage phase is still decisive.</a:t>
+            </a:r>
+            <a:endParaRPr lang="en-US" sz="1200" dirty="0"/>
+          </a:p>
+          <a:p>
+            <a:pPr marL="203200" indent="-203200">
+              <a:spcAft>
+                <a:spcPts val="700"/>
+              </a:spcAft>
+              <a:buSzPct val="100000"/>
+              <a:buChar char="▪"/>
+            </a:pPr>
+            <a:r>
+              <a:rPr lang="en-US" sz="1200" dirty="0">
+                <a:solidFill>
+                  <a:srgbClr val="000000"/>
+                </a:solidFill>
+                <a:latin typeface="Calibri" pitchFamily="34" charset="0"/>
+                <a:ea typeface="Calibri" pitchFamily="34" charset="-122"/>
+                <a:cs typeface="Calibri" pitchFamily="34" charset="-120"/>
+              </a:rPr>
+              <a:t>Fine-tuned detector did not help the closed loop (UW-TIG F1 0.883 vs 0.921).</a:t>
+            </a:r>
+            <a:endParaRPr lang="en-US" sz="1200" dirty="0"/>
+          </a:p>
+        </p:txBody>
+      </p:sp>
+      <p:sp>
+        <p:nvSpPr>
+          <p:cNvPr id="10" name="Text 7"/>
+          <p:cNvSpPr txBox="1"/>
+          <p:nvPr/>
+        </p:nvSpPr>
+        <p:spPr>
+          <a:xfrm>
+            <a:off x="548640" y="5440680"/>
+            <a:ext cx="11091672" cy="548640"/>
+          </a:xfrm>
+          <a:prstGeom prst="rect">
+            <a:avLst/>
+          </a:prstGeom>
+          <a:noFill/>
+          <a:ln/>
+        </p:spPr>
+        <p:txBody>
+          <a:bodyPr wrap="square" lIns="0" tIns="0" rIns="0" bIns="0" rtlCol="0" anchor="t"/>
+          <a:lstStyle/>
+          <a:p>
+            <a:pPr indent="0" marL="0">
+              <a:buNone/>
+            </a:pPr>
+            <a:r>
+              <a:rPr lang="en-US" sz="1150" dirty="0">
+                <a:solidFill>
+                  <a:srgbClr val="595959"/>
+                </a:solidFill>
+                <a:latin typeface="Calibri" pitchFamily="34" charset="0"/>
+                <a:ea typeface="Calibri" pitchFamily="34" charset="-122"/>
+                <a:cs typeface="Calibri" pitchFamily="34" charset="-120"/>
+              </a:rPr>
+              <a:t>Ablations repeat: removing uncertainty or growth changes F1 by &lt;0.005; removing staleness/lookahead shortens the flight with no F1 loss.</a:t>
+            </a:r>
+            <a:endParaRPr lang="en-US" sz="1150" dirty="0"/>
+          </a:p>
+        </p:txBody>
+      </p:sp>
+    </p:spTree>
+  </p:cSld>
+  <p:clrMapOvr>
+    <a:masterClrMapping/>
+  </p:clrMapOvr>
+</p:sld>
+</file>
+
+<file path=ppt/slides/slide12.xml><?xml version="1.0" encoding="utf-8"?>
+<p:sld xmlns:a="http://schemas.openxmlformats.org/drawingml/2006/main" xmlns:r="http://schemas.openxmlformats.org/officeDocument/2006/relationships" xmlns:p="http://schemas.openxmlformats.org/presentationml/2006/main">
+  <p:cSld name="Slide 12">
+    <p:spTree>
+      <p:nvGrpSpPr>
+        <p:cNvPr id="1" name=""/>
+        <p:cNvGrpSpPr/>
+        <p:nvPr/>
+      </p:nvGrpSpPr>
+      <p:grpSpPr>
+        <a:xfrm>
+          <a:off x="0" y="0"/>
+          <a:ext cx="0" cy="0"/>
+          <a:chOff x="0" y="0"/>
+          <a:chExt cx="0" cy="0"/>
+        </a:xfrm>
+      </p:grpSpPr>
+      <p:sp>
+        <p:nvSpPr>
+          <p:cNvPr id="2" name="Text 0"/>
+          <p:cNvSpPr/>
+          <p:nvPr>
+            <p:ph idx="100" type="title" hasCustomPrompt="1"/>
+          </p:nvPr>
+        </p:nvSpPr>
+        <p:spPr>
+          <a:xfrm>
+            <a:off x="548640" y="320040"/>
+            <a:ext cx="11091672" cy="640080"/>
+          </a:xfrm>
+          <a:prstGeom prst="rect">
+            <a:avLst/>
+          </a:prstGeom>
+          <a:noFill/>
+          <a:ln/>
+        </p:spPr>
+        <p:txBody>
+          <a:bodyPr wrap="square" lIns="0" tIns="0" rIns="0" bIns="0" rtlCol="0" anchor="ctr"/>
+          <a:lstStyle/>
+          <a:p>
+            <a:pPr algn="l" indent="0" marL="0">
+              <a:buNone/>
+            </a:pPr>
+            <a:r>
+              <a:rPr lang="en-US" sz="2600" b="1" dirty="0">
+                <a:solidFill>
+                  <a:srgbClr val="000000"/>
+                </a:solidFill>
+                <a:latin typeface="Cambria" pitchFamily="34" charset="0"/>
+                <a:ea typeface="Cambria" pitchFamily="34" charset="-122"/>
+                <a:cs typeface="Cambria" pitchFamily="34" charset="-120"/>
+              </a:rPr>
               <a:t>Conclusion &amp; Future Work</a:t>
             </a:r>
             <a:endParaRPr lang="en-US" sz="2600" dirty="0"/>
@@ -6813,7 +10594,7 @@
                 <a:ea typeface="Calibri" pitchFamily="34" charset="-122"/>
                 <a:cs typeface="Calibri" pitchFamily="34" charset="-120"/>
               </a:rPr>
-              <a:t>11</a:t>
+              <a:t>12</a:t>
             </a:r>
             <a:endParaRPr lang="en-US" sz="900" dirty="0"/>
           </a:p>
@@ -6985,7 +10766,28 @@
                 <a:ea typeface="Calibri" pitchFamily="34" charset="-122"/>
                 <a:cs typeface="Calibri" pitchFamily="34" charset="-120"/>
               </a:rPr>
-              <a:t>Matches the strongest of five published planners on detection while flying far less.</a:t>
+              <a:t>Matches the strongest published planners on detection at lower flight cost, in a 9-wall and a 31-wall yard.</a:t>
+            </a:r>
+            <a:endParaRPr lang="en-US" sz="1500" dirty="0"/>
+          </a:p>
+          <a:p>
+            <a:pPr marL="203200" indent="-203200">
+              <a:spcAft>
+                <a:spcPts val="1800"/>
+              </a:spcAft>
+              <a:buSzPct val="100000"/>
+              <a:buChar char="▪"/>
+            </a:pPr>
+            <a:r>
+              <a:rPr lang="en-US" sz="1500" dirty="0">
+                <a:solidFill>
+                  <a:srgbClr val="000000"/>
+                </a:solidFill>
+                <a:latin typeface="Calibri" pitchFamily="34" charset="0"/>
+                <a:ea typeface="Calibri" pitchFamily="34" charset="-122"/>
+                <a:cs typeface="Calibri" pitchFamily="34" charset="-120"/>
+              </a:rPr>
+              <a:t>Reported honestly: margins shrink at scale, and the fine-tuned detector was not adopted.</a:t>
             </a:r>
             <a:endParaRPr lang="en-US" sz="1500" dirty="0"/>
           </a:p>
@@ -15215,7 +19017,7 @@
                 <a:ea typeface="Calibri" pitchFamily="34" charset="-122"/>
                 <a:cs typeface="Calibri" pitchFamily="34" charset="-120"/>
               </a:rPr>
-              <a:t>NVIDIA L4 GPU, rented (detector training only)</a:t>
+              <a:t>NVIDIA L4 GPU on a rented 32-vCPU machine (training and the 31-wall sweeps)</a:t>
             </a:r>
             <a:endParaRPr lang="en-US" sz="1250" dirty="0"/>
           </a:p>
@@ -15279,7 +19081,7 @@
                 <a:ea typeface="Cambria" pitchFamily="34" charset="-122"/>
                 <a:cs typeface="Cambria" pitchFamily="34" charset="-120"/>
               </a:rPr>
-              <a:t>Dataset</a:t>
+              <a:t>Datasets</a:t>
             </a:r>
             <a:endParaRPr lang="en-US" sz="1500" dirty="0"/>
           </a:p>
@@ -15331,13 +19133,13 @@
           <a:p>
             <a:pPr marL="203200" indent="-203200">
               <a:spcAft>
-                <a:spcPts val="800"/>
+                <a:spcPts val="700"/>
               </a:spcAft>
               <a:buSzPct val="100000"/>
               <a:buChar char="▪"/>
             </a:pPr>
             <a:r>
-              <a:rPr lang="en-US" sz="1250" b="1" dirty="0">
+              <a:rPr lang="en-US" sz="1200" b="1" dirty="0">
                 <a:solidFill>
                   <a:srgbClr val="000000"/>
                 </a:solidFill>
@@ -15351,7 +19153,7 @@
               <a:buNone/>
             </a:pPr>
             <a:r>
-              <a:rPr lang="en-US" sz="1250" dirty="0">
+              <a:rPr lang="en-US" sz="1200" dirty="0">
                 <a:solidFill>
                   <a:srgbClr val="000000"/>
                 </a:solidFill>
@@ -15359,20 +19161,20 @@
                 <a:ea typeface="Calibri" pitchFamily="34" charset="-122"/>
                 <a:cs typeface="Calibri" pitchFamily="34" charset="-120"/>
               </a:rPr>
-              <a:t>14,471 real UAV photos of building surfaces (Zha et al., Scientific Data 2025).</a:t>
+              <a:t>14,471 UAV photos, 5 classes; detector training/test and the simulator's wall textures (1,448 held-out test images).</a:t>
             </a:r>
-            <a:endParaRPr lang="en-US" sz="1250" dirty="0"/>
+            <a:endParaRPr lang="en-US" sz="1200" dirty="0"/>
           </a:p>
           <a:p>
             <a:pPr marL="203200" indent="-203200">
               <a:spcAft>
-                <a:spcPts val="800"/>
+                <a:spcPts val="700"/>
               </a:spcAft>
               <a:buSzPct val="100000"/>
               <a:buChar char="▪"/>
             </a:pPr>
             <a:r>
-              <a:rPr lang="en-US" sz="1250" b="1" dirty="0">
+              <a:rPr lang="en-US" sz="1200" b="1" dirty="0">
                 <a:solidFill>
                   <a:srgbClr val="000000"/>
                 </a:solidFill>
@@ -15380,13 +19182,13 @@
                 <a:ea typeface="Calibri" pitchFamily="34" charset="-122"/>
                 <a:cs typeface="Calibri" pitchFamily="34" charset="-120"/>
               </a:rPr>
-              <a:t>5 classes: </a:t>
+              <a:t>dacl10k: </a:t>
             </a:r>
             <a:pPr indent="0" marL="0">
               <a:buNone/>
             </a:pPr>
             <a:r>
-              <a:rPr lang="en-US" sz="1250" dirty="0">
+              <a:rPr lang="en-US" sz="1200" dirty="0">
                 <a:solidFill>
                   <a:srgbClr val="000000"/>
                 </a:solidFill>
@@ -15394,20 +19196,20 @@
                 <a:ea typeface="Calibri" pitchFamily="34" charset="-122"/>
                 <a:cs typeface="Calibri" pitchFamily="34" charset="-120"/>
               </a:rPr>
-              <a:t>crack, leakage, abscission, corrosion, bulge.</a:t>
+              <a:t>real bridge-inspection photos (CC-BY-4.0); 5,362 train images added, 810 held out as a cross-dataset test.</a:t>
             </a:r>
-            <a:endParaRPr lang="en-US" sz="1250" dirty="0"/>
+            <a:endParaRPr lang="en-US" sz="1200" dirty="0"/>
           </a:p>
           <a:p>
             <a:pPr marL="203200" indent="-203200">
               <a:spcAft>
-                <a:spcPts val="800"/>
+                <a:spcPts val="700"/>
               </a:spcAft>
               <a:buSzPct val="100000"/>
               <a:buChar char="▪"/>
             </a:pPr>
             <a:r>
-              <a:rPr lang="en-US" sz="1250" b="1" dirty="0">
+              <a:rPr lang="en-US" sz="1200" b="1" dirty="0">
                 <a:solidFill>
                   <a:srgbClr val="000000"/>
                 </a:solidFill>
@@ -15415,13 +19217,13 @@
                 <a:ea typeface="Calibri" pitchFamily="34" charset="-122"/>
                 <a:cs typeface="Calibri" pitchFamily="34" charset="-120"/>
               </a:rPr>
-              <a:t>Split: </a:t>
+              <a:t>Roboflow corrosion: </a:t>
             </a:r>
             <a:pPr indent="0" marL="0">
               <a:buNone/>
             </a:pPr>
             <a:r>
-              <a:rPr lang="en-US" sz="1250" dirty="0">
+              <a:rPr lang="en-US" sz="1200" dirty="0">
                 <a:solidFill>
                   <a:srgbClr val="000000"/>
                 </a:solidFill>
@@ -15429,20 +19231,20 @@
                 <a:ea typeface="Calibri" pitchFamily="34" charset="-122"/>
                 <a:cs typeface="Calibri" pitchFamily="34" charset="-120"/>
               </a:rPr>
-              <a:t>70 / 20 / 10 train / val / test; 1,448 held-out test images.</a:t>
+              <a:t>851 corrosion/crack images added to training.</a:t>
             </a:r>
-            <a:endParaRPr lang="en-US" sz="1250" dirty="0"/>
+            <a:endParaRPr lang="en-US" sz="1200" dirty="0"/>
           </a:p>
           <a:p>
             <a:pPr marL="203200" indent="-203200">
               <a:spcAft>
-                <a:spcPts val="800"/>
+                <a:spcPts val="700"/>
               </a:spcAft>
               <a:buSzPct val="100000"/>
               <a:buChar char="▪"/>
             </a:pPr>
             <a:r>
-              <a:rPr lang="en-US" sz="1250" b="1" dirty="0">
+              <a:rPr lang="en-US" sz="1200" b="1" dirty="0">
                 <a:solidFill>
                   <a:srgbClr val="000000"/>
                 </a:solidFill>
@@ -15450,13 +19252,13 @@
                 <a:ea typeface="Calibri" pitchFamily="34" charset="-122"/>
                 <a:cs typeface="Calibri" pitchFamily="34" charset="-120"/>
               </a:rPr>
-              <a:t>Imbalance: </a:t>
+              <a:t>Concrete-crack crops: </a:t>
             </a:r>
             <a:pPr indent="0" marL="0">
               <a:buNone/>
             </a:pPr>
             <a:r>
-              <a:rPr lang="en-US" sz="1250" dirty="0">
+              <a:rPr lang="en-US" sz="1200" dirty="0">
                 <a:solidFill>
                   <a:srgbClr val="000000"/>
                 </a:solidFill>
@@ -15464,20 +19266,20 @@
                 <a:ea typeface="Calibri" pitchFamily="34" charset="-122"/>
                 <a:cs typeface="Calibri" pitchFamily="34" charset="-120"/>
               </a:rPr>
-              <a:t>bulge has 2,018 instances vs. 22,702 for abscission.</a:t>
+              <a:t>800 held-out images for an image-level check (never trained on).</a:t>
             </a:r>
-            <a:endParaRPr lang="en-US" sz="1250" dirty="0"/>
+            <a:endParaRPr lang="en-US" sz="1200" dirty="0"/>
           </a:p>
           <a:p>
             <a:pPr marL="203200" indent="-203200">
               <a:spcAft>
-                <a:spcPts val="800"/>
+                <a:spcPts val="700"/>
               </a:spcAft>
               <a:buSzPct val="100000"/>
               <a:buChar char="▪"/>
             </a:pPr>
             <a:r>
-              <a:rPr lang="en-US" sz="1250" b="1" dirty="0">
+              <a:rPr lang="en-US" sz="1200" b="1" dirty="0">
                 <a:solidFill>
                   <a:srgbClr val="000000"/>
                 </a:solidFill>
@@ -15491,7 +19293,7 @@
               <a:buNone/>
             </a:pPr>
             <a:r>
-              <a:rPr lang="en-US" sz="1250" dirty="0">
+              <a:rPr lang="en-US" sz="1200" dirty="0">
                 <a:solidFill>
                   <a:srgbClr val="000000"/>
                 </a:solidFill>
@@ -15499,9 +19301,9 @@
                 <a:ea typeface="Calibri" pitchFamily="34" charset="-122"/>
                 <a:cs typeface="Calibri" pitchFamily="34" charset="-120"/>
               </a:rPr>
-              <a:t>crack augmentation planned; download pending.</a:t>
+              <a:t>planned, but its download is bot-blocked; replaced by the sets above.</a:t>
             </a:r>
-            <a:endParaRPr lang="en-US" sz="1250" dirty="0"/>
+            <a:endParaRPr lang="en-US" sz="1200" dirty="0"/>
           </a:p>
         </p:txBody>
       </p:sp>
@@ -19831,8 +23633,8 @@
         </p:nvSpPr>
         <p:spPr>
           <a:xfrm>
-            <a:off x="548640" y="5623560"/>
-            <a:ext cx="11091672" cy="548640"/>
+            <a:off x="548640" y="5486400"/>
+            <a:ext cx="11091672" cy="822960"/>
           </a:xfrm>
           <a:prstGeom prst="rect">
             <a:avLst/>
@@ -19848,6 +23650,34 @@
               <a:buNone/>
             </a:pPr>
             <a:r>
+              <a:rPr lang="en-US" sz="1150" b="1" dirty="0">
+                <a:solidFill>
+                  <a:srgbClr val="000000"/>
+                </a:solidFill>
+                <a:latin typeface="Calibri" pitchFamily="34" charset="0"/>
+                <a:ea typeface="Calibri" pitchFamily="34" charset="-122"/>
+                <a:cs typeface="Calibri" pitchFamily="34" charset="-120"/>
+              </a:rPr>
+              <a:t>Extra datasets: </a:t>
+            </a:r>
+            <a:pPr indent="0" marL="0">
+              <a:buNone/>
+            </a:pPr>
+            <a:r>
+              <a:rPr lang="en-US" sz="1150" dirty="0">
+                <a:solidFill>
+                  <a:srgbClr val="000000"/>
+                </a:solidFill>
+                <a:latin typeface="Calibri" pitchFamily="34" charset="0"/>
+                <a:ea typeface="Calibri" pitchFamily="34" charset="-122"/>
+                <a:cs typeface="Calibri" pitchFamily="34" charset="-120"/>
+              </a:rPr>
+              <a:t>fine-tuning on MBDD + dacl10k + Roboflow lifted held-out dacl10k mAP50 from 0.004 to 0.184, left MBDD unchanged (0.884 vs 0.886), and did not improve the closed loop -- so the original detector stays the default. </a:t>
+            </a:r>
+            <a:pPr indent="0" marL="0">
+              <a:buNone/>
+            </a:pPr>
+            <a:r>
               <a:rPr lang="en-US" sz="1150" dirty="0">
                 <a:solidFill>
                   <a:srgbClr val="595959"/>
@@ -19856,7 +23686,7 @@
                 <a:ea typeface="Calibri" pitchFamily="34" charset="-122"/>
                 <a:cs typeface="Calibri" pitchFamily="34" charset="-120"/>
               </a:rPr>
-              <a:t>Calibration check: expected calibration error 0.29-0.33, and uncertainty is slightly lower on wrong detections than right ones -- so uncertainty is used only to rank views within a mission, never as a probability.</a:t>
+              <a:t>Calibration: expected calibration error 0.29-0.33; uncertainty is used only to rank views, never as a probability.</a:t>
             </a:r>
             <a:endParaRPr lang="en-US" sz="1150" dirty="0"/>
           </a:p>

</xml_diff>